<commit_message>
Clarify submission evidence, improve presentations and document validation plans
</commit_message>
<xml_diff>
--- a/reports/Franklin_Guillano_DIAL_ALERT_Business_Presentation.pptx
+++ b/reports/Franklin_Guillano_DIAL_ALERT_Business_Presentation.pptx
@@ -2,22 +2,22 @@
 <file path=ppt/presentation.xml><?xml version="1.0" encoding="utf-8"?>
 <p:presentation xmlns:p="http://schemas.openxmlformats.org/presentationml/2006/main">
   <p:sldMasterIdLst>
-    <p:sldMasterId xmlns:r="http://schemas.openxmlformats.org/officeDocument/2006/relationships" id="2147483648" r:id="R0cfe6567100e486c"/>
+    <p:sldMasterId xmlns:r="http://schemas.openxmlformats.org/officeDocument/2006/relationships" id="2147483648" r:id="Rf96c2edef4fc4103"/>
   </p:sldMasterIdLst>
   <p:notesMasterIdLst>
-    <p:notesMasterId xmlns:r="http://schemas.openxmlformats.org/officeDocument/2006/relationships" r:id="Rb16060f429e04e2a"/>
+    <p:notesMasterId xmlns:r="http://schemas.openxmlformats.org/officeDocument/2006/relationships" r:id="Rd18d8753a4794aaf"/>
   </p:notesMasterIdLst>
   <p:sldIdLst>
-    <p:sldId xmlns:r="http://schemas.openxmlformats.org/officeDocument/2006/relationships" id="256" r:id="R8e008ec0ad844815"/>
-    <p:sldId xmlns:r="http://schemas.openxmlformats.org/officeDocument/2006/relationships" id="257" r:id="Rc342fd37abfa4594"/>
-    <p:sldId xmlns:r="http://schemas.openxmlformats.org/officeDocument/2006/relationships" id="258" r:id="R2c379e7616014ef6"/>
-    <p:sldId xmlns:r="http://schemas.openxmlformats.org/officeDocument/2006/relationships" id="259" r:id="R75b6950ea38f4619"/>
-    <p:sldId xmlns:r="http://schemas.openxmlformats.org/officeDocument/2006/relationships" id="260" r:id="Rc304c2f50ec94790"/>
-    <p:sldId xmlns:r="http://schemas.openxmlformats.org/officeDocument/2006/relationships" id="261" r:id="Rc8fa9dbb8d894e31"/>
-    <p:sldId xmlns:r="http://schemas.openxmlformats.org/officeDocument/2006/relationships" id="262" r:id="R4fd89c71c3ca4a23"/>
-    <p:sldId xmlns:r="http://schemas.openxmlformats.org/officeDocument/2006/relationships" id="263" r:id="R08ed60c549c34f0d"/>
-    <p:sldId xmlns:r="http://schemas.openxmlformats.org/officeDocument/2006/relationships" id="264" r:id="R3c38607a5d2548f6"/>
-    <p:sldId xmlns:r="http://schemas.openxmlformats.org/officeDocument/2006/relationships" id="265" r:id="Rcecb6e3d1b4949e8"/>
+    <p:sldId xmlns:r="http://schemas.openxmlformats.org/officeDocument/2006/relationships" id="256" r:id="R50c07d8ed83844d4"/>
+    <p:sldId xmlns:r="http://schemas.openxmlformats.org/officeDocument/2006/relationships" id="257" r:id="Rcb841abf9b3e42f6"/>
+    <p:sldId xmlns:r="http://schemas.openxmlformats.org/officeDocument/2006/relationships" id="258" r:id="R7eb515b863634cde"/>
+    <p:sldId xmlns:r="http://schemas.openxmlformats.org/officeDocument/2006/relationships" id="259" r:id="R04b49e91dc4e4efe"/>
+    <p:sldId xmlns:r="http://schemas.openxmlformats.org/officeDocument/2006/relationships" id="260" r:id="R281f91b037ac4318"/>
+    <p:sldId xmlns:r="http://schemas.openxmlformats.org/officeDocument/2006/relationships" id="261" r:id="R36f2e37c66a94856"/>
+    <p:sldId xmlns:r="http://schemas.openxmlformats.org/officeDocument/2006/relationships" id="262" r:id="R3dad596ae78b4171"/>
+    <p:sldId xmlns:r="http://schemas.openxmlformats.org/officeDocument/2006/relationships" id="263" r:id="R0fa31a2813504f64"/>
+    <p:sldId xmlns:r="http://schemas.openxmlformats.org/officeDocument/2006/relationships" id="264" r:id="Rf71dfb7f50dd4f92"/>
+    <p:sldId xmlns:r="http://schemas.openxmlformats.org/officeDocument/2006/relationships" id="265" r:id="Rb334fb7f06934056"/>
   </p:sldIdLst>
   <p:sldSz cx="12192000" cy="6858000"/>
   <p:notesSz cx="6858000" cy="9144000"/>
@@ -1306,12 +1306,12 @@
           </a:p>
           <a:p xmlns:a="http://schemas.openxmlformats.org/drawingml/2006/main">
             <a:r>
-              <a:t>• The plan deliberately separates technical validation from clinical exposure.</a:t>
-            </a:r>
-          </a:p>
-          <a:p xmlns:a="http://schemas.openxmlformats.org/drawingml/2006/main">
-            <a:r>
-              <a:t>• Silent mode shows whether data arrive on time and whether the score behaves as expected without creating patient risk.</a:t>
+              <a:t>• The 90-day schedule is illustrative and conditional. Targets were drafted after the retrospective study and were not original prespecified study criteria. They concern feasibility, not demonstrated clinical benefit. Clinical and operational leads must approve the strategy, sample size, confidence-interval requirements and stop rules before collecting pilot outcomes.</a:t>
+            </a:r>
+          </a:p>
+          <a:p xmlns:a="http://schemas.openxmlformats.org/drawingml/2006/main">
+            <a:r>
+              <a:t>• Silent mode evaluates data delivery and score behavior without displaying alerts. Time review work in simulation first. The separate draft total-review budget is at most 40 minutes per 100 sessions. A median of two minutes does not imply a two-minute mean; measure total time and tail times directly.</a:t>
             </a:r>
           </a:p>
           <a:p xmlns:a="http://schemas.openxmlformats.org/drawingml/2006/main">
@@ -1384,7 +1384,7 @@
   </p:cSld>
   <p:clrMap bg1="lt1" tx1="dk1" bg2="lt2" tx2="dk2" accent1="accent1" accent2="accent2" accent3="accent3" accent4="accent4" accent5="accent5" accent6="accent6" hlink="hlink" folHlink="folHlink"/>
   <p:sldLayoutIdLst>
-    <p:sldLayoutId xmlns:r="http://schemas.openxmlformats.org/officeDocument/2006/relationships" id="2147483649" r:id="R5de47790c1e54578"/>
+    <p:sldLayoutId xmlns:r="http://schemas.openxmlformats.org/officeDocument/2006/relationships" id="2147483649" r:id="R275874af07954c83"/>
   </p:sldLayoutIdLst>
   <p:txStyles>
     <p:titleStyle>
@@ -2005,26 +2005,6 @@
         </a:ln>
       </c:spPr>
     </c:plotArea>
-    <c:legend>
-      <c:legendPos val="b"/>
-      <c:overlay val="0"/>
-      <c:txPr>
-        <a:bodyPr xmlns:a="http://schemas.openxmlformats.org/drawingml/2006/main" anchorCtr="1"/>
-        <a:lstStyle xmlns:a="http://schemas.openxmlformats.org/drawingml/2006/main"/>
-        <a:p xmlns:a="http://schemas.openxmlformats.org/drawingml/2006/main">
-          <a:pPr>
-            <a:defRPr sz="1200">
-              <a:solidFill>
-                <a:srgbClr val="243B53"/>
-              </a:solidFill>
-              <a:latin typeface="Nimbus Sans"/>
-              <a:ea typeface="Nimbus Sans"/>
-              <a:cs typeface="Nimbus Sans"/>
-            </a:defRPr>
-          </a:pPr>
-        </a:p>
-      </c:txPr>
-    </c:legend>
     <c:plotVisOnly val="1"/>
   </c:chart>
   <c:spPr>
@@ -2135,26 +2115,6 @@
         </a:ln>
       </c:spPr>
     </c:plotArea>
-    <c:legend>
-      <c:legendPos val="b"/>
-      <c:overlay val="0"/>
-      <c:txPr>
-        <a:bodyPr xmlns:a="http://schemas.openxmlformats.org/drawingml/2006/main" anchorCtr="1"/>
-        <a:lstStyle xmlns:a="http://schemas.openxmlformats.org/drawingml/2006/main"/>
-        <a:p xmlns:a="http://schemas.openxmlformats.org/drawingml/2006/main">
-          <a:pPr>
-            <a:defRPr sz="1200">
-              <a:solidFill>
-                <a:srgbClr val="243B53"/>
-              </a:solidFill>
-              <a:latin typeface="Nimbus Sans"/>
-              <a:ea typeface="Nimbus Sans"/>
-              <a:cs typeface="Nimbus Sans"/>
-            </a:defRPr>
-          </a:pPr>
-        </a:p>
-      </c:txPr>
-    </c:legend>
     <c:plotVisOnly val="1"/>
   </c:chart>
   <c:spPr>
@@ -2195,7 +2155,7 @@
           <p:cNvPr id="10" name="">
             <a:extLst xmlns:a="http://schemas.openxmlformats.org/drawingml/2006/main">
               <a:ext uri="{FF2B5EF4-FFF2-40B4-BE49-F238E27FC236}">
-                <a16:creationId xmlns:a16="http://schemas.microsoft.com/office/drawing/2014/main" id="{3B88686C-1600-4B64-B5F4-38356EE8FDA1}"/>
+                <a16:creationId xmlns:a16="http://schemas.microsoft.com/office/drawing/2014/main" id="{F64F804A-AFAC-4B67-9E63-431F71EC57A5}"/>
               </a:ext>
             </a:extLst>
           </p:cNvPr>
@@ -2226,7 +2186,7 @@
           <p:cNvPr id="2" name="">
             <a:extLst xmlns:a="http://schemas.openxmlformats.org/drawingml/2006/main">
               <a:ext uri="{FF2B5EF4-FFF2-40B4-BE49-F238E27FC236}">
-                <a16:creationId xmlns:a16="http://schemas.microsoft.com/office/drawing/2014/main" id="{8298A010-553B-463D-9161-72CC822B64BA}"/>
+                <a16:creationId xmlns:a16="http://schemas.microsoft.com/office/drawing/2014/main" id="{F80FCA66-B56C-49DE-A787-D6F874156600}"/>
               </a:ext>
             </a:extLst>
           </p:cNvPr>
@@ -2284,7 +2244,7 @@
           <p:cNvPr id="3" name="">
             <a:extLst xmlns:a="http://schemas.openxmlformats.org/drawingml/2006/main">
               <a:ext uri="{FF2B5EF4-FFF2-40B4-BE49-F238E27FC236}">
-                <a16:creationId xmlns:a16="http://schemas.microsoft.com/office/drawing/2014/main" id="{22FCB1C4-43EE-423B-8461-715D3D05E527}"/>
+                <a16:creationId xmlns:a16="http://schemas.microsoft.com/office/drawing/2014/main" id="{847A2D03-BA4C-435D-8331-A986BF05C869}"/>
               </a:ext>
             </a:extLst>
           </p:cNvPr>
@@ -2342,7 +2302,7 @@
           <p:cNvPr id="4" name="">
             <a:extLst xmlns:a="http://schemas.openxmlformats.org/drawingml/2006/main">
               <a:ext uri="{FF2B5EF4-FFF2-40B4-BE49-F238E27FC236}">
-                <a16:creationId xmlns:a16="http://schemas.microsoft.com/office/drawing/2014/main" id="{7FA4F1C3-65A9-4D84-8C68-85469D4300F2}"/>
+                <a16:creationId xmlns:a16="http://schemas.microsoft.com/office/drawing/2014/main" id="{5EBF0EB0-A76E-4D41-AE60-1D46E9E4E798}"/>
               </a:ext>
             </a:extLst>
           </p:cNvPr>
@@ -2423,7 +2383,7 @@
           <p:cNvPr id="5" name="">
             <a:extLst xmlns:a="http://schemas.openxmlformats.org/drawingml/2006/main">
               <a:ext uri="{FF2B5EF4-FFF2-40B4-BE49-F238E27FC236}">
-                <a16:creationId xmlns:a16="http://schemas.microsoft.com/office/drawing/2014/main" id="{AFBB7749-D882-446A-91C9-3CDAAEC4D0A7}"/>
+                <a16:creationId xmlns:a16="http://schemas.microsoft.com/office/drawing/2014/main" id="{E06B33E6-0E93-40D3-B4A3-7128DC83F432}"/>
               </a:ext>
             </a:extLst>
           </p:cNvPr>
@@ -2454,7 +2414,7 @@
           <p:cNvPr id="6" name="">
             <a:extLst xmlns:a="http://schemas.openxmlformats.org/drawingml/2006/main">
               <a:ext uri="{FF2B5EF4-FFF2-40B4-BE49-F238E27FC236}">
-                <a16:creationId xmlns:a16="http://schemas.microsoft.com/office/drawing/2014/main" id="{C8698262-16B2-43F1-A35D-01733705DF1E}"/>
+                <a16:creationId xmlns:a16="http://schemas.microsoft.com/office/drawing/2014/main" id="{7760B3E2-F9E9-420E-8D46-83C59C8C4B13}"/>
               </a:ext>
             </a:extLst>
           </p:cNvPr>
@@ -2558,7 +2518,7 @@
           <p:cNvPr id="7" name="">
             <a:extLst xmlns:a="http://schemas.openxmlformats.org/drawingml/2006/main">
               <a:ext uri="{FF2B5EF4-FFF2-40B4-BE49-F238E27FC236}">
-                <a16:creationId xmlns:a16="http://schemas.microsoft.com/office/drawing/2014/main" id="{1CC64708-45A2-484B-8A2A-9D49CCF94DB7}"/>
+                <a16:creationId xmlns:a16="http://schemas.microsoft.com/office/drawing/2014/main" id="{58AE0CA6-6DF2-4EA3-AC78-F6030649A71E}"/>
               </a:ext>
             </a:extLst>
           </p:cNvPr>
@@ -2616,7 +2576,7 @@
           <p:cNvPr id="8" name="">
             <a:extLst xmlns:a="http://schemas.openxmlformats.org/drawingml/2006/main">
               <a:ext uri="{FF2B5EF4-FFF2-40B4-BE49-F238E27FC236}">
-                <a16:creationId xmlns:a16="http://schemas.microsoft.com/office/drawing/2014/main" id="{EBAA3928-BC60-4BA9-B630-192E5E750735}"/>
+                <a16:creationId xmlns:a16="http://schemas.microsoft.com/office/drawing/2014/main" id="{4C6EB808-6558-4ECA-ABC7-7DC18D8CC76A}"/>
               </a:ext>
             </a:extLst>
           </p:cNvPr>
@@ -2647,7 +2607,7 @@
           <p:cNvPr id="9" name="">
             <a:extLst xmlns:a="http://schemas.openxmlformats.org/drawingml/2006/main">
               <a:ext uri="{FF2B5EF4-FFF2-40B4-BE49-F238E27FC236}">
-                <a16:creationId xmlns:a16="http://schemas.microsoft.com/office/drawing/2014/main" id="{1A379BCD-5F10-4327-B79B-B0870098B41B}"/>
+                <a16:creationId xmlns:a16="http://schemas.microsoft.com/office/drawing/2014/main" id="{89BF2BE9-B28E-43D6-8AFA-0CFFD7EE7B8C}"/>
               </a:ext>
             </a:extLst>
           </p:cNvPr>
@@ -2703,7 +2663,7 @@
     </p:spTree>
     <p:extLst>
       <p:ext uri="{BB962C8B-B14F-4D97-AF65-F5344CB8AC3E}">
-        <p14:creationId xmlns:p14="http://schemas.microsoft.com/office/powerpoint/2010/main" val="454105053"/>
+        <p14:creationId xmlns:p14="http://schemas.microsoft.com/office/powerpoint/2010/main" val="2097706891"/>
       </p:ext>
     </p:extLst>
   </p:cSld>
@@ -2734,7 +2694,7 @@
           <p:cNvPr id="27" name="">
             <a:extLst xmlns:a="http://schemas.openxmlformats.org/drawingml/2006/main">
               <a:ext uri="{FF2B5EF4-FFF2-40B4-BE49-F238E27FC236}">
-                <a16:creationId xmlns:a16="http://schemas.microsoft.com/office/drawing/2014/main" id="{A6C7F00F-3193-4322-AD99-0B070520DDFD}"/>
+                <a16:creationId xmlns:a16="http://schemas.microsoft.com/office/drawing/2014/main" id="{787598DA-146C-41E8-B3FE-089306A07940}"/>
               </a:ext>
             </a:extLst>
           </p:cNvPr>
@@ -2765,7 +2725,7 @@
           <p:cNvPr id="2" name="">
             <a:extLst xmlns:a="http://schemas.openxmlformats.org/drawingml/2006/main">
               <a:ext uri="{FF2B5EF4-FFF2-40B4-BE49-F238E27FC236}">
-                <a16:creationId xmlns:a16="http://schemas.microsoft.com/office/drawing/2014/main" id="{05A70D49-1B42-42AF-B3F8-A8D1F06D875A}"/>
+                <a16:creationId xmlns:a16="http://schemas.microsoft.com/office/drawing/2014/main" id="{C89E779F-9E65-48BB-9A27-4DDD93B2E581}"/>
               </a:ext>
             </a:extLst>
           </p:cNvPr>
@@ -2795,7 +2755,7 @@
           <a:lstStyle xmlns:a="http://schemas.openxmlformats.org/drawingml/2006/main"/>
           <a:p xmlns:a="http://schemas.openxmlformats.org/drawingml/2006/main">
             <a:pPr algn="l">
-              <a:defRPr sz="2475" b="1" i="0">
+              <a:defRPr sz="3225" b="1" i="0">
                 <a:solidFill>
                   <a:srgbClr val="FFFFFF"/>
                 </a:solidFill>
@@ -2805,7 +2765,7 @@
               </a:defRPr>
             </a:pPr>
             <a:r>
-              <a:rPr sz="2475" b="1" i="0">
+              <a:rPr sz="3225" b="1" i="0">
                 <a:solidFill>
                   <a:srgbClr val="FFFFFF"/>
                 </a:solidFill>
@@ -2813,7 +2773,7 @@
                 <a:ea typeface="Nimbus Sans"/>
                 <a:cs typeface="Nimbus Sans"/>
               </a:rPr>
-              <a:t>Decision requested: approve validation, not clinical deployment</a:t>
+              <a:t>Decision requested: further validation</a:t>
             </a:r>
           </a:p>
         </p:txBody>
@@ -2823,7 +2783,7 @@
           <p:cNvPr id="3" name="">
             <a:extLst xmlns:a="http://schemas.openxmlformats.org/drawingml/2006/main">
               <a:ext uri="{FF2B5EF4-FFF2-40B4-BE49-F238E27FC236}">
-                <a16:creationId xmlns:a16="http://schemas.microsoft.com/office/drawing/2014/main" id="{F7690803-1C87-4B22-A7C1-2CC787C82767}"/>
+                <a16:creationId xmlns:a16="http://schemas.microsoft.com/office/drawing/2014/main" id="{01D10BA1-27C7-4E2C-B6FA-9AF475E6CFC7}"/>
               </a:ext>
             </a:extLst>
           </p:cNvPr>
@@ -2881,7 +2841,7 @@
           <p:cNvPr id="4" name="">
             <a:extLst xmlns:a="http://schemas.openxmlformats.org/drawingml/2006/main">
               <a:ext uri="{FF2B5EF4-FFF2-40B4-BE49-F238E27FC236}">
-                <a16:creationId xmlns:a16="http://schemas.microsoft.com/office/drawing/2014/main" id="{695EED8C-E688-4DF4-AFC6-3B6D5BD8B01E}"/>
+                <a16:creationId xmlns:a16="http://schemas.microsoft.com/office/drawing/2014/main" id="{6B0B09D8-0761-4D92-8F54-F826569A80DF}"/>
               </a:ext>
             </a:extLst>
           </p:cNvPr>
@@ -2939,7 +2899,7 @@
           <p:cNvPr id="5" name="">
             <a:extLst xmlns:a="http://schemas.openxmlformats.org/drawingml/2006/main">
               <a:ext uri="{FF2B5EF4-FFF2-40B4-BE49-F238E27FC236}">
-                <a16:creationId xmlns:a16="http://schemas.microsoft.com/office/drawing/2014/main" id="{951F261A-1983-4D2E-9314-5A20119556C2}"/>
+                <a16:creationId xmlns:a16="http://schemas.microsoft.com/office/drawing/2014/main" id="{DB8FFEE7-A504-4ECD-888F-1B5309C958AC}"/>
               </a:ext>
             </a:extLst>
           </p:cNvPr>
@@ -2970,7 +2930,7 @@
           <p:cNvPr id="6" name="">
             <a:extLst xmlns:a="http://schemas.openxmlformats.org/drawingml/2006/main">
               <a:ext uri="{FF2B5EF4-FFF2-40B4-BE49-F238E27FC236}">
-                <a16:creationId xmlns:a16="http://schemas.microsoft.com/office/drawing/2014/main" id="{4933E973-F856-48F6-95EA-378035CCE929}"/>
+                <a16:creationId xmlns:a16="http://schemas.microsoft.com/office/drawing/2014/main" id="{974A50B5-ED2E-4C41-A49F-06C284D5F622}"/>
               </a:ext>
             </a:extLst>
           </p:cNvPr>
@@ -3028,7 +2988,7 @@
           <p:cNvPr id="7" name="">
             <a:extLst xmlns:a="http://schemas.openxmlformats.org/drawingml/2006/main">
               <a:ext uri="{FF2B5EF4-FFF2-40B4-BE49-F238E27FC236}">
-                <a16:creationId xmlns:a16="http://schemas.microsoft.com/office/drawing/2014/main" id="{ED2F9C28-6FEC-483B-AD7C-2E76B026CED3}"/>
+                <a16:creationId xmlns:a16="http://schemas.microsoft.com/office/drawing/2014/main" id="{E9FEA2F3-0A8E-4A0D-AB63-8F92B270DECA}"/>
               </a:ext>
             </a:extLst>
           </p:cNvPr>
@@ -3059,7 +3019,7 @@
           <p:cNvPr id="8" name="">
             <a:extLst xmlns:a="http://schemas.openxmlformats.org/drawingml/2006/main">
               <a:ext uri="{FF2B5EF4-FFF2-40B4-BE49-F238E27FC236}">
-                <a16:creationId xmlns:a16="http://schemas.microsoft.com/office/drawing/2014/main" id="{FAA09D64-6F40-4C7A-9298-4BAAAE793F2E}"/>
+                <a16:creationId xmlns:a16="http://schemas.microsoft.com/office/drawing/2014/main" id="{30D90F73-83B9-422C-A332-920E7A0BB6B5}"/>
               </a:ext>
             </a:extLst>
           </p:cNvPr>
@@ -3117,7 +3077,7 @@
           <p:cNvPr id="9" name="">
             <a:extLst xmlns:a="http://schemas.openxmlformats.org/drawingml/2006/main">
               <a:ext uri="{FF2B5EF4-FFF2-40B4-BE49-F238E27FC236}">
-                <a16:creationId xmlns:a16="http://schemas.microsoft.com/office/drawing/2014/main" id="{81F7687D-8948-4C31-B4E6-DF169C22FD81}"/>
+                <a16:creationId xmlns:a16="http://schemas.microsoft.com/office/drawing/2014/main" id="{16D7CD49-766E-4754-AAB3-EBE0341DCE8E}"/>
               </a:ext>
             </a:extLst>
           </p:cNvPr>
@@ -3148,7 +3108,7 @@
           <p:cNvPr id="10" name="">
             <a:extLst xmlns:a="http://schemas.openxmlformats.org/drawingml/2006/main">
               <a:ext uri="{FF2B5EF4-FFF2-40B4-BE49-F238E27FC236}">
-                <a16:creationId xmlns:a16="http://schemas.microsoft.com/office/drawing/2014/main" id="{03B094B8-F975-4C83-96CA-A8A936F7E0EC}"/>
+                <a16:creationId xmlns:a16="http://schemas.microsoft.com/office/drawing/2014/main" id="{3851D415-22B3-4BC3-850A-99541307268C}"/>
               </a:ext>
             </a:extLst>
           </p:cNvPr>
@@ -3206,7 +3166,7 @@
           <p:cNvPr id="11" name="">
             <a:extLst xmlns:a="http://schemas.openxmlformats.org/drawingml/2006/main">
               <a:ext uri="{FF2B5EF4-FFF2-40B4-BE49-F238E27FC236}">
-                <a16:creationId xmlns:a16="http://schemas.microsoft.com/office/drawing/2014/main" id="{07237BE1-BA61-4046-8171-9945D4A407F0}"/>
+                <a16:creationId xmlns:a16="http://schemas.microsoft.com/office/drawing/2014/main" id="{BE7323F4-0544-4262-9B28-96011759C694}"/>
               </a:ext>
             </a:extLst>
           </p:cNvPr>
@@ -3237,7 +3197,7 @@
           <p:cNvPr id="12" name="">
             <a:extLst xmlns:a="http://schemas.openxmlformats.org/drawingml/2006/main">
               <a:ext uri="{FF2B5EF4-FFF2-40B4-BE49-F238E27FC236}">
-                <a16:creationId xmlns:a16="http://schemas.microsoft.com/office/drawing/2014/main" id="{BE3D9DA7-99FA-47FA-A68B-EAD596E9667E}"/>
+                <a16:creationId xmlns:a16="http://schemas.microsoft.com/office/drawing/2014/main" id="{ED74C135-20A0-409D-88C6-B47881508205}"/>
               </a:ext>
             </a:extLst>
           </p:cNvPr>
@@ -3295,7 +3255,7 @@
           <p:cNvPr id="13" name="">
             <a:extLst xmlns:a="http://schemas.openxmlformats.org/drawingml/2006/main">
               <a:ext uri="{FF2B5EF4-FFF2-40B4-BE49-F238E27FC236}">
-                <a16:creationId xmlns:a16="http://schemas.microsoft.com/office/drawing/2014/main" id="{8E7D8B3B-096E-486D-B57E-6F70ABD32B9C}"/>
+                <a16:creationId xmlns:a16="http://schemas.microsoft.com/office/drawing/2014/main" id="{C0E9E804-85EE-4FA3-995E-D2D2633E52F3}"/>
               </a:ext>
             </a:extLst>
           </p:cNvPr>
@@ -3326,7 +3286,7 @@
           <p:cNvPr id="14" name="">
             <a:extLst xmlns:a="http://schemas.openxmlformats.org/drawingml/2006/main">
               <a:ext uri="{FF2B5EF4-FFF2-40B4-BE49-F238E27FC236}">
-                <a16:creationId xmlns:a16="http://schemas.microsoft.com/office/drawing/2014/main" id="{0017C2A9-040B-456C-A81C-ADB62D311108}"/>
+                <a16:creationId xmlns:a16="http://schemas.microsoft.com/office/drawing/2014/main" id="{D3293EED-1A66-4A5F-8C80-128C0DE38896}"/>
               </a:ext>
             </a:extLst>
           </p:cNvPr>
@@ -3384,7 +3344,7 @@
           <p:cNvPr id="15" name="">
             <a:extLst xmlns:a="http://schemas.openxmlformats.org/drawingml/2006/main">
               <a:ext uri="{FF2B5EF4-FFF2-40B4-BE49-F238E27FC236}">
-                <a16:creationId xmlns:a16="http://schemas.microsoft.com/office/drawing/2014/main" id="{B2BE4D02-FC59-4E91-94A5-953BC8D57C7D}"/>
+                <a16:creationId xmlns:a16="http://schemas.microsoft.com/office/drawing/2014/main" id="{8A4E6919-5B5B-47F0-9499-EFCE22F5473E}"/>
               </a:ext>
             </a:extLst>
           </p:cNvPr>
@@ -3415,7 +3375,7 @@
           <p:cNvPr id="16" name="">
             <a:extLst xmlns:a="http://schemas.openxmlformats.org/drawingml/2006/main">
               <a:ext uri="{FF2B5EF4-FFF2-40B4-BE49-F238E27FC236}">
-                <a16:creationId xmlns:a16="http://schemas.microsoft.com/office/drawing/2014/main" id="{955005AB-0C3E-4A7B-AA2D-A66CA4301679}"/>
+                <a16:creationId xmlns:a16="http://schemas.microsoft.com/office/drawing/2014/main" id="{E74DCCDC-69C0-4E36-A619-80CD27051AA8}"/>
               </a:ext>
             </a:extLst>
           </p:cNvPr>
@@ -3473,7 +3433,7 @@
           <p:cNvPr id="17" name="">
             <a:extLst xmlns:a="http://schemas.openxmlformats.org/drawingml/2006/main">
               <a:ext uri="{FF2B5EF4-FFF2-40B4-BE49-F238E27FC236}">
-                <a16:creationId xmlns:a16="http://schemas.microsoft.com/office/drawing/2014/main" id="{50410028-4804-4E1A-8149-B0227B481406}"/>
+                <a16:creationId xmlns:a16="http://schemas.microsoft.com/office/drawing/2014/main" id="{7070F01E-B537-4895-8DED-6FA7F540ED0F}"/>
               </a:ext>
             </a:extLst>
           </p:cNvPr>
@@ -3504,7 +3464,7 @@
           <p:cNvPr id="18" name="">
             <a:extLst xmlns:a="http://schemas.openxmlformats.org/drawingml/2006/main">
               <a:ext uri="{FF2B5EF4-FFF2-40B4-BE49-F238E27FC236}">
-                <a16:creationId xmlns:a16="http://schemas.microsoft.com/office/drawing/2014/main" id="{69EBDF33-EC91-46B6-BDC4-A5F99BCC8BD7}"/>
+                <a16:creationId xmlns:a16="http://schemas.microsoft.com/office/drawing/2014/main" id="{B587AD21-AEB7-41C4-93BC-2D75B783D126}"/>
               </a:ext>
             </a:extLst>
           </p:cNvPr>
@@ -3562,7 +3522,7 @@
           <p:cNvPr id="19" name="">
             <a:extLst xmlns:a="http://schemas.openxmlformats.org/drawingml/2006/main">
               <a:ext uri="{FF2B5EF4-FFF2-40B4-BE49-F238E27FC236}">
-                <a16:creationId xmlns:a16="http://schemas.microsoft.com/office/drawing/2014/main" id="{6A0E9FD6-B162-44A9-AFC4-256841B03187}"/>
+                <a16:creationId xmlns:a16="http://schemas.microsoft.com/office/drawing/2014/main" id="{E93C71B1-AB5D-44B5-8235-36CE387894F7}"/>
               </a:ext>
             </a:extLst>
           </p:cNvPr>
@@ -3593,7 +3553,7 @@
           <p:cNvPr id="20" name="">
             <a:extLst xmlns:a="http://schemas.openxmlformats.org/drawingml/2006/main">
               <a:ext uri="{FF2B5EF4-FFF2-40B4-BE49-F238E27FC236}">
-                <a16:creationId xmlns:a16="http://schemas.microsoft.com/office/drawing/2014/main" id="{F485D1AB-134D-4EB1-A0F6-51FEB1B95BEE}"/>
+                <a16:creationId xmlns:a16="http://schemas.microsoft.com/office/drawing/2014/main" id="{D99A619B-5D00-49EE-9A18-5C37ED628A5B}"/>
               </a:ext>
             </a:extLst>
           </p:cNvPr>
@@ -3651,7 +3611,7 @@
           <p:cNvPr id="21" name="">
             <a:extLst xmlns:a="http://schemas.openxmlformats.org/drawingml/2006/main">
               <a:ext uri="{FF2B5EF4-FFF2-40B4-BE49-F238E27FC236}">
-                <a16:creationId xmlns:a16="http://schemas.microsoft.com/office/drawing/2014/main" id="{89F6D400-1CD7-4D5C-B064-95A6EBBDEB90}"/>
+                <a16:creationId xmlns:a16="http://schemas.microsoft.com/office/drawing/2014/main" id="{9F92F5F1-BBA7-4F54-A351-B2865B7D33AF}"/>
               </a:ext>
             </a:extLst>
           </p:cNvPr>
@@ -3682,7 +3642,7 @@
           <p:cNvPr id="22" name="">
             <a:extLst xmlns:a="http://schemas.openxmlformats.org/drawingml/2006/main">
               <a:ext uri="{FF2B5EF4-FFF2-40B4-BE49-F238E27FC236}">
-                <a16:creationId xmlns:a16="http://schemas.microsoft.com/office/drawing/2014/main" id="{C5835517-6FBE-4231-95D2-464B9E6F7199}"/>
+                <a16:creationId xmlns:a16="http://schemas.microsoft.com/office/drawing/2014/main" id="{66BF746C-0B3B-4D9A-8D62-2A1E122C6A47}"/>
               </a:ext>
             </a:extLst>
           </p:cNvPr>
@@ -3740,7 +3700,7 @@
           <p:cNvPr id="23" name="">
             <a:extLst xmlns:a="http://schemas.openxmlformats.org/drawingml/2006/main">
               <a:ext uri="{FF2B5EF4-FFF2-40B4-BE49-F238E27FC236}">
-                <a16:creationId xmlns:a16="http://schemas.microsoft.com/office/drawing/2014/main" id="{B87D36E2-BFC1-4B0B-8A09-484D1B630083}"/>
+                <a16:creationId xmlns:a16="http://schemas.microsoft.com/office/drawing/2014/main" id="{6EBA2182-C16C-484C-8113-A42C9E7B7B6E}"/>
               </a:ext>
             </a:extLst>
           </p:cNvPr>
@@ -3771,7 +3731,7 @@
           <p:cNvPr id="24" name="">
             <a:extLst xmlns:a="http://schemas.openxmlformats.org/drawingml/2006/main">
               <a:ext uri="{FF2B5EF4-FFF2-40B4-BE49-F238E27FC236}">
-                <a16:creationId xmlns:a16="http://schemas.microsoft.com/office/drawing/2014/main" id="{7966FC0A-E9CD-4FAA-93D6-1C68BC0CEEF0}"/>
+                <a16:creationId xmlns:a16="http://schemas.microsoft.com/office/drawing/2014/main" id="{328A5EF7-3378-448C-A8C6-CEFDF83A9BEB}"/>
               </a:ext>
             </a:extLst>
           </p:cNvPr>
@@ -3829,7 +3789,7 @@
           <p:cNvPr id="25" name="">
             <a:extLst xmlns:a="http://schemas.openxmlformats.org/drawingml/2006/main">
               <a:ext uri="{FF2B5EF4-FFF2-40B4-BE49-F238E27FC236}">
-                <a16:creationId xmlns:a16="http://schemas.microsoft.com/office/drawing/2014/main" id="{B4699015-AC7A-479D-A76F-1C2406759EF1}"/>
+                <a16:creationId xmlns:a16="http://schemas.microsoft.com/office/drawing/2014/main" id="{6462ABBE-99BE-43EE-BD96-6205A02B3190}"/>
               </a:ext>
             </a:extLst>
           </p:cNvPr>
@@ -3860,7 +3820,7 @@
           <p:cNvPr id="26" name="">
             <a:extLst xmlns:a="http://schemas.openxmlformats.org/drawingml/2006/main">
               <a:ext uri="{FF2B5EF4-FFF2-40B4-BE49-F238E27FC236}">
-                <a16:creationId xmlns:a16="http://schemas.microsoft.com/office/drawing/2014/main" id="{03B19487-FE7A-4B67-BE72-B24148A15124}"/>
+                <a16:creationId xmlns:a16="http://schemas.microsoft.com/office/drawing/2014/main" id="{47137AF2-A3F6-4903-82A8-130CC2FF2B98}"/>
               </a:ext>
             </a:extLst>
           </p:cNvPr>
@@ -3916,7 +3876,7 @@
     </p:spTree>
     <p:extLst>
       <p:ext uri="{BB962C8B-B14F-4D97-AF65-F5344CB8AC3E}">
-        <p14:creationId xmlns:p14="http://schemas.microsoft.com/office/powerpoint/2010/main" val="697142995"/>
+        <p14:creationId xmlns:p14="http://schemas.microsoft.com/office/powerpoint/2010/main" val="476067083"/>
       </p:ext>
     </p:extLst>
   </p:cSld>
@@ -3947,7 +3907,7 @@
           <p:cNvPr id="16" name="">
             <a:extLst xmlns:a="http://schemas.openxmlformats.org/drawingml/2006/main">
               <a:ext uri="{FF2B5EF4-FFF2-40B4-BE49-F238E27FC236}">
-                <a16:creationId xmlns:a16="http://schemas.microsoft.com/office/drawing/2014/main" id="{B2B55384-D7CC-48D9-86A0-FFEAFF58415E}"/>
+                <a16:creationId xmlns:a16="http://schemas.microsoft.com/office/drawing/2014/main" id="{87B51BDE-967D-462C-9195-C7A7CA0F35E1}"/>
               </a:ext>
             </a:extLst>
           </p:cNvPr>
@@ -3978,7 +3938,7 @@
           <p:cNvPr id="2" name="">
             <a:extLst xmlns:a="http://schemas.openxmlformats.org/drawingml/2006/main">
               <a:ext uri="{FF2B5EF4-FFF2-40B4-BE49-F238E27FC236}">
-                <a16:creationId xmlns:a16="http://schemas.microsoft.com/office/drawing/2014/main" id="{0DDF6C1E-E5B3-4D8D-8486-B59F0C40EEE4}"/>
+                <a16:creationId xmlns:a16="http://schemas.microsoft.com/office/drawing/2014/main" id="{3E964305-0686-4DE4-A00F-80D18CB50F81}"/>
               </a:ext>
             </a:extLst>
           </p:cNvPr>
@@ -4008,7 +3968,7 @@
           <a:lstStyle xmlns:a="http://schemas.openxmlformats.org/drawingml/2006/main"/>
           <a:p xmlns:a="http://schemas.openxmlformats.org/drawingml/2006/main">
             <a:pPr algn="l">
-              <a:defRPr sz="2325" b="1" i="0">
+              <a:defRPr sz="3225" b="1" i="0">
                 <a:solidFill>
                   <a:srgbClr val="FFFFFF"/>
                 </a:solidFill>
@@ -4018,7 +3978,7 @@
               </a:defRPr>
             </a:pPr>
             <a:r>
-              <a:rPr sz="2325" b="1" i="0">
+              <a:rPr sz="3225" b="1" i="0">
                 <a:solidFill>
                   <a:srgbClr val="FFFFFF"/>
                 </a:solidFill>
@@ -4026,7 +3986,7 @@
                 <a:ea typeface="Nimbus Sans"/>
                 <a:cs typeface="Nimbus Sans"/>
               </a:rPr>
-              <a:t>The model concentrates risk, but deployment evidence is incomplete</a:t>
+              <a:t>Potential value and remaining evidence</a:t>
             </a:r>
           </a:p>
         </p:txBody>
@@ -4036,7 +3996,7 @@
           <p:cNvPr id="3" name="">
             <a:extLst xmlns:a="http://schemas.openxmlformats.org/drawingml/2006/main">
               <a:ext uri="{FF2B5EF4-FFF2-40B4-BE49-F238E27FC236}">
-                <a16:creationId xmlns:a16="http://schemas.microsoft.com/office/drawing/2014/main" id="{D70B1EA3-7C46-4224-88F7-FFFEFDCA850A}"/>
+                <a16:creationId xmlns:a16="http://schemas.microsoft.com/office/drawing/2014/main" id="{59537A88-4C13-4556-A37C-5F32AC47040D}"/>
               </a:ext>
             </a:extLst>
           </p:cNvPr>
@@ -4094,7 +4054,7 @@
           <p:cNvPr id="4" name="">
             <a:extLst xmlns:a="http://schemas.openxmlformats.org/drawingml/2006/main">
               <a:ext uri="{FF2B5EF4-FFF2-40B4-BE49-F238E27FC236}">
-                <a16:creationId xmlns:a16="http://schemas.microsoft.com/office/drawing/2014/main" id="{8D07AAB9-6078-4B04-BC66-08633657B952}"/>
+                <a16:creationId xmlns:a16="http://schemas.microsoft.com/office/drawing/2014/main" id="{DF31818E-1C23-4AA8-8186-43C5314221BD}"/>
               </a:ext>
             </a:extLst>
           </p:cNvPr>
@@ -4152,7 +4112,7 @@
           <p:cNvPr id="5" name="">
             <a:extLst xmlns:a="http://schemas.openxmlformats.org/drawingml/2006/main">
               <a:ext uri="{FF2B5EF4-FFF2-40B4-BE49-F238E27FC236}">
-                <a16:creationId xmlns:a16="http://schemas.microsoft.com/office/drawing/2014/main" id="{3CB4A054-8448-4E2A-850C-73003F8DC716}"/>
+                <a16:creationId xmlns:a16="http://schemas.microsoft.com/office/drawing/2014/main" id="{2F088708-D5FC-4840-91C5-782DB1DFE8DC}"/>
               </a:ext>
             </a:extLst>
           </p:cNvPr>
@@ -4210,7 +4170,7 @@
           <p:cNvPr id="6" name="">
             <a:extLst xmlns:a="http://schemas.openxmlformats.org/drawingml/2006/main">
               <a:ext uri="{FF2B5EF4-FFF2-40B4-BE49-F238E27FC236}">
-                <a16:creationId xmlns:a16="http://schemas.microsoft.com/office/drawing/2014/main" id="{8B402B97-ADF0-42FC-96CE-0F5B90C6CC76}"/>
+                <a16:creationId xmlns:a16="http://schemas.microsoft.com/office/drawing/2014/main" id="{697A4F7D-7C84-4425-AA5F-5E6434ABEB8F}"/>
               </a:ext>
             </a:extLst>
           </p:cNvPr>
@@ -4241,7 +4201,7 @@
           <p:cNvPr id="7" name="">
             <a:extLst xmlns:a="http://schemas.openxmlformats.org/drawingml/2006/main">
               <a:ext uri="{FF2B5EF4-FFF2-40B4-BE49-F238E27FC236}">
-                <a16:creationId xmlns:a16="http://schemas.microsoft.com/office/drawing/2014/main" id="{5CB50885-CE86-4153-ADB7-AE69A545F97A}"/>
+                <a16:creationId xmlns:a16="http://schemas.microsoft.com/office/drawing/2014/main" id="{F276EA9B-33B8-41A0-A94E-E4015B9856EA}"/>
               </a:ext>
             </a:extLst>
           </p:cNvPr>
@@ -4299,7 +4259,7 @@
           <p:cNvPr id="8" name="">
             <a:extLst xmlns:a="http://schemas.openxmlformats.org/drawingml/2006/main">
               <a:ext uri="{FF2B5EF4-FFF2-40B4-BE49-F238E27FC236}">
-                <a16:creationId xmlns:a16="http://schemas.microsoft.com/office/drawing/2014/main" id="{5064453B-E6D1-48A7-B3CF-5A24D3FEB5BA}"/>
+                <a16:creationId xmlns:a16="http://schemas.microsoft.com/office/drawing/2014/main" id="{AA94971D-99FF-403B-B1F6-15CB4B4C53B4}"/>
               </a:ext>
             </a:extLst>
           </p:cNvPr>
@@ -4380,7 +4340,7 @@
           <p:cNvPr id="9" name="">
             <a:extLst xmlns:a="http://schemas.openxmlformats.org/drawingml/2006/main">
               <a:ext uri="{FF2B5EF4-FFF2-40B4-BE49-F238E27FC236}">
-                <a16:creationId xmlns:a16="http://schemas.microsoft.com/office/drawing/2014/main" id="{746FA3F6-EC70-4F2E-A422-62653AF88B70}"/>
+                <a16:creationId xmlns:a16="http://schemas.microsoft.com/office/drawing/2014/main" id="{3A1EC51C-085D-448A-958E-7BD97672E2BD}"/>
               </a:ext>
             </a:extLst>
           </p:cNvPr>
@@ -4438,7 +4398,7 @@
           <p:cNvPr id="10" name="">
             <a:extLst xmlns:a="http://schemas.openxmlformats.org/drawingml/2006/main">
               <a:ext uri="{FF2B5EF4-FFF2-40B4-BE49-F238E27FC236}">
-                <a16:creationId xmlns:a16="http://schemas.microsoft.com/office/drawing/2014/main" id="{3BC00B57-7F63-4020-9B38-57CC2D77A3BC}"/>
+                <a16:creationId xmlns:a16="http://schemas.microsoft.com/office/drawing/2014/main" id="{038A9B49-4AFC-437D-89FB-AB6F5F191C8C}"/>
               </a:ext>
             </a:extLst>
           </p:cNvPr>
@@ -4496,7 +4456,7 @@
           <p:cNvPr id="11" name="">
             <a:extLst xmlns:a="http://schemas.openxmlformats.org/drawingml/2006/main">
               <a:ext uri="{FF2B5EF4-FFF2-40B4-BE49-F238E27FC236}">
-                <a16:creationId xmlns:a16="http://schemas.microsoft.com/office/drawing/2014/main" id="{9B35C0F9-02E2-4F72-A07D-04DA4A4457D4}"/>
+                <a16:creationId xmlns:a16="http://schemas.microsoft.com/office/drawing/2014/main" id="{00F370DD-5854-436C-BAC9-A67471676321}"/>
               </a:ext>
             </a:extLst>
           </p:cNvPr>
@@ -4527,7 +4487,7 @@
           <p:cNvPr id="12" name="">
             <a:extLst xmlns:a="http://schemas.openxmlformats.org/drawingml/2006/main">
               <a:ext uri="{FF2B5EF4-FFF2-40B4-BE49-F238E27FC236}">
-                <a16:creationId xmlns:a16="http://schemas.microsoft.com/office/drawing/2014/main" id="{BD13FAB4-5ED2-4102-88B2-DE4AB2193523}"/>
+                <a16:creationId xmlns:a16="http://schemas.microsoft.com/office/drawing/2014/main" id="{F155A1B9-3DFA-4019-B2A8-14334F2BDCDF}"/>
               </a:ext>
             </a:extLst>
           </p:cNvPr>
@@ -4585,7 +4545,7 @@
           <p:cNvPr id="13" name="">
             <a:extLst xmlns:a="http://schemas.openxmlformats.org/drawingml/2006/main">
               <a:ext uri="{FF2B5EF4-FFF2-40B4-BE49-F238E27FC236}">
-                <a16:creationId xmlns:a16="http://schemas.microsoft.com/office/drawing/2014/main" id="{96A78993-5827-4C95-B89F-BB2371BE7342}"/>
+                <a16:creationId xmlns:a16="http://schemas.microsoft.com/office/drawing/2014/main" id="{DE0029CD-F018-43B9-958D-46B3EA849806}"/>
               </a:ext>
             </a:extLst>
           </p:cNvPr>
@@ -4643,7 +4603,7 @@
           <p:cNvPr id="14" name="">
             <a:extLst xmlns:a="http://schemas.openxmlformats.org/drawingml/2006/main">
               <a:ext uri="{FF2B5EF4-FFF2-40B4-BE49-F238E27FC236}">
-                <a16:creationId xmlns:a16="http://schemas.microsoft.com/office/drawing/2014/main" id="{3B5971CB-85B1-4133-87B6-47A3C96EAEFC}"/>
+                <a16:creationId xmlns:a16="http://schemas.microsoft.com/office/drawing/2014/main" id="{92DE7256-91C3-41FD-AEFD-0BB4B787177F}"/>
               </a:ext>
             </a:extLst>
           </p:cNvPr>
@@ -4674,7 +4634,7 @@
           <p:cNvPr id="15" name="">
             <a:extLst xmlns:a="http://schemas.openxmlformats.org/drawingml/2006/main">
               <a:ext uri="{FF2B5EF4-FFF2-40B4-BE49-F238E27FC236}">
-                <a16:creationId xmlns:a16="http://schemas.microsoft.com/office/drawing/2014/main" id="{7EAAD916-8DD1-4CF8-A7BD-E1470C640C6A}"/>
+                <a16:creationId xmlns:a16="http://schemas.microsoft.com/office/drawing/2014/main" id="{48B132CB-5E71-4C66-9769-97B22D84A731}"/>
               </a:ext>
             </a:extLst>
           </p:cNvPr>
@@ -4730,7 +4690,7 @@
     </p:spTree>
     <p:extLst>
       <p:ext uri="{BB962C8B-B14F-4D97-AF65-F5344CB8AC3E}">
-        <p14:creationId xmlns:p14="http://schemas.microsoft.com/office/powerpoint/2010/main" val="1817989316"/>
+        <p14:creationId xmlns:p14="http://schemas.microsoft.com/office/powerpoint/2010/main" val="1772620420"/>
       </p:ext>
     </p:extLst>
   </p:cSld>
@@ -4761,7 +4721,7 @@
           <p:cNvPr id="29" name="">
             <a:extLst xmlns:a="http://schemas.openxmlformats.org/drawingml/2006/main">
               <a:ext uri="{FF2B5EF4-FFF2-40B4-BE49-F238E27FC236}">
-                <a16:creationId xmlns:a16="http://schemas.microsoft.com/office/drawing/2014/main" id="{CA375FCB-9051-4F35-8D89-44CE6FC81A2D}"/>
+                <a16:creationId xmlns:a16="http://schemas.microsoft.com/office/drawing/2014/main" id="{B9956C5B-A1F4-4DA8-91AD-CA5EA760A54C}"/>
               </a:ext>
             </a:extLst>
           </p:cNvPr>
@@ -4792,7 +4752,7 @@
           <p:cNvPr id="2" name="">
             <a:extLst xmlns:a="http://schemas.openxmlformats.org/drawingml/2006/main">
               <a:ext uri="{FF2B5EF4-FFF2-40B4-BE49-F238E27FC236}">
-                <a16:creationId xmlns:a16="http://schemas.microsoft.com/office/drawing/2014/main" id="{359FC3F9-111B-473E-BEE5-FFD10F7626A7}"/>
+                <a16:creationId xmlns:a16="http://schemas.microsoft.com/office/drawing/2014/main" id="{07DB7CF0-3832-4D6D-882B-8CDD820DEEDB}"/>
               </a:ext>
             </a:extLst>
           </p:cNvPr>
@@ -4822,7 +4782,7 @@
           <a:lstStyle xmlns:a="http://schemas.openxmlformats.org/drawingml/2006/main"/>
           <a:p xmlns:a="http://schemas.openxmlformats.org/drawingml/2006/main">
             <a:pPr algn="l">
-              <a:defRPr sz="2475" b="1" i="0">
+              <a:defRPr sz="3225" b="1" i="0">
                 <a:solidFill>
                   <a:srgbClr val="102A43"/>
                 </a:solidFill>
@@ -4832,7 +4792,7 @@
               </a:defRPr>
             </a:pPr>
             <a:r>
-              <a:rPr sz="2475" b="1" i="0">
+              <a:rPr sz="3225" b="1" i="0">
                 <a:solidFill>
                   <a:srgbClr val="102A43"/>
                 </a:solidFill>
@@ -4840,7 +4800,7 @@
                 <a:ea typeface="Nimbus Sans"/>
                 <a:cs typeface="Nimbus Sans"/>
               </a:rPr>
-              <a:t>DIAL-ALERT adds a review signal to the existing dialysis workflow</a:t>
+              <a:t>Proposed workflow for clinician review</a:t>
             </a:r>
           </a:p>
         </p:txBody>
@@ -4850,7 +4810,7 @@
           <p:cNvPr id="3" name="">
             <a:extLst xmlns:a="http://schemas.openxmlformats.org/drawingml/2006/main">
               <a:ext uri="{FF2B5EF4-FFF2-40B4-BE49-F238E27FC236}">
-                <a16:creationId xmlns:a16="http://schemas.microsoft.com/office/drawing/2014/main" id="{077152F7-9DA0-46B1-9C83-6BBD2710816D}"/>
+                <a16:creationId xmlns:a16="http://schemas.microsoft.com/office/drawing/2014/main" id="{64714A02-37DE-4FBF-A83F-5E81BFE2C751}"/>
               </a:ext>
             </a:extLst>
           </p:cNvPr>
@@ -4908,7 +4868,7 @@
           <p:cNvPr id="4" name="">
             <a:extLst xmlns:a="http://schemas.openxmlformats.org/drawingml/2006/main">
               <a:ext uri="{FF2B5EF4-FFF2-40B4-BE49-F238E27FC236}">
-                <a16:creationId xmlns:a16="http://schemas.microsoft.com/office/drawing/2014/main" id="{5DB678B2-058F-4AEC-80A0-B04C38457F5B}"/>
+                <a16:creationId xmlns:a16="http://schemas.microsoft.com/office/drawing/2014/main" id="{6099DB2D-3815-44CF-A96D-993143E6756B}"/>
               </a:ext>
             </a:extLst>
           </p:cNvPr>
@@ -4941,7 +4901,7 @@
           <p:cNvPr id="5" name="">
             <a:extLst xmlns:a="http://schemas.openxmlformats.org/drawingml/2006/main">
               <a:ext uri="{FF2B5EF4-FFF2-40B4-BE49-F238E27FC236}">
-                <a16:creationId xmlns:a16="http://schemas.microsoft.com/office/drawing/2014/main" id="{D715A04E-8C26-46B1-A2DA-4A498BE0AC77}"/>
+                <a16:creationId xmlns:a16="http://schemas.microsoft.com/office/drawing/2014/main" id="{CD01A16E-6C69-445E-881F-891D73407C16}"/>
               </a:ext>
             </a:extLst>
           </p:cNvPr>
@@ -5001,7 +4961,7 @@
           <p:cNvPr id="6" name="">
             <a:extLst xmlns:a="http://schemas.openxmlformats.org/drawingml/2006/main">
               <a:ext uri="{FF2B5EF4-FFF2-40B4-BE49-F238E27FC236}">
-                <a16:creationId xmlns:a16="http://schemas.microsoft.com/office/drawing/2014/main" id="{76C1E302-CAE6-4BF9-9D91-BB13E69E2000}"/>
+                <a16:creationId xmlns:a16="http://schemas.microsoft.com/office/drawing/2014/main" id="{26158F76-0C24-45AC-ACA9-3AD8EA4518B7}"/>
               </a:ext>
             </a:extLst>
           </p:cNvPr>
@@ -5059,7 +5019,7 @@
           <p:cNvPr id="7" name="">
             <a:extLst xmlns:a="http://schemas.openxmlformats.org/drawingml/2006/main">
               <a:ext uri="{FF2B5EF4-FFF2-40B4-BE49-F238E27FC236}">
-                <a16:creationId xmlns:a16="http://schemas.microsoft.com/office/drawing/2014/main" id="{75BBD1C3-F575-4C89-89EB-880EF1D29327}"/>
+                <a16:creationId xmlns:a16="http://schemas.microsoft.com/office/drawing/2014/main" id="{B29D7BB3-A6BA-44DC-BD04-8D5F85414711}"/>
               </a:ext>
             </a:extLst>
           </p:cNvPr>
@@ -5117,7 +5077,7 @@
           <p:cNvPr id="8" name="">
             <a:extLst xmlns:a="http://schemas.openxmlformats.org/drawingml/2006/main">
               <a:ext uri="{FF2B5EF4-FFF2-40B4-BE49-F238E27FC236}">
-                <a16:creationId xmlns:a16="http://schemas.microsoft.com/office/drawing/2014/main" id="{CC33EE1B-AA16-497B-8513-6B2E9DFE6D3C}"/>
+                <a16:creationId xmlns:a16="http://schemas.microsoft.com/office/drawing/2014/main" id="{D3431C5E-C5AC-406F-B7DF-EE1ACBCA66F0}"/>
               </a:ext>
             </a:extLst>
           </p:cNvPr>
@@ -5150,7 +5110,7 @@
           <p:cNvPr id="9" name="">
             <a:extLst xmlns:a="http://schemas.openxmlformats.org/drawingml/2006/main">
               <a:ext uri="{FF2B5EF4-FFF2-40B4-BE49-F238E27FC236}">
-                <a16:creationId xmlns:a16="http://schemas.microsoft.com/office/drawing/2014/main" id="{0C3FF392-894C-46D1-BEF0-6D3E999AB4D7}"/>
+                <a16:creationId xmlns:a16="http://schemas.microsoft.com/office/drawing/2014/main" id="{A01030EC-EAB5-44D5-A92E-6148453DE17E}"/>
               </a:ext>
             </a:extLst>
           </p:cNvPr>
@@ -5210,7 +5170,7 @@
           <p:cNvPr id="10" name="">
             <a:extLst xmlns:a="http://schemas.openxmlformats.org/drawingml/2006/main">
               <a:ext uri="{FF2B5EF4-FFF2-40B4-BE49-F238E27FC236}">
-                <a16:creationId xmlns:a16="http://schemas.microsoft.com/office/drawing/2014/main" id="{6A9278F0-86EB-43B8-A549-7660675158EF}"/>
+                <a16:creationId xmlns:a16="http://schemas.microsoft.com/office/drawing/2014/main" id="{21786438-AE60-4A7E-A59E-335A6B42C519}"/>
               </a:ext>
             </a:extLst>
           </p:cNvPr>
@@ -5268,7 +5228,7 @@
           <p:cNvPr id="11" name="">
             <a:extLst xmlns:a="http://schemas.openxmlformats.org/drawingml/2006/main">
               <a:ext uri="{FF2B5EF4-FFF2-40B4-BE49-F238E27FC236}">
-                <a16:creationId xmlns:a16="http://schemas.microsoft.com/office/drawing/2014/main" id="{448EC6D4-1134-47F7-B761-0FAE3F2022A8}"/>
+                <a16:creationId xmlns:a16="http://schemas.microsoft.com/office/drawing/2014/main" id="{707D842F-FF12-44A5-BB22-459A0C6CE11F}"/>
               </a:ext>
             </a:extLst>
           </p:cNvPr>
@@ -5326,7 +5286,7 @@
           <p:cNvPr id="12" name="">
             <a:extLst xmlns:a="http://schemas.openxmlformats.org/drawingml/2006/main">
               <a:ext uri="{FF2B5EF4-FFF2-40B4-BE49-F238E27FC236}">
-                <a16:creationId xmlns:a16="http://schemas.microsoft.com/office/drawing/2014/main" id="{6BA5EA61-97E3-4F25-B77F-D46E859FB9D3}"/>
+                <a16:creationId xmlns:a16="http://schemas.microsoft.com/office/drawing/2014/main" id="{898E80E3-B7AC-48BB-A57A-6B566BAA7449}"/>
               </a:ext>
             </a:extLst>
           </p:cNvPr>
@@ -5359,7 +5319,7 @@
           <p:cNvPr id="13" name="">
             <a:extLst xmlns:a="http://schemas.openxmlformats.org/drawingml/2006/main">
               <a:ext uri="{FF2B5EF4-FFF2-40B4-BE49-F238E27FC236}">
-                <a16:creationId xmlns:a16="http://schemas.microsoft.com/office/drawing/2014/main" id="{191BE872-C2FF-4A6C-9A37-7AB96116489A}"/>
+                <a16:creationId xmlns:a16="http://schemas.microsoft.com/office/drawing/2014/main" id="{1DD0EF99-0E28-4043-935D-F5E1EC041B04}"/>
               </a:ext>
             </a:extLst>
           </p:cNvPr>
@@ -5419,7 +5379,7 @@
           <p:cNvPr id="14" name="">
             <a:extLst xmlns:a="http://schemas.openxmlformats.org/drawingml/2006/main">
               <a:ext uri="{FF2B5EF4-FFF2-40B4-BE49-F238E27FC236}">
-                <a16:creationId xmlns:a16="http://schemas.microsoft.com/office/drawing/2014/main" id="{5069A916-02BE-48B5-BD4C-47A94DB9059D}"/>
+                <a16:creationId xmlns:a16="http://schemas.microsoft.com/office/drawing/2014/main" id="{849C7E7D-D8B7-443D-BACA-653D51989E89}"/>
               </a:ext>
             </a:extLst>
           </p:cNvPr>
@@ -5477,7 +5437,7 @@
           <p:cNvPr id="15" name="">
             <a:extLst xmlns:a="http://schemas.openxmlformats.org/drawingml/2006/main">
               <a:ext uri="{FF2B5EF4-FFF2-40B4-BE49-F238E27FC236}">
-                <a16:creationId xmlns:a16="http://schemas.microsoft.com/office/drawing/2014/main" id="{DFB3FB3B-4722-404E-BA41-DB04C2C9104B}"/>
+                <a16:creationId xmlns:a16="http://schemas.microsoft.com/office/drawing/2014/main" id="{BD7D27C3-CB9A-4D5C-BACC-BC4E7DD9941F}"/>
               </a:ext>
             </a:extLst>
           </p:cNvPr>
@@ -5535,7 +5495,7 @@
           <p:cNvPr id="16" name="">
             <a:extLst xmlns:a="http://schemas.openxmlformats.org/drawingml/2006/main">
               <a:ext uri="{FF2B5EF4-FFF2-40B4-BE49-F238E27FC236}">
-                <a16:creationId xmlns:a16="http://schemas.microsoft.com/office/drawing/2014/main" id="{CE5AAEA7-4FC7-4EE7-947F-FDA51C62095D}"/>
+                <a16:creationId xmlns:a16="http://schemas.microsoft.com/office/drawing/2014/main" id="{0DCC29D6-612B-4A75-9691-193C606BD080}"/>
               </a:ext>
             </a:extLst>
           </p:cNvPr>
@@ -5568,7 +5528,7 @@
           <p:cNvPr id="17" name="">
             <a:extLst xmlns:a="http://schemas.openxmlformats.org/drawingml/2006/main">
               <a:ext uri="{FF2B5EF4-FFF2-40B4-BE49-F238E27FC236}">
-                <a16:creationId xmlns:a16="http://schemas.microsoft.com/office/drawing/2014/main" id="{3E151388-889D-4A56-AF46-699919811309}"/>
+                <a16:creationId xmlns:a16="http://schemas.microsoft.com/office/drawing/2014/main" id="{0CE82358-00A2-4A11-A03C-6C0595F6A345}"/>
               </a:ext>
             </a:extLst>
           </p:cNvPr>
@@ -5628,7 +5588,7 @@
           <p:cNvPr id="18" name="">
             <a:extLst xmlns:a="http://schemas.openxmlformats.org/drawingml/2006/main">
               <a:ext uri="{FF2B5EF4-FFF2-40B4-BE49-F238E27FC236}">
-                <a16:creationId xmlns:a16="http://schemas.microsoft.com/office/drawing/2014/main" id="{78D8A80C-DA2E-4315-8A9C-4AD06EDCD33C}"/>
+                <a16:creationId xmlns:a16="http://schemas.microsoft.com/office/drawing/2014/main" id="{EB81FD40-F6EF-433E-B5F2-E56342E918D0}"/>
               </a:ext>
             </a:extLst>
           </p:cNvPr>
@@ -5686,7 +5646,7 @@
           <p:cNvPr id="19" name="">
             <a:extLst xmlns:a="http://schemas.openxmlformats.org/drawingml/2006/main">
               <a:ext uri="{FF2B5EF4-FFF2-40B4-BE49-F238E27FC236}">
-                <a16:creationId xmlns:a16="http://schemas.microsoft.com/office/drawing/2014/main" id="{7675F7FC-DE51-420E-93D0-7124A77D19C8}"/>
+                <a16:creationId xmlns:a16="http://schemas.microsoft.com/office/drawing/2014/main" id="{2B89C924-DBD7-4FF8-A478-35CEAB69C89B}"/>
               </a:ext>
             </a:extLst>
           </p:cNvPr>
@@ -5822,7 +5782,7 @@
           <p:cNvPr id="23" name="">
             <a:extLst xmlns:a="http://schemas.openxmlformats.org/drawingml/2006/main">
               <a:ext uri="{FF2B5EF4-FFF2-40B4-BE49-F238E27FC236}">
-                <a16:creationId xmlns:a16="http://schemas.microsoft.com/office/drawing/2014/main" id="{9A21D499-D5F8-4B6D-9F1C-B5A8B0C89AB1}"/>
+                <a16:creationId xmlns:a16="http://schemas.microsoft.com/office/drawing/2014/main" id="{FF1A847B-B56B-4939-94EB-D6D730552E6B}"/>
               </a:ext>
             </a:extLst>
           </p:cNvPr>
@@ -5853,7 +5813,7 @@
           <p:cNvPr id="24" name="">
             <a:extLst xmlns:a="http://schemas.openxmlformats.org/drawingml/2006/main">
               <a:ext uri="{FF2B5EF4-FFF2-40B4-BE49-F238E27FC236}">
-                <a16:creationId xmlns:a16="http://schemas.microsoft.com/office/drawing/2014/main" id="{68C5D219-6D0A-4375-B36C-F7D75ACCC944}"/>
+                <a16:creationId xmlns:a16="http://schemas.microsoft.com/office/drawing/2014/main" id="{EE832BF4-92B8-46F6-B0BD-BF9E0F32F2B0}"/>
               </a:ext>
             </a:extLst>
           </p:cNvPr>
@@ -5911,7 +5871,7 @@
           <p:cNvPr id="25" name="">
             <a:extLst xmlns:a="http://schemas.openxmlformats.org/drawingml/2006/main">
               <a:ext uri="{FF2B5EF4-FFF2-40B4-BE49-F238E27FC236}">
-                <a16:creationId xmlns:a16="http://schemas.microsoft.com/office/drawing/2014/main" id="{625DA148-AA93-4BC2-8426-FA089BFC40CB}"/>
+                <a16:creationId xmlns:a16="http://schemas.microsoft.com/office/drawing/2014/main" id="{9C3F87FC-79E2-4A3A-8E65-70AE07B49BDA}"/>
               </a:ext>
             </a:extLst>
           </p:cNvPr>
@@ -5969,7 +5929,7 @@
           <p:cNvPr id="26" name="">
             <a:extLst xmlns:a="http://schemas.openxmlformats.org/drawingml/2006/main">
               <a:ext uri="{FF2B5EF4-FFF2-40B4-BE49-F238E27FC236}">
-                <a16:creationId xmlns:a16="http://schemas.microsoft.com/office/drawing/2014/main" id="{AF901006-F36F-4A24-98DC-37B9716304D1}"/>
+                <a16:creationId xmlns:a16="http://schemas.microsoft.com/office/drawing/2014/main" id="{B6A17E0E-3ADF-4FE3-9576-94BECFAD9134}"/>
               </a:ext>
             </a:extLst>
           </p:cNvPr>
@@ -6027,7 +5987,7 @@
           <p:cNvPr id="27" name="">
             <a:extLst xmlns:a="http://schemas.openxmlformats.org/drawingml/2006/main">
               <a:ext uri="{FF2B5EF4-FFF2-40B4-BE49-F238E27FC236}">
-                <a16:creationId xmlns:a16="http://schemas.microsoft.com/office/drawing/2014/main" id="{03638A67-1E25-4CAE-8CE0-80334AE29F7E}"/>
+                <a16:creationId xmlns:a16="http://schemas.microsoft.com/office/drawing/2014/main" id="{BE8BCCB2-8006-4493-BF5B-2A78AABD7E42}"/>
               </a:ext>
             </a:extLst>
           </p:cNvPr>
@@ -6058,7 +6018,7 @@
           <p:cNvPr id="28" name="">
             <a:extLst xmlns:a="http://schemas.openxmlformats.org/drawingml/2006/main">
               <a:ext uri="{FF2B5EF4-FFF2-40B4-BE49-F238E27FC236}">
-                <a16:creationId xmlns:a16="http://schemas.microsoft.com/office/drawing/2014/main" id="{9E67ED3B-26A1-410E-A05F-6140759C72BD}"/>
+                <a16:creationId xmlns:a16="http://schemas.microsoft.com/office/drawing/2014/main" id="{6E0D84E8-5067-49A4-B30D-CEDA24847ADD}"/>
               </a:ext>
             </a:extLst>
           </p:cNvPr>
@@ -6114,7 +6074,7 @@
     </p:spTree>
     <p:extLst>
       <p:ext uri="{BB962C8B-B14F-4D97-AF65-F5344CB8AC3E}">
-        <p14:creationId xmlns:p14="http://schemas.microsoft.com/office/powerpoint/2010/main" val="1025238420"/>
+        <p14:creationId xmlns:p14="http://schemas.microsoft.com/office/powerpoint/2010/main" val="239083573"/>
       </p:ext>
     </p:extLst>
   </p:cSld>
@@ -6145,7 +6105,7 @@
           <p:cNvPr id="17" name="">
             <a:extLst xmlns:a="http://schemas.openxmlformats.org/drawingml/2006/main">
               <a:ext uri="{FF2B5EF4-FFF2-40B4-BE49-F238E27FC236}">
-                <a16:creationId xmlns:a16="http://schemas.microsoft.com/office/drawing/2014/main" id="{16588818-7AF2-4182-899A-757C8D2AB804}"/>
+                <a16:creationId xmlns:a16="http://schemas.microsoft.com/office/drawing/2014/main" id="{723064E3-138E-40CC-B9C6-2253CCAFC57D}"/>
               </a:ext>
             </a:extLst>
           </p:cNvPr>
@@ -6176,7 +6136,7 @@
           <p:cNvPr id="2" name="">
             <a:extLst xmlns:a="http://schemas.openxmlformats.org/drawingml/2006/main">
               <a:ext uri="{FF2B5EF4-FFF2-40B4-BE49-F238E27FC236}">
-                <a16:creationId xmlns:a16="http://schemas.microsoft.com/office/drawing/2014/main" id="{AA158A59-7F20-4ECC-9CD7-727D29F837F3}"/>
+                <a16:creationId xmlns:a16="http://schemas.microsoft.com/office/drawing/2014/main" id="{6B8A8035-EF66-408B-B4B0-54BE3D66C87B}"/>
               </a:ext>
             </a:extLst>
           </p:cNvPr>
@@ -6206,7 +6166,7 @@
           <a:lstStyle xmlns:a="http://schemas.openxmlformats.org/drawingml/2006/main"/>
           <a:p xmlns:a="http://schemas.openxmlformats.org/drawingml/2006/main">
             <a:pPr algn="l">
-              <a:defRPr sz="2475" b="1" i="0">
+              <a:defRPr sz="3225" b="1" i="0">
                 <a:solidFill>
                   <a:srgbClr val="102A43"/>
                 </a:solidFill>
@@ -6216,7 +6176,7 @@
               </a:defRPr>
             </a:pPr>
             <a:r>
-              <a:rPr sz="2475" b="1" i="0">
+              <a:rPr sz="3225" b="1" i="0">
                 <a:solidFill>
                   <a:srgbClr val="102A43"/>
                 </a:solidFill>
@@ -6224,7 +6184,7 @@
                 <a:ea typeface="Nimbus Sans"/>
                 <a:cs typeface="Nimbus Sans"/>
               </a:rPr>
-              <a:t>The evidence base is large by session count and narrow by setting</a:t>
+              <a:t>Evidence from one retrospective setting</a:t>
             </a:r>
           </a:p>
         </p:txBody>
@@ -6234,7 +6194,7 @@
           <p:cNvPr id="3" name="">
             <a:extLst xmlns:a="http://schemas.openxmlformats.org/drawingml/2006/main">
               <a:ext uri="{FF2B5EF4-FFF2-40B4-BE49-F238E27FC236}">
-                <a16:creationId xmlns:a16="http://schemas.microsoft.com/office/drawing/2014/main" id="{7DAE078D-B95F-411E-8429-528C9BABCE6C}"/>
+                <a16:creationId xmlns:a16="http://schemas.microsoft.com/office/drawing/2014/main" id="{5DB7078B-134B-4995-9528-25289377AF52}"/>
               </a:ext>
             </a:extLst>
           </p:cNvPr>
@@ -6296,7 +6256,7 @@
           <p:nvPr/>
         </p:nvPicPr>
         <p:blipFill>
-          <a:blip xmlns:r="http://schemas.openxmlformats.org/officeDocument/2006/relationships" xmlns:a="http://schemas.openxmlformats.org/drawingml/2006/main" r:embed="R092e52d54ea542b3"/>
+          <a:blip xmlns:r="http://schemas.openxmlformats.org/officeDocument/2006/relationships" xmlns:a="http://schemas.openxmlformats.org/drawingml/2006/main" r:embed="Ra20fd4d4b1ac4233"/>
           <a:stretch xmlns:a="http://schemas.openxmlformats.org/drawingml/2006/main"/>
         </p:blipFill>
         <p:spPr>
@@ -6314,7 +6274,7 @@
           <p:cNvPr id="5" name="">
             <a:extLst xmlns:a="http://schemas.openxmlformats.org/drawingml/2006/main">
               <a:ext uri="{FF2B5EF4-FFF2-40B4-BE49-F238E27FC236}">
-                <a16:creationId xmlns:a16="http://schemas.microsoft.com/office/drawing/2014/main" id="{D87EF7ED-2FED-4A02-BD34-6E36ED51626A}"/>
+                <a16:creationId xmlns:a16="http://schemas.microsoft.com/office/drawing/2014/main" id="{AF941FC8-1BB0-4722-9AAE-55ED81765E00}"/>
               </a:ext>
             </a:extLst>
           </p:cNvPr>
@@ -6372,7 +6332,7 @@
           <p:cNvPr id="6" name="">
             <a:extLst xmlns:a="http://schemas.openxmlformats.org/drawingml/2006/main">
               <a:ext uri="{FF2B5EF4-FFF2-40B4-BE49-F238E27FC236}">
-                <a16:creationId xmlns:a16="http://schemas.microsoft.com/office/drawing/2014/main" id="{B57E91C5-2417-438D-8EE7-EF47C3AA880E}"/>
+                <a16:creationId xmlns:a16="http://schemas.microsoft.com/office/drawing/2014/main" id="{9DE5FDF7-1C56-492B-8421-457620021247}"/>
               </a:ext>
             </a:extLst>
           </p:cNvPr>
@@ -6430,7 +6390,7 @@
           <p:cNvPr id="7" name="">
             <a:extLst xmlns:a="http://schemas.openxmlformats.org/drawingml/2006/main">
               <a:ext uri="{FF2B5EF4-FFF2-40B4-BE49-F238E27FC236}">
-                <a16:creationId xmlns:a16="http://schemas.microsoft.com/office/drawing/2014/main" id="{9D08718F-7613-4217-8AED-FFFA7924F0D9}"/>
+                <a16:creationId xmlns:a16="http://schemas.microsoft.com/office/drawing/2014/main" id="{C414868F-3444-4B5F-A83A-9263C4A3F405}"/>
               </a:ext>
             </a:extLst>
           </p:cNvPr>
@@ -6488,7 +6448,7 @@
           <p:cNvPr id="8" name="">
             <a:extLst xmlns:a="http://schemas.openxmlformats.org/drawingml/2006/main">
               <a:ext uri="{FF2B5EF4-FFF2-40B4-BE49-F238E27FC236}">
-                <a16:creationId xmlns:a16="http://schemas.microsoft.com/office/drawing/2014/main" id="{C8E25EF6-E2AE-4055-B9A7-5A27D89A87C1}"/>
+                <a16:creationId xmlns:a16="http://schemas.microsoft.com/office/drawing/2014/main" id="{C6651D4E-4222-47EC-BEA0-22E677DB124A}"/>
               </a:ext>
             </a:extLst>
           </p:cNvPr>
@@ -6546,7 +6506,7 @@
           <p:cNvPr id="9" name="">
             <a:extLst xmlns:a="http://schemas.openxmlformats.org/drawingml/2006/main">
               <a:ext uri="{FF2B5EF4-FFF2-40B4-BE49-F238E27FC236}">
-                <a16:creationId xmlns:a16="http://schemas.microsoft.com/office/drawing/2014/main" id="{0F0E5546-15CA-43C1-8ECF-128E4F9FB277}"/>
+                <a16:creationId xmlns:a16="http://schemas.microsoft.com/office/drawing/2014/main" id="{AF583C06-566B-4CF1-BF7B-19E8BE32A022}"/>
               </a:ext>
             </a:extLst>
           </p:cNvPr>
@@ -6604,7 +6564,7 @@
           <p:cNvPr id="10" name="">
             <a:extLst xmlns:a="http://schemas.openxmlformats.org/drawingml/2006/main">
               <a:ext uri="{FF2B5EF4-FFF2-40B4-BE49-F238E27FC236}">
-                <a16:creationId xmlns:a16="http://schemas.microsoft.com/office/drawing/2014/main" id="{AA11F8DD-32A6-43DE-A7F0-062EEFDD6FA5}"/>
+                <a16:creationId xmlns:a16="http://schemas.microsoft.com/office/drawing/2014/main" id="{2BC0B5DF-317B-4C2D-BC87-962921EC9D87}"/>
               </a:ext>
             </a:extLst>
           </p:cNvPr>
@@ -6662,7 +6622,7 @@
           <p:cNvPr id="11" name="">
             <a:extLst xmlns:a="http://schemas.openxmlformats.org/drawingml/2006/main">
               <a:ext uri="{FF2B5EF4-FFF2-40B4-BE49-F238E27FC236}">
-                <a16:creationId xmlns:a16="http://schemas.microsoft.com/office/drawing/2014/main" id="{7D4FC805-8A2E-407B-AF6F-86C837034CB0}"/>
+                <a16:creationId xmlns:a16="http://schemas.microsoft.com/office/drawing/2014/main" id="{1A625D5F-3026-41E0-942F-1A675E73BAF9}"/>
               </a:ext>
             </a:extLst>
           </p:cNvPr>
@@ -6693,7 +6653,7 @@
           <p:cNvPr id="12" name="">
             <a:extLst xmlns:a="http://schemas.openxmlformats.org/drawingml/2006/main">
               <a:ext uri="{FF2B5EF4-FFF2-40B4-BE49-F238E27FC236}">
-                <a16:creationId xmlns:a16="http://schemas.microsoft.com/office/drawing/2014/main" id="{7507A655-37E8-4E0F-AB92-B796D3DA38DC}"/>
+                <a16:creationId xmlns:a16="http://schemas.microsoft.com/office/drawing/2014/main" id="{00D248F9-67CF-4F01-9B64-889BB7AEE811}"/>
               </a:ext>
             </a:extLst>
           </p:cNvPr>
@@ -6751,7 +6711,7 @@
           <p:cNvPr id="13" name="">
             <a:extLst xmlns:a="http://schemas.openxmlformats.org/drawingml/2006/main">
               <a:ext uri="{FF2B5EF4-FFF2-40B4-BE49-F238E27FC236}">
-                <a16:creationId xmlns:a16="http://schemas.microsoft.com/office/drawing/2014/main" id="{409677BD-4A08-4404-94E9-79A9626C0AC9}"/>
+                <a16:creationId xmlns:a16="http://schemas.microsoft.com/office/drawing/2014/main" id="{8797250D-0ED0-4BA8-9BED-2D2B58A4DA61}"/>
               </a:ext>
             </a:extLst>
           </p:cNvPr>
@@ -6809,7 +6769,7 @@
           <p:cNvPr id="14" name="">
             <a:extLst xmlns:a="http://schemas.openxmlformats.org/drawingml/2006/main">
               <a:ext uri="{FF2B5EF4-FFF2-40B4-BE49-F238E27FC236}">
-                <a16:creationId xmlns:a16="http://schemas.microsoft.com/office/drawing/2014/main" id="{267E0BF3-0DBB-4439-979E-386331D8ECBE}"/>
+                <a16:creationId xmlns:a16="http://schemas.microsoft.com/office/drawing/2014/main" id="{5F07A1B9-6D5E-4F74-B9CC-A9D45525C904}"/>
               </a:ext>
             </a:extLst>
           </p:cNvPr>
@@ -6867,7 +6827,7 @@
           <p:cNvPr id="15" name="">
             <a:extLst xmlns:a="http://schemas.openxmlformats.org/drawingml/2006/main">
               <a:ext uri="{FF2B5EF4-FFF2-40B4-BE49-F238E27FC236}">
-                <a16:creationId xmlns:a16="http://schemas.microsoft.com/office/drawing/2014/main" id="{686D70F0-9C68-4981-868E-05F7333595DA}"/>
+                <a16:creationId xmlns:a16="http://schemas.microsoft.com/office/drawing/2014/main" id="{21F0FB7F-7836-4C92-8F39-BEFFA3C6DE43}"/>
               </a:ext>
             </a:extLst>
           </p:cNvPr>
@@ -6898,7 +6858,7 @@
           <p:cNvPr id="16" name="">
             <a:extLst xmlns:a="http://schemas.openxmlformats.org/drawingml/2006/main">
               <a:ext uri="{FF2B5EF4-FFF2-40B4-BE49-F238E27FC236}">
-                <a16:creationId xmlns:a16="http://schemas.microsoft.com/office/drawing/2014/main" id="{F563B7CF-5E5D-4ECC-8DDF-7B5588DB683F}"/>
+                <a16:creationId xmlns:a16="http://schemas.microsoft.com/office/drawing/2014/main" id="{B59A0294-A280-43EC-8F5B-6BEE65983554}"/>
               </a:ext>
             </a:extLst>
           </p:cNvPr>
@@ -6954,7 +6914,7 @@
     </p:spTree>
     <p:extLst>
       <p:ext uri="{BB962C8B-B14F-4D97-AF65-F5344CB8AC3E}">
-        <p14:creationId xmlns:p14="http://schemas.microsoft.com/office/powerpoint/2010/main" val="876567448"/>
+        <p14:creationId xmlns:p14="http://schemas.microsoft.com/office/powerpoint/2010/main" val="1517043802"/>
       </p:ext>
     </p:extLst>
   </p:cSld>
@@ -6982,10 +6942,10 @@
       </p:grpSpPr>
       <p:sp>
         <p:nvSpPr>
-          <p:cNvPr id="12" name="">
-            <a:extLst xmlns:a="http://schemas.openxmlformats.org/drawingml/2006/main">
-              <a:ext uri="{FF2B5EF4-FFF2-40B4-BE49-F238E27FC236}">
-                <a16:creationId xmlns:a16="http://schemas.microsoft.com/office/drawing/2014/main" id="{107752AC-0014-4DB2-9989-2FD1343D5965}"/>
+          <p:cNvPr id="14" name="">
+            <a:extLst xmlns:a="http://schemas.openxmlformats.org/drawingml/2006/main">
+              <a:ext uri="{FF2B5EF4-FFF2-40B4-BE49-F238E27FC236}">
+                <a16:creationId xmlns:a16="http://schemas.microsoft.com/office/drawing/2014/main" id="{E67AAEBC-9DD9-4237-AA82-7D547E4C7B70}"/>
               </a:ext>
             </a:extLst>
           </p:cNvPr>
@@ -7016,7 +6976,7 @@
           <p:cNvPr id="2" name="">
             <a:extLst xmlns:a="http://schemas.openxmlformats.org/drawingml/2006/main">
               <a:ext uri="{FF2B5EF4-FFF2-40B4-BE49-F238E27FC236}">
-                <a16:creationId xmlns:a16="http://schemas.microsoft.com/office/drawing/2014/main" id="{BE46DDD8-56A1-4928-8B4B-0D4A34625C4D}"/>
+                <a16:creationId xmlns:a16="http://schemas.microsoft.com/office/drawing/2014/main" id="{BB8F6E50-D9D4-46CF-B7D9-CC5A9D0150C9}"/>
               </a:ext>
             </a:extLst>
           </p:cNvPr>
@@ -7046,7 +7006,7 @@
           <a:lstStyle xmlns:a="http://schemas.openxmlformats.org/drawingml/2006/main"/>
           <a:p xmlns:a="http://schemas.openxmlformats.org/drawingml/2006/main">
             <a:pPr algn="l">
-              <a:defRPr sz="2325" b="1" i="0">
+              <a:defRPr sz="3225" b="1" i="0">
                 <a:solidFill>
                   <a:srgbClr val="102A43"/>
                 </a:solidFill>
@@ -7056,7 +7016,7 @@
               </a:defRPr>
             </a:pPr>
             <a:r>
-              <a:rPr sz="2325" b="1" i="0">
+              <a:rPr sz="3225" b="1" i="0">
                 <a:solidFill>
                   <a:srgbClr val="102A43"/>
                 </a:solidFill>
@@ -7064,7 +7024,7 @@
                 <a:ea typeface="Nimbus Sans"/>
                 <a:cs typeface="Nimbus Sans"/>
               </a:rPr>
-              <a:t>At 20% review capacity, 5.9 observed events concentrate in the alert group</a:t>
+              <a:t>Workload at 20% review capacity</a:t>
             </a:r>
           </a:p>
         </p:txBody>
@@ -7074,7 +7034,7 @@
           <p:cNvPr id="3" name="">
             <a:extLst xmlns:a="http://schemas.openxmlformats.org/drawingml/2006/main">
               <a:ext uri="{FF2B5EF4-FFF2-40B4-BE49-F238E27FC236}">
-                <a16:creationId xmlns:a16="http://schemas.microsoft.com/office/drawing/2014/main" id="{06FD3178-AB05-4D45-86DA-F72932A55475}"/>
+                <a16:creationId xmlns:a16="http://schemas.microsoft.com/office/drawing/2014/main" id="{B877C366-57C4-4361-AE74-279BBD6E9A72}"/>
               </a:ext>
             </a:extLst>
           </p:cNvPr>
@@ -7129,7 +7089,7 @@
       </p:sp>
       <p:graphicFrame>
         <p:nvGraphicFramePr>
-          <p:cNvPr id="15" name="Chart"/>
+          <p:cNvPr id="17" name="Chart"/>
           <p:cNvGraphicFramePr/>
           <p:nvPr/>
         </p:nvGraphicFramePr>
@@ -7139,13 +7099,13 @@
         </p:xfrm>
         <a:graphic xmlns:a="http://schemas.openxmlformats.org/drawingml/2006/main">
           <a:graphicData uri="http://schemas.openxmlformats.org/drawingml/2006/chart">
-            <c:chart xmlns:r="http://schemas.openxmlformats.org/officeDocument/2006/relationships" xmlns:c="http://schemas.openxmlformats.org/drawingml/2006/chart" r:id="Rf3fb530cc62a4a28"/>
+            <c:chart xmlns:r="http://schemas.openxmlformats.org/officeDocument/2006/relationships" xmlns:c="http://schemas.openxmlformats.org/drawingml/2006/chart" r:id="R3ee277c1cee04224"/>
           </a:graphicData>
         </a:graphic>
       </p:graphicFrame>
       <p:graphicFrame>
         <p:nvGraphicFramePr>
-          <p:cNvPr id="16" name="Chart"/>
+          <p:cNvPr id="18" name="Chart"/>
           <p:cNvGraphicFramePr/>
           <p:nvPr/>
         </p:nvGraphicFramePr>
@@ -7155,7 +7115,7 @@
         </p:xfrm>
         <a:graphic xmlns:a="http://schemas.openxmlformats.org/drawingml/2006/main">
           <a:graphicData uri="http://schemas.openxmlformats.org/drawingml/2006/chart">
-            <c:chart xmlns:r="http://schemas.openxmlformats.org/officeDocument/2006/relationships" xmlns:c="http://schemas.openxmlformats.org/drawingml/2006/chart" r:id="Raf4f07b38cf3416a"/>
+            <c:chart xmlns:r="http://schemas.openxmlformats.org/officeDocument/2006/relationships" xmlns:c="http://schemas.openxmlformats.org/drawingml/2006/chart" r:id="R42931ae315434791"/>
           </a:graphicData>
         </a:graphic>
       </p:graphicFrame>
@@ -7164,7 +7124,123 @@
           <p:cNvPr id="6" name="">
             <a:extLst xmlns:a="http://schemas.openxmlformats.org/drawingml/2006/main">
               <a:ext uri="{FF2B5EF4-FFF2-40B4-BE49-F238E27FC236}">
-                <a16:creationId xmlns:a16="http://schemas.microsoft.com/office/drawing/2014/main" id="{DBEFE700-46B9-4B0E-9E71-05B457564B44}"/>
+                <a16:creationId xmlns:a16="http://schemas.microsoft.com/office/drawing/2014/main" id="{68EA3AF7-AB58-4933-9AFC-6D26128C8F4C}"/>
+              </a:ext>
+            </a:extLst>
+          </p:cNvPr>
+          <p:cNvSpPr>
+            <a:spLocks xmlns:a="http://schemas.openxmlformats.org/drawingml/2006/main" noGrp="1"/>
+          </p:cNvSpPr>
+          <p:nvPr/>
+        </p:nvSpPr>
+        <p:spPr>
+          <a:xfrm xmlns:a="http://schemas.openxmlformats.org/drawingml/2006/main">
+            <a:off x="714375" y="4676775"/>
+            <a:ext cx="5381625" cy="304800"/>
+          </a:xfrm>
+          <a:prstGeom xmlns:a="http://schemas.openxmlformats.org/drawingml/2006/main" prst="rect">
+            <a:avLst/>
+          </a:prstGeom>
+          <a:noFill xmlns:a="http://schemas.openxmlformats.org/drawingml/2006/main"/>
+          <a:ln xmlns:a="http://schemas.openxmlformats.org/drawingml/2006/main" w="0">
+            <a:noFill/>
+            <a:prstDash val="solid"/>
+          </a:ln>
+        </p:spPr>
+        <p:txBody>
+          <a:bodyPr xmlns:a="http://schemas.openxmlformats.org/drawingml/2006/main" wrap="square" lIns="0" tIns="0" rIns="0" bIns="0" anchor="t">
+            <a:noAutofit/>
+          </a:bodyPr>
+          <a:lstStyle xmlns:a="http://schemas.openxmlformats.org/drawingml/2006/main"/>
+          <a:p xmlns:a="http://schemas.openxmlformats.org/drawingml/2006/main">
+            <a:pPr algn="l">
+              <a:defRPr sz="1350" b="0" i="0">
+                <a:solidFill>
+                  <a:srgbClr val="243B53"/>
+                </a:solidFill>
+                <a:latin typeface="Nimbus Sans"/>
+                <a:ea typeface="Nimbus Sans"/>
+                <a:cs typeface="Nimbus Sans"/>
+              </a:defRPr>
+            </a:pPr>
+            <a:r>
+              <a:rPr sz="1350" b="0" i="0">
+                <a:solidFill>
+                  <a:srgbClr val="243B53"/>
+                </a:solidFill>
+                <a:latin typeface="Nimbus Sans"/>
+                <a:ea typeface="Nimbus Sans"/>
+                <a:cs typeface="Nimbus Sans"/>
+              </a:rPr>
+              <a:t>Teal: captured 69.1%    Gray: missed 30.9%</a:t>
+            </a:r>
+          </a:p>
+        </p:txBody>
+      </p:sp>
+      <p:sp>
+        <p:nvSpPr>
+          <p:cNvPr id="7" name="">
+            <a:extLst xmlns:a="http://schemas.openxmlformats.org/drawingml/2006/main">
+              <a:ext uri="{FF2B5EF4-FFF2-40B4-BE49-F238E27FC236}">
+                <a16:creationId xmlns:a16="http://schemas.microsoft.com/office/drawing/2014/main" id="{D6CC613D-F0D8-4D2A-902A-5F327B80621F}"/>
+              </a:ext>
+            </a:extLst>
+          </p:cNvPr>
+          <p:cNvSpPr>
+            <a:spLocks xmlns:a="http://schemas.openxmlformats.org/drawingml/2006/main" noGrp="1"/>
+          </p:cNvSpPr>
+          <p:nvPr/>
+        </p:nvSpPr>
+        <p:spPr>
+          <a:xfrm xmlns:a="http://schemas.openxmlformats.org/drawingml/2006/main">
+            <a:off x="6648450" y="4676775"/>
+            <a:ext cx="5048250" cy="304800"/>
+          </a:xfrm>
+          <a:prstGeom xmlns:a="http://schemas.openxmlformats.org/drawingml/2006/main" prst="rect">
+            <a:avLst/>
+          </a:prstGeom>
+          <a:noFill xmlns:a="http://schemas.openxmlformats.org/drawingml/2006/main"/>
+          <a:ln xmlns:a="http://schemas.openxmlformats.org/drawingml/2006/main" w="0">
+            <a:noFill/>
+            <a:prstDash val="solid"/>
+          </a:ln>
+        </p:spPr>
+        <p:txBody>
+          <a:bodyPr xmlns:a="http://schemas.openxmlformats.org/drawingml/2006/main" wrap="square" lIns="0" tIns="0" rIns="0" bIns="0" anchor="t">
+            <a:noAutofit/>
+          </a:bodyPr>
+          <a:lstStyle xmlns:a="http://schemas.openxmlformats.org/drawingml/2006/main"/>
+          <a:p xmlns:a="http://schemas.openxmlformats.org/drawingml/2006/main">
+            <a:pPr algn="l">
+              <a:defRPr sz="1350" b="0" i="0">
+                <a:solidFill>
+                  <a:srgbClr val="243B53"/>
+                </a:solidFill>
+                <a:latin typeface="Nimbus Sans"/>
+                <a:ea typeface="Nimbus Sans"/>
+                <a:cs typeface="Nimbus Sans"/>
+              </a:defRPr>
+            </a:pPr>
+            <a:r>
+              <a:rPr sz="1350" b="0" i="0">
+                <a:solidFill>
+                  <a:srgbClr val="243B53"/>
+                </a:solidFill>
+                <a:latin typeface="Nimbus Sans"/>
+                <a:ea typeface="Nimbus Sans"/>
+                <a:cs typeface="Nimbus Sans"/>
+              </a:rPr>
+              <a:t>Coral: event 29.4%    Gold: no event 70.6%</a:t>
+            </a:r>
+          </a:p>
+        </p:txBody>
+      </p:sp>
+      <p:sp>
+        <p:nvSpPr>
+          <p:cNvPr id="8" name="">
+            <a:extLst xmlns:a="http://schemas.openxmlformats.org/drawingml/2006/main">
+              <a:ext uri="{FF2B5EF4-FFF2-40B4-BE49-F238E27FC236}">
+                <a16:creationId xmlns:a16="http://schemas.microsoft.com/office/drawing/2014/main" id="{23EA5441-B6C5-449C-AD47-921C494762C2}"/>
               </a:ext>
             </a:extLst>
           </p:cNvPr>
@@ -7219,10 +7295,10 @@
       </p:sp>
       <p:sp>
         <p:nvSpPr>
-          <p:cNvPr id="7" name="">
-            <a:extLst xmlns:a="http://schemas.openxmlformats.org/drawingml/2006/main">
-              <a:ext uri="{FF2B5EF4-FFF2-40B4-BE49-F238E27FC236}">
-                <a16:creationId xmlns:a16="http://schemas.microsoft.com/office/drawing/2014/main" id="{4A0F2E77-059D-4E78-827D-797CDF97311A}"/>
+          <p:cNvPr id="9" name="">
+            <a:extLst xmlns:a="http://schemas.openxmlformats.org/drawingml/2006/main">
+              <a:ext uri="{FF2B5EF4-FFF2-40B4-BE49-F238E27FC236}">
+                <a16:creationId xmlns:a16="http://schemas.microsoft.com/office/drawing/2014/main" id="{57EC8ED0-BD40-4D08-BB8F-818A30C8A443}"/>
               </a:ext>
             </a:extLst>
           </p:cNvPr>
@@ -7277,10 +7353,10 @@
       </p:sp>
       <p:sp>
         <p:nvSpPr>
-          <p:cNvPr id="8" name="">
-            <a:extLst xmlns:a="http://schemas.openxmlformats.org/drawingml/2006/main">
-              <a:ext uri="{FF2B5EF4-FFF2-40B4-BE49-F238E27FC236}">
-                <a16:creationId xmlns:a16="http://schemas.microsoft.com/office/drawing/2014/main" id="{492210A7-7A32-4C6E-BCB2-7DECC20170BF}"/>
+          <p:cNvPr id="10" name="">
+            <a:extLst xmlns:a="http://schemas.openxmlformats.org/drawingml/2006/main">
+              <a:ext uri="{FF2B5EF4-FFF2-40B4-BE49-F238E27FC236}">
+                <a16:creationId xmlns:a16="http://schemas.microsoft.com/office/drawing/2014/main" id="{51A34564-240D-457D-AFA4-DAF87BA5B694}"/>
               </a:ext>
             </a:extLst>
           </p:cNvPr>
@@ -7335,10 +7411,10 @@
       </p:sp>
       <p:sp>
         <p:nvSpPr>
-          <p:cNvPr id="9" name="">
-            <a:extLst xmlns:a="http://schemas.openxmlformats.org/drawingml/2006/main">
-              <a:ext uri="{FF2B5EF4-FFF2-40B4-BE49-F238E27FC236}">
-                <a16:creationId xmlns:a16="http://schemas.microsoft.com/office/drawing/2014/main" id="{F16751A5-90CC-460B-BED4-FF2241E7A3F7}"/>
+          <p:cNvPr id="11" name="">
+            <a:extLst xmlns:a="http://schemas.openxmlformats.org/drawingml/2006/main">
+              <a:ext uri="{FF2B5EF4-FFF2-40B4-BE49-F238E27FC236}">
+                <a16:creationId xmlns:a16="http://schemas.microsoft.com/office/drawing/2014/main" id="{4654930D-101B-4E05-BF20-D8E60479E7AA}"/>
               </a:ext>
             </a:extLst>
           </p:cNvPr>
@@ -7393,10 +7469,10 @@
       </p:sp>
       <p:sp>
         <p:nvSpPr>
-          <p:cNvPr id="10" name="">
-            <a:extLst xmlns:a="http://schemas.openxmlformats.org/drawingml/2006/main">
-              <a:ext uri="{FF2B5EF4-FFF2-40B4-BE49-F238E27FC236}">
-                <a16:creationId xmlns:a16="http://schemas.microsoft.com/office/drawing/2014/main" id="{80DE89FF-66A3-41DE-B801-216FF5CC5700}"/>
+          <p:cNvPr id="12" name="">
+            <a:extLst xmlns:a="http://schemas.openxmlformats.org/drawingml/2006/main">
+              <a:ext uri="{FF2B5EF4-FFF2-40B4-BE49-F238E27FC236}">
+                <a16:creationId xmlns:a16="http://schemas.microsoft.com/office/drawing/2014/main" id="{C02658A5-94DB-4791-B87F-FEF73FCCC866}"/>
               </a:ext>
             </a:extLst>
           </p:cNvPr>
@@ -7424,10 +7500,10 @@
       </p:sp>
       <p:sp>
         <p:nvSpPr>
-          <p:cNvPr id="11" name="">
-            <a:extLst xmlns:a="http://schemas.openxmlformats.org/drawingml/2006/main">
-              <a:ext uri="{FF2B5EF4-FFF2-40B4-BE49-F238E27FC236}">
-                <a16:creationId xmlns:a16="http://schemas.microsoft.com/office/drawing/2014/main" id="{8A98C372-2360-4CE8-AF60-1051E1068C1F}"/>
+          <p:cNvPr id="13" name="">
+            <a:extLst xmlns:a="http://schemas.openxmlformats.org/drawingml/2006/main">
+              <a:ext uri="{FF2B5EF4-FFF2-40B4-BE49-F238E27FC236}">
+                <a16:creationId xmlns:a16="http://schemas.microsoft.com/office/drawing/2014/main" id="{A30B3E0E-208F-4432-8B3A-AD7868BC4FFB}"/>
               </a:ext>
             </a:extLst>
           </p:cNvPr>
@@ -7483,7 +7559,7 @@
     </p:spTree>
     <p:extLst>
       <p:ext uri="{BB962C8B-B14F-4D97-AF65-F5344CB8AC3E}">
-        <p14:creationId xmlns:p14="http://schemas.microsoft.com/office/powerpoint/2010/main" val="1388446995"/>
+        <p14:creationId xmlns:p14="http://schemas.microsoft.com/office/powerpoint/2010/main" val="891382167"/>
       </p:ext>
     </p:extLst>
   </p:cSld>
@@ -7514,7 +7590,7 @@
           <p:cNvPr id="29" name="">
             <a:extLst xmlns:a="http://schemas.openxmlformats.org/drawingml/2006/main">
               <a:ext uri="{FF2B5EF4-FFF2-40B4-BE49-F238E27FC236}">
-                <a16:creationId xmlns:a16="http://schemas.microsoft.com/office/drawing/2014/main" id="{44AF8819-D6BB-47E8-899D-942CDB2B6173}"/>
+                <a16:creationId xmlns:a16="http://schemas.microsoft.com/office/drawing/2014/main" id="{E66D5993-013B-4610-B691-8BDB082D8623}"/>
               </a:ext>
             </a:extLst>
           </p:cNvPr>
@@ -7545,7 +7621,7 @@
           <p:cNvPr id="2" name="">
             <a:extLst xmlns:a="http://schemas.openxmlformats.org/drawingml/2006/main">
               <a:ext uri="{FF2B5EF4-FFF2-40B4-BE49-F238E27FC236}">
-                <a16:creationId xmlns:a16="http://schemas.microsoft.com/office/drawing/2014/main" id="{057B3602-0E34-4A7A-851A-68FB1E5184F6}"/>
+                <a16:creationId xmlns:a16="http://schemas.microsoft.com/office/drawing/2014/main" id="{01CF13EA-76C3-4469-8907-DA68E5FC969B}"/>
               </a:ext>
             </a:extLst>
           </p:cNvPr>
@@ -7575,7 +7651,7 @@
           <a:lstStyle xmlns:a="http://schemas.openxmlformats.org/drawingml/2006/main"/>
           <a:p xmlns:a="http://schemas.openxmlformats.org/drawingml/2006/main">
             <a:pPr algn="l">
-              <a:defRPr sz="2700" b="1" i="0">
+              <a:defRPr sz="3225" b="1" i="0">
                 <a:solidFill>
                   <a:srgbClr val="102A43"/>
                 </a:solidFill>
@@ -7585,7 +7661,7 @@
               </a:defRPr>
             </a:pPr>
             <a:r>
-              <a:rPr sz="2700" b="1" i="0">
+              <a:rPr sz="3225" b="1" i="0">
                 <a:solidFill>
                   <a:srgbClr val="102A43"/>
                 </a:solidFill>
@@ -7593,7 +7669,7 @@
                 <a:ea typeface="Nimbus Sans"/>
                 <a:cs typeface="Nimbus Sans"/>
               </a:rPr>
-              <a:t>ROI depends on clinical effect, not model accuracy alone</a:t>
+              <a:t>ROI measurement framework</a:t>
             </a:r>
           </a:p>
         </p:txBody>
@@ -7603,7 +7679,7 @@
           <p:cNvPr id="3" name="">
             <a:extLst xmlns:a="http://schemas.openxmlformats.org/drawingml/2006/main">
               <a:ext uri="{FF2B5EF4-FFF2-40B4-BE49-F238E27FC236}">
-                <a16:creationId xmlns:a16="http://schemas.microsoft.com/office/drawing/2014/main" id="{B99FCAE9-6907-4260-9778-AAEB3DD7AD32}"/>
+                <a16:creationId xmlns:a16="http://schemas.microsoft.com/office/drawing/2014/main" id="{C2990B1E-E0BC-457D-B564-9FB121C4D5FB}"/>
               </a:ext>
             </a:extLst>
           </p:cNvPr>
@@ -7661,7 +7737,7 @@
           <p:cNvPr id="4" name="">
             <a:extLst xmlns:a="http://schemas.openxmlformats.org/drawingml/2006/main">
               <a:ext uri="{FF2B5EF4-FFF2-40B4-BE49-F238E27FC236}">
-                <a16:creationId xmlns:a16="http://schemas.microsoft.com/office/drawing/2014/main" id="{A6BBA583-E307-4825-8588-1AB9E71E4A00}"/>
+                <a16:creationId xmlns:a16="http://schemas.microsoft.com/office/drawing/2014/main" id="{6B59CC92-59B8-4369-B62D-13A29FDE8B50}"/>
               </a:ext>
             </a:extLst>
           </p:cNvPr>
@@ -7694,7 +7770,7 @@
           <p:cNvPr id="5" name="">
             <a:extLst xmlns:a="http://schemas.openxmlformats.org/drawingml/2006/main">
               <a:ext uri="{FF2B5EF4-FFF2-40B4-BE49-F238E27FC236}">
-                <a16:creationId xmlns:a16="http://schemas.microsoft.com/office/drawing/2014/main" id="{327F3497-658F-45F6-A5D1-1A110F70F070}"/>
+                <a16:creationId xmlns:a16="http://schemas.microsoft.com/office/drawing/2014/main" id="{4FD7E8F5-531D-4D12-9CBF-B6E922CF9CF0}"/>
               </a:ext>
             </a:extLst>
           </p:cNvPr>
@@ -7752,7 +7828,7 @@
           <p:cNvPr id="6" name="">
             <a:extLst xmlns:a="http://schemas.openxmlformats.org/drawingml/2006/main">
               <a:ext uri="{FF2B5EF4-FFF2-40B4-BE49-F238E27FC236}">
-                <a16:creationId xmlns:a16="http://schemas.microsoft.com/office/drawing/2014/main" id="{7D5139C8-BA07-4EDC-82E9-5A524385174D}"/>
+                <a16:creationId xmlns:a16="http://schemas.microsoft.com/office/drawing/2014/main" id="{14313E99-6E62-4C64-B1FF-7BBA10DEC9CE}"/>
               </a:ext>
             </a:extLst>
           </p:cNvPr>
@@ -7810,7 +7886,7 @@
           <p:cNvPr id="7" name="">
             <a:extLst xmlns:a="http://schemas.openxmlformats.org/drawingml/2006/main">
               <a:ext uri="{FF2B5EF4-FFF2-40B4-BE49-F238E27FC236}">
-                <a16:creationId xmlns:a16="http://schemas.microsoft.com/office/drawing/2014/main" id="{B8A114DA-3FD6-4326-B40E-35E3FAAECDF2}"/>
+                <a16:creationId xmlns:a16="http://schemas.microsoft.com/office/drawing/2014/main" id="{88987410-9A57-4B8E-B1C9-E48FC8677E02}"/>
               </a:ext>
             </a:extLst>
           </p:cNvPr>
@@ -7841,7 +7917,7 @@
           <p:cNvPr id="8" name="">
             <a:extLst xmlns:a="http://schemas.openxmlformats.org/drawingml/2006/main">
               <a:ext uri="{FF2B5EF4-FFF2-40B4-BE49-F238E27FC236}">
-                <a16:creationId xmlns:a16="http://schemas.microsoft.com/office/drawing/2014/main" id="{72FBF7C5-917A-436D-B4D6-0A7489D56F79}"/>
+                <a16:creationId xmlns:a16="http://schemas.microsoft.com/office/drawing/2014/main" id="{CF1F1053-8D24-465B-B3CE-C4044A212B40}"/>
               </a:ext>
             </a:extLst>
           </p:cNvPr>
@@ -7899,7 +7975,7 @@
           <p:cNvPr id="9" name="">
             <a:extLst xmlns:a="http://schemas.openxmlformats.org/drawingml/2006/main">
               <a:ext uri="{FF2B5EF4-FFF2-40B4-BE49-F238E27FC236}">
-                <a16:creationId xmlns:a16="http://schemas.microsoft.com/office/drawing/2014/main" id="{B187BB12-E935-472E-91BB-BD4C6F8D35B0}"/>
+                <a16:creationId xmlns:a16="http://schemas.microsoft.com/office/drawing/2014/main" id="{2B515995-814B-4AB8-99C3-7C1D29C78FD6}"/>
               </a:ext>
             </a:extLst>
           </p:cNvPr>
@@ -7930,7 +8006,7 @@
           <p:cNvPr id="10" name="">
             <a:extLst xmlns:a="http://schemas.openxmlformats.org/drawingml/2006/main">
               <a:ext uri="{FF2B5EF4-FFF2-40B4-BE49-F238E27FC236}">
-                <a16:creationId xmlns:a16="http://schemas.microsoft.com/office/drawing/2014/main" id="{F93EBDF8-A9B4-4156-83E4-723D1D234FED}"/>
+                <a16:creationId xmlns:a16="http://schemas.microsoft.com/office/drawing/2014/main" id="{DD0D63A6-0CD9-434B-9AC7-78BC16500EBC}"/>
               </a:ext>
             </a:extLst>
           </p:cNvPr>
@@ -7988,7 +8064,7 @@
           <p:cNvPr id="11" name="">
             <a:extLst xmlns:a="http://schemas.openxmlformats.org/drawingml/2006/main">
               <a:ext uri="{FF2B5EF4-FFF2-40B4-BE49-F238E27FC236}">
-                <a16:creationId xmlns:a16="http://schemas.microsoft.com/office/drawing/2014/main" id="{DBFE2C61-919C-4B03-868F-6EC85AA67E07}"/>
+                <a16:creationId xmlns:a16="http://schemas.microsoft.com/office/drawing/2014/main" id="{DF16E927-03AD-4655-9DA9-AE2852D07FEF}"/>
               </a:ext>
             </a:extLst>
           </p:cNvPr>
@@ -8019,7 +8095,7 @@
           <p:cNvPr id="12" name="">
             <a:extLst xmlns:a="http://schemas.openxmlformats.org/drawingml/2006/main">
               <a:ext uri="{FF2B5EF4-FFF2-40B4-BE49-F238E27FC236}">
-                <a16:creationId xmlns:a16="http://schemas.microsoft.com/office/drawing/2014/main" id="{B3F3FA00-BE85-43F8-BAEE-337C98E310B2}"/>
+                <a16:creationId xmlns:a16="http://schemas.microsoft.com/office/drawing/2014/main" id="{245F94FF-2D8D-4178-BD8E-DAD3EF9521CB}"/>
               </a:ext>
             </a:extLst>
           </p:cNvPr>
@@ -8077,7 +8153,7 @@
           <p:cNvPr id="13" name="">
             <a:extLst xmlns:a="http://schemas.openxmlformats.org/drawingml/2006/main">
               <a:ext uri="{FF2B5EF4-FFF2-40B4-BE49-F238E27FC236}">
-                <a16:creationId xmlns:a16="http://schemas.microsoft.com/office/drawing/2014/main" id="{CA359373-E8E8-4093-81CB-2816CC844291}"/>
+                <a16:creationId xmlns:a16="http://schemas.microsoft.com/office/drawing/2014/main" id="{D9961007-DEB5-4D85-BB3D-30172DF12502}"/>
               </a:ext>
             </a:extLst>
           </p:cNvPr>
@@ -8108,7 +8184,7 @@
           <p:cNvPr id="14" name="">
             <a:extLst xmlns:a="http://schemas.openxmlformats.org/drawingml/2006/main">
               <a:ext uri="{FF2B5EF4-FFF2-40B4-BE49-F238E27FC236}">
-                <a16:creationId xmlns:a16="http://schemas.microsoft.com/office/drawing/2014/main" id="{BB6BDFEC-4487-405E-9DAA-CEAA08ACE45B}"/>
+                <a16:creationId xmlns:a16="http://schemas.microsoft.com/office/drawing/2014/main" id="{1A3E061F-A198-4B5C-8BAF-5B83B4924351}"/>
               </a:ext>
             </a:extLst>
           </p:cNvPr>
@@ -8166,7 +8242,7 @@
           <p:cNvPr id="15" name="">
             <a:extLst xmlns:a="http://schemas.openxmlformats.org/drawingml/2006/main">
               <a:ext uri="{FF2B5EF4-FFF2-40B4-BE49-F238E27FC236}">
-                <a16:creationId xmlns:a16="http://schemas.microsoft.com/office/drawing/2014/main" id="{21232FF0-D94C-436B-A423-9597A73815AC}"/>
+                <a16:creationId xmlns:a16="http://schemas.microsoft.com/office/drawing/2014/main" id="{EE554682-211D-4A98-A5EC-70E16E07C611}"/>
               </a:ext>
             </a:extLst>
           </p:cNvPr>
@@ -8197,7 +8273,7 @@
           <p:cNvPr id="16" name="">
             <a:extLst xmlns:a="http://schemas.openxmlformats.org/drawingml/2006/main">
               <a:ext uri="{FF2B5EF4-FFF2-40B4-BE49-F238E27FC236}">
-                <a16:creationId xmlns:a16="http://schemas.microsoft.com/office/drawing/2014/main" id="{ABB48C6D-5F9D-4BC5-A7F7-14A1A0148591}"/>
+                <a16:creationId xmlns:a16="http://schemas.microsoft.com/office/drawing/2014/main" id="{DC35C739-32BF-4363-8544-D5FF5415D552}"/>
               </a:ext>
             </a:extLst>
           </p:cNvPr>
@@ -8255,7 +8331,7 @@
           <p:cNvPr id="17" name="">
             <a:extLst xmlns:a="http://schemas.openxmlformats.org/drawingml/2006/main">
               <a:ext uri="{FF2B5EF4-FFF2-40B4-BE49-F238E27FC236}">
-                <a16:creationId xmlns:a16="http://schemas.microsoft.com/office/drawing/2014/main" id="{CA146333-F731-401D-AB48-D12A5FA6AFD4}"/>
+                <a16:creationId xmlns:a16="http://schemas.microsoft.com/office/drawing/2014/main" id="{0C2069FE-7A4E-4F16-B356-ED8EBB3BDDA6}"/>
               </a:ext>
             </a:extLst>
           </p:cNvPr>
@@ -8286,7 +8362,7 @@
           <p:cNvPr id="18" name="">
             <a:extLst xmlns:a="http://schemas.openxmlformats.org/drawingml/2006/main">
               <a:ext uri="{FF2B5EF4-FFF2-40B4-BE49-F238E27FC236}">
-                <a16:creationId xmlns:a16="http://schemas.microsoft.com/office/drawing/2014/main" id="{FEB9D8EB-9121-4982-A957-598B2D5A8CBE}"/>
+                <a16:creationId xmlns:a16="http://schemas.microsoft.com/office/drawing/2014/main" id="{B07395AA-B019-4AC7-B479-F7E12FD23636}"/>
               </a:ext>
             </a:extLst>
           </p:cNvPr>
@@ -8344,7 +8420,7 @@
           <p:cNvPr id="19" name="">
             <a:extLst xmlns:a="http://schemas.openxmlformats.org/drawingml/2006/main">
               <a:ext uri="{FF2B5EF4-FFF2-40B4-BE49-F238E27FC236}">
-                <a16:creationId xmlns:a16="http://schemas.microsoft.com/office/drawing/2014/main" id="{498367D4-CA62-40E6-A313-C546120E9EAA}"/>
+                <a16:creationId xmlns:a16="http://schemas.microsoft.com/office/drawing/2014/main" id="{2A521E0B-71B7-4338-A80F-9B3C2B0164D9}"/>
               </a:ext>
             </a:extLst>
           </p:cNvPr>
@@ -8375,7 +8451,7 @@
           <p:cNvPr id="20" name="">
             <a:extLst xmlns:a="http://schemas.openxmlformats.org/drawingml/2006/main">
               <a:ext uri="{FF2B5EF4-FFF2-40B4-BE49-F238E27FC236}">
-                <a16:creationId xmlns:a16="http://schemas.microsoft.com/office/drawing/2014/main" id="{774821E6-EB73-4745-8CF9-5FA9B667E99E}"/>
+                <a16:creationId xmlns:a16="http://schemas.microsoft.com/office/drawing/2014/main" id="{444EF6B7-A34D-48A1-807B-36A1F88E2C2D}"/>
               </a:ext>
             </a:extLst>
           </p:cNvPr>
@@ -8433,7 +8509,7 @@
           <p:cNvPr id="21" name="">
             <a:extLst xmlns:a="http://schemas.openxmlformats.org/drawingml/2006/main">
               <a:ext uri="{FF2B5EF4-FFF2-40B4-BE49-F238E27FC236}">
-                <a16:creationId xmlns:a16="http://schemas.microsoft.com/office/drawing/2014/main" id="{441BCDA6-BE27-4D02-98A7-CF42EE2D73A2}"/>
+                <a16:creationId xmlns:a16="http://schemas.microsoft.com/office/drawing/2014/main" id="{9481D719-054E-430E-92F5-09FAC1FA9E57}"/>
               </a:ext>
             </a:extLst>
           </p:cNvPr>
@@ -8464,7 +8540,7 @@
           <p:cNvPr id="22" name="">
             <a:extLst xmlns:a="http://schemas.openxmlformats.org/drawingml/2006/main">
               <a:ext uri="{FF2B5EF4-FFF2-40B4-BE49-F238E27FC236}">
-                <a16:creationId xmlns:a16="http://schemas.microsoft.com/office/drawing/2014/main" id="{6E9AB711-2CCB-4B46-8AB1-08A1579488A7}"/>
+                <a16:creationId xmlns:a16="http://schemas.microsoft.com/office/drawing/2014/main" id="{F3FBBC3B-9F97-48FD-B957-AAB5A82CEB01}"/>
               </a:ext>
             </a:extLst>
           </p:cNvPr>
@@ -8522,7 +8598,7 @@
           <p:cNvPr id="23" name="">
             <a:extLst xmlns:a="http://schemas.openxmlformats.org/drawingml/2006/main">
               <a:ext uri="{FF2B5EF4-FFF2-40B4-BE49-F238E27FC236}">
-                <a16:creationId xmlns:a16="http://schemas.microsoft.com/office/drawing/2014/main" id="{F51977EC-AFD7-4CAF-9552-8551D1211AE3}"/>
+                <a16:creationId xmlns:a16="http://schemas.microsoft.com/office/drawing/2014/main" id="{2E883ED6-227A-4DB4-AC3C-650562F40491}"/>
               </a:ext>
             </a:extLst>
           </p:cNvPr>
@@ -8553,7 +8629,7 @@
           <p:cNvPr id="24" name="">
             <a:extLst xmlns:a="http://schemas.openxmlformats.org/drawingml/2006/main">
               <a:ext uri="{FF2B5EF4-FFF2-40B4-BE49-F238E27FC236}">
-                <a16:creationId xmlns:a16="http://schemas.microsoft.com/office/drawing/2014/main" id="{E10AC1D9-0CAD-4A4A-8943-BBFFE43C83A3}"/>
+                <a16:creationId xmlns:a16="http://schemas.microsoft.com/office/drawing/2014/main" id="{87DE01C3-66C3-4818-BC8F-2893FBA409A0}"/>
               </a:ext>
             </a:extLst>
           </p:cNvPr>
@@ -8611,7 +8687,7 @@
           <p:cNvPr id="25" name="">
             <a:extLst xmlns:a="http://schemas.openxmlformats.org/drawingml/2006/main">
               <a:ext uri="{FF2B5EF4-FFF2-40B4-BE49-F238E27FC236}">
-                <a16:creationId xmlns:a16="http://schemas.microsoft.com/office/drawing/2014/main" id="{124B722B-F26B-43EE-882A-3228152A51BF}"/>
+                <a16:creationId xmlns:a16="http://schemas.microsoft.com/office/drawing/2014/main" id="{1D7DBFFD-61A4-4329-92C9-FF7C9708516C}"/>
               </a:ext>
             </a:extLst>
           </p:cNvPr>
@@ -8642,7 +8718,7 @@
           <p:cNvPr id="26" name="">
             <a:extLst xmlns:a="http://schemas.openxmlformats.org/drawingml/2006/main">
               <a:ext uri="{FF2B5EF4-FFF2-40B4-BE49-F238E27FC236}">
-                <a16:creationId xmlns:a16="http://schemas.microsoft.com/office/drawing/2014/main" id="{C8A6D297-CE07-4BF7-B199-FE8F9CC18EBA}"/>
+                <a16:creationId xmlns:a16="http://schemas.microsoft.com/office/drawing/2014/main" id="{F07D7055-7981-4C63-94C0-99273D570416}"/>
               </a:ext>
             </a:extLst>
           </p:cNvPr>
@@ -8700,7 +8776,7 @@
           <p:cNvPr id="27" name="">
             <a:extLst xmlns:a="http://schemas.openxmlformats.org/drawingml/2006/main">
               <a:ext uri="{FF2B5EF4-FFF2-40B4-BE49-F238E27FC236}">
-                <a16:creationId xmlns:a16="http://schemas.microsoft.com/office/drawing/2014/main" id="{680D339B-FFAF-4B2E-9F7B-32D6E0FE4344}"/>
+                <a16:creationId xmlns:a16="http://schemas.microsoft.com/office/drawing/2014/main" id="{1327A7FD-84CF-42AD-98E9-758EB6E85032}"/>
               </a:ext>
             </a:extLst>
           </p:cNvPr>
@@ -8731,7 +8807,7 @@
           <p:cNvPr id="28" name="">
             <a:extLst xmlns:a="http://schemas.openxmlformats.org/drawingml/2006/main">
               <a:ext uri="{FF2B5EF4-FFF2-40B4-BE49-F238E27FC236}">
-                <a16:creationId xmlns:a16="http://schemas.microsoft.com/office/drawing/2014/main" id="{1C74A598-063C-4D01-BCDA-B5C3733E95AE}"/>
+                <a16:creationId xmlns:a16="http://schemas.microsoft.com/office/drawing/2014/main" id="{7EF0EF13-824B-4E2D-B48B-E717CE6B6603}"/>
               </a:ext>
             </a:extLst>
           </p:cNvPr>
@@ -8787,7 +8863,7 @@
     </p:spTree>
     <p:extLst>
       <p:ext uri="{BB962C8B-B14F-4D97-AF65-F5344CB8AC3E}">
-        <p14:creationId xmlns:p14="http://schemas.microsoft.com/office/powerpoint/2010/main" val="1238003293"/>
+        <p14:creationId xmlns:p14="http://schemas.microsoft.com/office/powerpoint/2010/main" val="1078484317"/>
       </p:ext>
     </p:extLst>
   </p:cSld>
@@ -8818,7 +8894,7 @@
           <p:cNvPr id="23" name="">
             <a:extLst xmlns:a="http://schemas.openxmlformats.org/drawingml/2006/main">
               <a:ext uri="{FF2B5EF4-FFF2-40B4-BE49-F238E27FC236}">
-                <a16:creationId xmlns:a16="http://schemas.microsoft.com/office/drawing/2014/main" id="{2D6D315E-78C5-4FE3-A7C7-D98A4A14EED3}"/>
+                <a16:creationId xmlns:a16="http://schemas.microsoft.com/office/drawing/2014/main" id="{8A3603D9-BEAC-407D-B23B-F7372071F008}"/>
               </a:ext>
             </a:extLst>
           </p:cNvPr>
@@ -8849,7 +8925,7 @@
           <p:cNvPr id="2" name="">
             <a:extLst xmlns:a="http://schemas.openxmlformats.org/drawingml/2006/main">
               <a:ext uri="{FF2B5EF4-FFF2-40B4-BE49-F238E27FC236}">
-                <a16:creationId xmlns:a16="http://schemas.microsoft.com/office/drawing/2014/main" id="{D83B3770-AFCC-4063-AB06-D58420A40F1C}"/>
+                <a16:creationId xmlns:a16="http://schemas.microsoft.com/office/drawing/2014/main" id="{FC6EFA45-BFF6-433C-B127-F4A235AED9A5}"/>
               </a:ext>
             </a:extLst>
           </p:cNvPr>
@@ -8879,7 +8955,7 @@
           <a:lstStyle xmlns:a="http://schemas.openxmlformats.org/drawingml/2006/main"/>
           <a:p xmlns:a="http://schemas.openxmlformats.org/drawingml/2006/main">
             <a:pPr algn="l">
-              <a:defRPr sz="2475" b="1" i="0">
+              <a:defRPr sz="3225" b="1" i="0">
                 <a:solidFill>
                   <a:srgbClr val="102A43"/>
                 </a:solidFill>
@@ -8889,7 +8965,7 @@
               </a:defRPr>
             </a:pPr>
             <a:r>
-              <a:rPr sz="2475" b="1" i="0">
+              <a:rPr sz="3225" b="1" i="0">
                 <a:solidFill>
                   <a:srgbClr val="102A43"/>
                 </a:solidFill>
@@ -8897,7 +8973,7 @@
                 <a:ea typeface="Nimbus Sans"/>
                 <a:cs typeface="Nimbus Sans"/>
               </a:rPr>
-              <a:t>The main risks are clinical, operational, and equity related</a:t>
+              <a:t>Clinical, workload and fairness risks</a:t>
             </a:r>
           </a:p>
         </p:txBody>
@@ -8907,7 +8983,7 @@
           <p:cNvPr id="3" name="">
             <a:extLst xmlns:a="http://schemas.openxmlformats.org/drawingml/2006/main">
               <a:ext uri="{FF2B5EF4-FFF2-40B4-BE49-F238E27FC236}">
-                <a16:creationId xmlns:a16="http://schemas.microsoft.com/office/drawing/2014/main" id="{3959914F-8D1D-4CD6-87C4-045B29ABFAE8}"/>
+                <a16:creationId xmlns:a16="http://schemas.microsoft.com/office/drawing/2014/main" id="{89F7E915-7F3A-4DC8-8DF6-502CA18F9C8C}"/>
               </a:ext>
             </a:extLst>
           </p:cNvPr>
@@ -8965,7 +9041,7 @@
           <p:cNvPr id="4" name="">
             <a:extLst xmlns:a="http://schemas.openxmlformats.org/drawingml/2006/main">
               <a:ext uri="{FF2B5EF4-FFF2-40B4-BE49-F238E27FC236}">
-                <a16:creationId xmlns:a16="http://schemas.microsoft.com/office/drawing/2014/main" id="{126F768D-9621-4A6D-9435-F4C1F6DC8FF5}"/>
+                <a16:creationId xmlns:a16="http://schemas.microsoft.com/office/drawing/2014/main" id="{B5EDE20D-DE8C-4D7D-A969-3D4778F3A2D8}"/>
               </a:ext>
             </a:extLst>
           </p:cNvPr>
@@ -9023,7 +9099,7 @@
           <p:cNvPr id="5" name="">
             <a:extLst xmlns:a="http://schemas.openxmlformats.org/drawingml/2006/main">
               <a:ext uri="{FF2B5EF4-FFF2-40B4-BE49-F238E27FC236}">
-                <a16:creationId xmlns:a16="http://schemas.microsoft.com/office/drawing/2014/main" id="{0F6299E6-7A8D-4762-A1FB-A338C9E7F32A}"/>
+                <a16:creationId xmlns:a16="http://schemas.microsoft.com/office/drawing/2014/main" id="{40F89DAB-349F-40C9-9C4F-B4260FF2AB0D}"/>
               </a:ext>
             </a:extLst>
           </p:cNvPr>
@@ -9054,7 +9130,7 @@
           <p:cNvPr id="6" name="">
             <a:extLst xmlns:a="http://schemas.openxmlformats.org/drawingml/2006/main">
               <a:ext uri="{FF2B5EF4-FFF2-40B4-BE49-F238E27FC236}">
-                <a16:creationId xmlns:a16="http://schemas.microsoft.com/office/drawing/2014/main" id="{8BFBE4EE-CF31-48E4-BC3E-EFA867B00882}"/>
+                <a16:creationId xmlns:a16="http://schemas.microsoft.com/office/drawing/2014/main" id="{70BD27CA-6C5A-49D4-BE6D-081F4D5957B3}"/>
               </a:ext>
             </a:extLst>
           </p:cNvPr>
@@ -9112,7 +9188,7 @@
           <p:cNvPr id="7" name="">
             <a:extLst xmlns:a="http://schemas.openxmlformats.org/drawingml/2006/main">
               <a:ext uri="{FF2B5EF4-FFF2-40B4-BE49-F238E27FC236}">
-                <a16:creationId xmlns:a16="http://schemas.microsoft.com/office/drawing/2014/main" id="{CD7EE5DA-6D34-4873-9C66-9C7ACED266F4}"/>
+                <a16:creationId xmlns:a16="http://schemas.microsoft.com/office/drawing/2014/main" id="{F52497E6-035C-4788-B044-A130066D26FD}"/>
               </a:ext>
             </a:extLst>
           </p:cNvPr>
@@ -9170,7 +9246,7 @@
           <p:cNvPr id="8" name="">
             <a:extLst xmlns:a="http://schemas.openxmlformats.org/drawingml/2006/main">
               <a:ext uri="{FF2B5EF4-FFF2-40B4-BE49-F238E27FC236}">
-                <a16:creationId xmlns:a16="http://schemas.microsoft.com/office/drawing/2014/main" id="{0A736ADA-A043-46A4-9B1C-913B77C2BED5}"/>
+                <a16:creationId xmlns:a16="http://schemas.microsoft.com/office/drawing/2014/main" id="{6DC22059-879F-4556-9B28-7103588E8E2B}"/>
               </a:ext>
             </a:extLst>
           </p:cNvPr>
@@ -9201,7 +9277,7 @@
           <p:cNvPr id="9" name="">
             <a:extLst xmlns:a="http://schemas.openxmlformats.org/drawingml/2006/main">
               <a:ext uri="{FF2B5EF4-FFF2-40B4-BE49-F238E27FC236}">
-                <a16:creationId xmlns:a16="http://schemas.microsoft.com/office/drawing/2014/main" id="{95D067EA-B4B8-4975-9BF5-F9FA196B0624}"/>
+                <a16:creationId xmlns:a16="http://schemas.microsoft.com/office/drawing/2014/main" id="{1C7771EE-E760-4851-AEDE-2FD2F19877FD}"/>
               </a:ext>
             </a:extLst>
           </p:cNvPr>
@@ -9259,7 +9335,7 @@
           <p:cNvPr id="10" name="">
             <a:extLst xmlns:a="http://schemas.openxmlformats.org/drawingml/2006/main">
               <a:ext uri="{FF2B5EF4-FFF2-40B4-BE49-F238E27FC236}">
-                <a16:creationId xmlns:a16="http://schemas.microsoft.com/office/drawing/2014/main" id="{7F393BD1-D212-4CA8-A97E-BA7AB612D462}"/>
+                <a16:creationId xmlns:a16="http://schemas.microsoft.com/office/drawing/2014/main" id="{B0B4DB67-BC23-4904-8FE9-19BE3DDF1D31}"/>
               </a:ext>
             </a:extLst>
           </p:cNvPr>
@@ -9317,7 +9393,7 @@
           <p:cNvPr id="11" name="">
             <a:extLst xmlns:a="http://schemas.openxmlformats.org/drawingml/2006/main">
               <a:ext uri="{FF2B5EF4-FFF2-40B4-BE49-F238E27FC236}">
-                <a16:creationId xmlns:a16="http://schemas.microsoft.com/office/drawing/2014/main" id="{FAFE8398-24C9-42AF-A342-5A9ADBE78C67}"/>
+                <a16:creationId xmlns:a16="http://schemas.microsoft.com/office/drawing/2014/main" id="{FBEA6DBC-83BA-4F44-B1B8-DE40A1E85C2F}"/>
               </a:ext>
             </a:extLst>
           </p:cNvPr>
@@ -9348,7 +9424,7 @@
           <p:cNvPr id="12" name="">
             <a:extLst xmlns:a="http://schemas.openxmlformats.org/drawingml/2006/main">
               <a:ext uri="{FF2B5EF4-FFF2-40B4-BE49-F238E27FC236}">
-                <a16:creationId xmlns:a16="http://schemas.microsoft.com/office/drawing/2014/main" id="{032B103C-2922-4728-861C-572347A53BE1}"/>
+                <a16:creationId xmlns:a16="http://schemas.microsoft.com/office/drawing/2014/main" id="{F1B48868-B298-4DA8-B4DF-2FB380FF195C}"/>
               </a:ext>
             </a:extLst>
           </p:cNvPr>
@@ -9406,7 +9482,7 @@
           <p:cNvPr id="13" name="">
             <a:extLst xmlns:a="http://schemas.openxmlformats.org/drawingml/2006/main">
               <a:ext uri="{FF2B5EF4-FFF2-40B4-BE49-F238E27FC236}">
-                <a16:creationId xmlns:a16="http://schemas.microsoft.com/office/drawing/2014/main" id="{1CDC2E79-3A24-47DB-846B-28FCC8C7858E}"/>
+                <a16:creationId xmlns:a16="http://schemas.microsoft.com/office/drawing/2014/main" id="{ACDA03C7-1C40-4656-AE22-20213A961634}"/>
               </a:ext>
             </a:extLst>
           </p:cNvPr>
@@ -9464,7 +9540,7 @@
           <p:cNvPr id="14" name="">
             <a:extLst xmlns:a="http://schemas.openxmlformats.org/drawingml/2006/main">
               <a:ext uri="{FF2B5EF4-FFF2-40B4-BE49-F238E27FC236}">
-                <a16:creationId xmlns:a16="http://schemas.microsoft.com/office/drawing/2014/main" id="{4CB63D34-B196-47A3-8CA6-90959849E128}"/>
+                <a16:creationId xmlns:a16="http://schemas.microsoft.com/office/drawing/2014/main" id="{5B8EE61D-1B2B-4882-B8D6-F28B5BA7DC7C}"/>
               </a:ext>
             </a:extLst>
           </p:cNvPr>
@@ -9495,7 +9571,7 @@
           <p:cNvPr id="15" name="">
             <a:extLst xmlns:a="http://schemas.openxmlformats.org/drawingml/2006/main">
               <a:ext uri="{FF2B5EF4-FFF2-40B4-BE49-F238E27FC236}">
-                <a16:creationId xmlns:a16="http://schemas.microsoft.com/office/drawing/2014/main" id="{9EA55E7B-5F89-4AA8-BBDA-760CFBB6087F}"/>
+                <a16:creationId xmlns:a16="http://schemas.microsoft.com/office/drawing/2014/main" id="{33873AC3-3DE1-4114-B5BC-E4119F1C3939}"/>
               </a:ext>
             </a:extLst>
           </p:cNvPr>
@@ -9553,7 +9629,7 @@
           <p:cNvPr id="16" name="">
             <a:extLst xmlns:a="http://schemas.openxmlformats.org/drawingml/2006/main">
               <a:ext uri="{FF2B5EF4-FFF2-40B4-BE49-F238E27FC236}">
-                <a16:creationId xmlns:a16="http://schemas.microsoft.com/office/drawing/2014/main" id="{D735C238-71C2-479A-B72A-76E1DF5189F2}"/>
+                <a16:creationId xmlns:a16="http://schemas.microsoft.com/office/drawing/2014/main" id="{9AAD739E-C057-46DD-95AA-AE8A72A2976A}"/>
               </a:ext>
             </a:extLst>
           </p:cNvPr>
@@ -9615,7 +9691,7 @@
           <p:nvPr/>
         </p:nvPicPr>
         <p:blipFill>
-          <a:blip xmlns:r="http://schemas.openxmlformats.org/officeDocument/2006/relationships" xmlns:a="http://schemas.openxmlformats.org/drawingml/2006/main" r:embed="R6de58cb279214e03"/>
+          <a:blip xmlns:r="http://schemas.openxmlformats.org/officeDocument/2006/relationships" xmlns:a="http://schemas.openxmlformats.org/drawingml/2006/main" r:embed="R6663d801802144d3"/>
           <a:stretch xmlns:a="http://schemas.openxmlformats.org/drawingml/2006/main"/>
         </p:blipFill>
         <p:spPr>
@@ -9633,7 +9709,7 @@
           <p:cNvPr id="18" name="">
             <a:extLst xmlns:a="http://schemas.openxmlformats.org/drawingml/2006/main">
               <a:ext uri="{FF2B5EF4-FFF2-40B4-BE49-F238E27FC236}">
-                <a16:creationId xmlns:a16="http://schemas.microsoft.com/office/drawing/2014/main" id="{35D66CED-F5D4-4A5B-94EE-FAB4DCE32845}"/>
+                <a16:creationId xmlns:a16="http://schemas.microsoft.com/office/drawing/2014/main" id="{1648EA8C-2770-4E86-9223-A9C49909E53A}"/>
               </a:ext>
             </a:extLst>
           </p:cNvPr>
@@ -9666,7 +9742,7 @@
           <p:cNvPr id="19" name="">
             <a:extLst xmlns:a="http://schemas.openxmlformats.org/drawingml/2006/main">
               <a:ext uri="{FF2B5EF4-FFF2-40B4-BE49-F238E27FC236}">
-                <a16:creationId xmlns:a16="http://schemas.microsoft.com/office/drawing/2014/main" id="{161F2F1F-BA86-45B0-B38D-B3AD42CCF50F}"/>
+                <a16:creationId xmlns:a16="http://schemas.microsoft.com/office/drawing/2014/main" id="{53E0B958-B072-4302-ABFA-65BD87FF2A35}"/>
               </a:ext>
             </a:extLst>
           </p:cNvPr>
@@ -9724,7 +9800,7 @@
           <p:cNvPr id="20" name="">
             <a:extLst xmlns:a="http://schemas.openxmlformats.org/drawingml/2006/main">
               <a:ext uri="{FF2B5EF4-FFF2-40B4-BE49-F238E27FC236}">
-                <a16:creationId xmlns:a16="http://schemas.microsoft.com/office/drawing/2014/main" id="{16F27438-A1A9-43BC-A740-86B40E114972}"/>
+                <a16:creationId xmlns:a16="http://schemas.microsoft.com/office/drawing/2014/main" id="{6C2E54E9-49A2-480B-A175-17E7DA7E5431}"/>
               </a:ext>
             </a:extLst>
           </p:cNvPr>
@@ -9782,7 +9858,7 @@
           <p:cNvPr id="21" name="">
             <a:extLst xmlns:a="http://schemas.openxmlformats.org/drawingml/2006/main">
               <a:ext uri="{FF2B5EF4-FFF2-40B4-BE49-F238E27FC236}">
-                <a16:creationId xmlns:a16="http://schemas.microsoft.com/office/drawing/2014/main" id="{B3351C57-D430-4E9E-82B0-C6EAA3C045BF}"/>
+                <a16:creationId xmlns:a16="http://schemas.microsoft.com/office/drawing/2014/main" id="{05BC8004-2392-422E-95F1-A0D49EE0C0EE}"/>
               </a:ext>
             </a:extLst>
           </p:cNvPr>
@@ -9813,7 +9889,7 @@
           <p:cNvPr id="22" name="">
             <a:extLst xmlns:a="http://schemas.openxmlformats.org/drawingml/2006/main">
               <a:ext uri="{FF2B5EF4-FFF2-40B4-BE49-F238E27FC236}">
-                <a16:creationId xmlns:a16="http://schemas.microsoft.com/office/drawing/2014/main" id="{C9B261A2-1B20-4290-9D10-25126B7EDE20}"/>
+                <a16:creationId xmlns:a16="http://schemas.microsoft.com/office/drawing/2014/main" id="{A6D1A136-A12B-474C-B918-6D057126D850}"/>
               </a:ext>
             </a:extLst>
           </p:cNvPr>
@@ -9869,7 +9945,7 @@
     </p:spTree>
     <p:extLst>
       <p:ext uri="{BB962C8B-B14F-4D97-AF65-F5344CB8AC3E}">
-        <p14:creationId xmlns:p14="http://schemas.microsoft.com/office/powerpoint/2010/main" val="1239906981"/>
+        <p14:creationId xmlns:p14="http://schemas.microsoft.com/office/powerpoint/2010/main" val="195772669"/>
       </p:ext>
     </p:extLst>
   </p:cSld>
@@ -9900,7 +9976,7 @@
           <p:cNvPr id="35" name="">
             <a:extLst xmlns:a="http://schemas.openxmlformats.org/drawingml/2006/main">
               <a:ext uri="{FF2B5EF4-FFF2-40B4-BE49-F238E27FC236}">
-                <a16:creationId xmlns:a16="http://schemas.microsoft.com/office/drawing/2014/main" id="{D895FBE0-A1AB-4496-AEB6-E63848E19DB5}"/>
+                <a16:creationId xmlns:a16="http://schemas.microsoft.com/office/drawing/2014/main" id="{2A4FE0B6-5B34-4F21-98BF-106C4D7E569F}"/>
               </a:ext>
             </a:extLst>
           </p:cNvPr>
@@ -9931,7 +10007,7 @@
           <p:cNvPr id="2" name="">
             <a:extLst xmlns:a="http://schemas.openxmlformats.org/drawingml/2006/main">
               <a:ext uri="{FF2B5EF4-FFF2-40B4-BE49-F238E27FC236}">
-                <a16:creationId xmlns:a16="http://schemas.microsoft.com/office/drawing/2014/main" id="{758CC68B-F807-43E1-A6F8-A0D4B083E6FE}"/>
+                <a16:creationId xmlns:a16="http://schemas.microsoft.com/office/drawing/2014/main" id="{33C055AB-4154-42EE-8DD8-0EC4989AF482}"/>
               </a:ext>
             </a:extLst>
           </p:cNvPr>
@@ -9989,7 +10065,7 @@
           <p:cNvPr id="3" name="">
             <a:extLst xmlns:a="http://schemas.openxmlformats.org/drawingml/2006/main">
               <a:ext uri="{FF2B5EF4-FFF2-40B4-BE49-F238E27FC236}">
-                <a16:creationId xmlns:a16="http://schemas.microsoft.com/office/drawing/2014/main" id="{E8B9B891-8266-4CFB-8C50-7C2A1C5FAE19}"/>
+                <a16:creationId xmlns:a16="http://schemas.microsoft.com/office/drawing/2014/main" id="{8C7192DC-2CBF-4D03-9E06-3A64E6B3E5AB}"/>
               </a:ext>
             </a:extLst>
           </p:cNvPr>
@@ -10047,7 +10123,7 @@
           <p:cNvPr id="4" name="">
             <a:extLst xmlns:a="http://schemas.openxmlformats.org/drawingml/2006/main">
               <a:ext uri="{FF2B5EF4-FFF2-40B4-BE49-F238E27FC236}">
-                <a16:creationId xmlns:a16="http://schemas.microsoft.com/office/drawing/2014/main" id="{31892CCC-73E8-4598-B739-CA78914A53BC}"/>
+                <a16:creationId xmlns:a16="http://schemas.microsoft.com/office/drawing/2014/main" id="{CA3B5700-440C-44D9-B249-127B057F114D}"/>
               </a:ext>
             </a:extLst>
           </p:cNvPr>
@@ -10105,7 +10181,7 @@
           <p:cNvPr id="5" name="">
             <a:extLst xmlns:a="http://schemas.openxmlformats.org/drawingml/2006/main">
               <a:ext uri="{FF2B5EF4-FFF2-40B4-BE49-F238E27FC236}">
-                <a16:creationId xmlns:a16="http://schemas.microsoft.com/office/drawing/2014/main" id="{F86EC87E-5DFB-4EBB-A94F-2D16F1262D3E}"/>
+                <a16:creationId xmlns:a16="http://schemas.microsoft.com/office/drawing/2014/main" id="{4D5F3EE8-171F-4157-9A93-77B1BB205621}"/>
               </a:ext>
             </a:extLst>
           </p:cNvPr>
@@ -10163,7 +10239,7 @@
           <p:cNvPr id="6" name="">
             <a:extLst xmlns:a="http://schemas.openxmlformats.org/drawingml/2006/main">
               <a:ext uri="{FF2B5EF4-FFF2-40B4-BE49-F238E27FC236}">
-                <a16:creationId xmlns:a16="http://schemas.microsoft.com/office/drawing/2014/main" id="{9A9A9AE6-6AE8-441F-A808-28B37D2357CF}"/>
+                <a16:creationId xmlns:a16="http://schemas.microsoft.com/office/drawing/2014/main" id="{5209AFE8-A359-44EC-93BC-C101F83D4A50}"/>
               </a:ext>
             </a:extLst>
           </p:cNvPr>
@@ -10221,7 +10297,7 @@
           <p:cNvPr id="7" name="">
             <a:extLst xmlns:a="http://schemas.openxmlformats.org/drawingml/2006/main">
               <a:ext uri="{FF2B5EF4-FFF2-40B4-BE49-F238E27FC236}">
-                <a16:creationId xmlns:a16="http://schemas.microsoft.com/office/drawing/2014/main" id="{BA7D1CB5-84F5-4CD2-A3E3-04A265B3A4FC}"/>
+                <a16:creationId xmlns:a16="http://schemas.microsoft.com/office/drawing/2014/main" id="{5635CB5B-9938-4FD3-86D9-EA6D838F0809}"/>
               </a:ext>
             </a:extLst>
           </p:cNvPr>
@@ -10252,7 +10328,7 @@
           <p:cNvPr id="8" name="">
             <a:extLst xmlns:a="http://schemas.openxmlformats.org/drawingml/2006/main">
               <a:ext uri="{FF2B5EF4-FFF2-40B4-BE49-F238E27FC236}">
-                <a16:creationId xmlns:a16="http://schemas.microsoft.com/office/drawing/2014/main" id="{580A9C67-1DBF-4FB9-B171-36D16BDC7C18}"/>
+                <a16:creationId xmlns:a16="http://schemas.microsoft.com/office/drawing/2014/main" id="{4917A908-D049-4C69-B701-08DF94CED107}"/>
               </a:ext>
             </a:extLst>
           </p:cNvPr>
@@ -10312,7 +10388,7 @@
           <p:cNvPr id="9" name="">
             <a:extLst xmlns:a="http://schemas.openxmlformats.org/drawingml/2006/main">
               <a:ext uri="{FF2B5EF4-FFF2-40B4-BE49-F238E27FC236}">
-                <a16:creationId xmlns:a16="http://schemas.microsoft.com/office/drawing/2014/main" id="{EC306C18-AF64-4FD1-B7AA-A06B9A599C06}"/>
+                <a16:creationId xmlns:a16="http://schemas.microsoft.com/office/drawing/2014/main" id="{0008268A-B394-4E5F-8B34-FB1E9678BA50}"/>
               </a:ext>
             </a:extLst>
           </p:cNvPr>
@@ -10370,7 +10446,7 @@
           <p:cNvPr id="10" name="">
             <a:extLst xmlns:a="http://schemas.openxmlformats.org/drawingml/2006/main">
               <a:ext uri="{FF2B5EF4-FFF2-40B4-BE49-F238E27FC236}">
-                <a16:creationId xmlns:a16="http://schemas.microsoft.com/office/drawing/2014/main" id="{989C3055-36DB-4E40-AFF2-422E5BAE8AF7}"/>
+                <a16:creationId xmlns:a16="http://schemas.microsoft.com/office/drawing/2014/main" id="{41966999-B939-4933-92D3-085ABA7608BD}"/>
               </a:ext>
             </a:extLst>
           </p:cNvPr>
@@ -10428,7 +10504,7 @@
           <p:cNvPr id="11" name="">
             <a:extLst xmlns:a="http://schemas.openxmlformats.org/drawingml/2006/main">
               <a:ext uri="{FF2B5EF4-FFF2-40B4-BE49-F238E27FC236}">
-                <a16:creationId xmlns:a16="http://schemas.microsoft.com/office/drawing/2014/main" id="{FF3029C2-D13A-4837-B663-5C77DF01E485}"/>
+                <a16:creationId xmlns:a16="http://schemas.microsoft.com/office/drawing/2014/main" id="{C045BED7-547F-4269-B38F-6B198B492BC8}"/>
               </a:ext>
             </a:extLst>
           </p:cNvPr>
@@ -10486,7 +10562,7 @@
           <p:cNvPr id="12" name="">
             <a:extLst xmlns:a="http://schemas.openxmlformats.org/drawingml/2006/main">
               <a:ext uri="{FF2B5EF4-FFF2-40B4-BE49-F238E27FC236}">
-                <a16:creationId xmlns:a16="http://schemas.microsoft.com/office/drawing/2014/main" id="{A69E5B9A-355E-4F7D-AB3F-EEDA4B3B62AC}"/>
+                <a16:creationId xmlns:a16="http://schemas.microsoft.com/office/drawing/2014/main" id="{3F61E5A8-850F-43B9-B1BC-C31D7B787F24}"/>
               </a:ext>
             </a:extLst>
           </p:cNvPr>
@@ -10517,7 +10593,7 @@
           <p:cNvPr id="13" name="">
             <a:extLst xmlns:a="http://schemas.openxmlformats.org/drawingml/2006/main">
               <a:ext uri="{FF2B5EF4-FFF2-40B4-BE49-F238E27FC236}">
-                <a16:creationId xmlns:a16="http://schemas.microsoft.com/office/drawing/2014/main" id="{871793FD-FD1C-40CA-B276-00656551611A}"/>
+                <a16:creationId xmlns:a16="http://schemas.microsoft.com/office/drawing/2014/main" id="{E0B8FED3-6540-421D-BC72-D5449123ED83}"/>
               </a:ext>
             </a:extLst>
           </p:cNvPr>
@@ -10577,7 +10653,7 @@
           <p:cNvPr id="14" name="">
             <a:extLst xmlns:a="http://schemas.openxmlformats.org/drawingml/2006/main">
               <a:ext uri="{FF2B5EF4-FFF2-40B4-BE49-F238E27FC236}">
-                <a16:creationId xmlns:a16="http://schemas.microsoft.com/office/drawing/2014/main" id="{B6880115-EF71-4459-9617-7922D94661A3}"/>
+                <a16:creationId xmlns:a16="http://schemas.microsoft.com/office/drawing/2014/main" id="{B8CA4367-BC39-48FF-8135-904C4EB03862}"/>
               </a:ext>
             </a:extLst>
           </p:cNvPr>
@@ -10635,7 +10711,7 @@
           <p:cNvPr id="15" name="">
             <a:extLst xmlns:a="http://schemas.openxmlformats.org/drawingml/2006/main">
               <a:ext uri="{FF2B5EF4-FFF2-40B4-BE49-F238E27FC236}">
-                <a16:creationId xmlns:a16="http://schemas.microsoft.com/office/drawing/2014/main" id="{AB7964CD-1240-4CD7-B9F9-BD54CFBD8370}"/>
+                <a16:creationId xmlns:a16="http://schemas.microsoft.com/office/drawing/2014/main" id="{8183C210-0193-4211-8063-1F49F1D14888}"/>
               </a:ext>
             </a:extLst>
           </p:cNvPr>
@@ -10693,7 +10769,7 @@
           <p:cNvPr id="16" name="">
             <a:extLst xmlns:a="http://schemas.openxmlformats.org/drawingml/2006/main">
               <a:ext uri="{FF2B5EF4-FFF2-40B4-BE49-F238E27FC236}">
-                <a16:creationId xmlns:a16="http://schemas.microsoft.com/office/drawing/2014/main" id="{EDC70E8F-628A-488B-B52A-309697D21807}"/>
+                <a16:creationId xmlns:a16="http://schemas.microsoft.com/office/drawing/2014/main" id="{77CC7975-0E17-4615-96DB-1D6E9D9046FE}"/>
               </a:ext>
             </a:extLst>
           </p:cNvPr>
@@ -10751,7 +10827,7 @@
           <p:cNvPr id="17" name="">
             <a:extLst xmlns:a="http://schemas.openxmlformats.org/drawingml/2006/main">
               <a:ext uri="{FF2B5EF4-FFF2-40B4-BE49-F238E27FC236}">
-                <a16:creationId xmlns:a16="http://schemas.microsoft.com/office/drawing/2014/main" id="{05FCD3D4-D9CD-4B2A-AA7C-56B74FB17F82}"/>
+                <a16:creationId xmlns:a16="http://schemas.microsoft.com/office/drawing/2014/main" id="{685AD252-E2D2-4754-A902-B9A319F1B7B5}"/>
               </a:ext>
             </a:extLst>
           </p:cNvPr>
@@ -10782,7 +10858,7 @@
           <p:cNvPr id="18" name="">
             <a:extLst xmlns:a="http://schemas.openxmlformats.org/drawingml/2006/main">
               <a:ext uri="{FF2B5EF4-FFF2-40B4-BE49-F238E27FC236}">
-                <a16:creationId xmlns:a16="http://schemas.microsoft.com/office/drawing/2014/main" id="{0605DD50-9C92-4DDE-87F7-2FA922F05066}"/>
+                <a16:creationId xmlns:a16="http://schemas.microsoft.com/office/drawing/2014/main" id="{4EC7F442-C7E7-479F-8F5F-23613128215C}"/>
               </a:ext>
             </a:extLst>
           </p:cNvPr>
@@ -10842,7 +10918,7 @@
           <p:cNvPr id="19" name="">
             <a:extLst xmlns:a="http://schemas.openxmlformats.org/drawingml/2006/main">
               <a:ext uri="{FF2B5EF4-FFF2-40B4-BE49-F238E27FC236}">
-                <a16:creationId xmlns:a16="http://schemas.microsoft.com/office/drawing/2014/main" id="{3042EE59-103C-41E5-A4C5-FD70C78514AA}"/>
+                <a16:creationId xmlns:a16="http://schemas.microsoft.com/office/drawing/2014/main" id="{08EB3F6D-77F0-47BF-969F-0B3D8006B086}"/>
               </a:ext>
             </a:extLst>
           </p:cNvPr>
@@ -10900,7 +10976,7 @@
           <p:cNvPr id="20" name="">
             <a:extLst xmlns:a="http://schemas.openxmlformats.org/drawingml/2006/main">
               <a:ext uri="{FF2B5EF4-FFF2-40B4-BE49-F238E27FC236}">
-                <a16:creationId xmlns:a16="http://schemas.microsoft.com/office/drawing/2014/main" id="{ABCD63A0-48B6-49C6-B18F-CF426E1B3FF0}"/>
+                <a16:creationId xmlns:a16="http://schemas.microsoft.com/office/drawing/2014/main" id="{78CB4152-AB4A-4CDA-B373-57DC2F2A18F6}"/>
               </a:ext>
             </a:extLst>
           </p:cNvPr>
@@ -10958,7 +11034,7 @@
           <p:cNvPr id="21" name="">
             <a:extLst xmlns:a="http://schemas.openxmlformats.org/drawingml/2006/main">
               <a:ext uri="{FF2B5EF4-FFF2-40B4-BE49-F238E27FC236}">
-                <a16:creationId xmlns:a16="http://schemas.microsoft.com/office/drawing/2014/main" id="{073AACC1-C042-484D-AE02-74A1435D9BF8}"/>
+                <a16:creationId xmlns:a16="http://schemas.microsoft.com/office/drawing/2014/main" id="{1162B53D-1FB7-4D14-A9D1-471903F8BCCA}"/>
               </a:ext>
             </a:extLst>
           </p:cNvPr>
@@ -11016,7 +11092,7 @@
           <p:cNvPr id="22" name="">
             <a:extLst xmlns:a="http://schemas.openxmlformats.org/drawingml/2006/main">
               <a:ext uri="{FF2B5EF4-FFF2-40B4-BE49-F238E27FC236}">
-                <a16:creationId xmlns:a16="http://schemas.microsoft.com/office/drawing/2014/main" id="{1FBBFDC0-3702-4E80-8A53-B55D7C3E6DC5}"/>
+                <a16:creationId xmlns:a16="http://schemas.microsoft.com/office/drawing/2014/main" id="{2F2C475E-CBE7-4B42-8A29-DDD232C4D7AB}"/>
               </a:ext>
             </a:extLst>
           </p:cNvPr>
@@ -11047,7 +11123,7 @@
           <p:cNvPr id="23" name="">
             <a:extLst xmlns:a="http://schemas.openxmlformats.org/drawingml/2006/main">
               <a:ext uri="{FF2B5EF4-FFF2-40B4-BE49-F238E27FC236}">
-                <a16:creationId xmlns:a16="http://schemas.microsoft.com/office/drawing/2014/main" id="{AD835A59-7843-4854-8F92-2988AEA77FCB}"/>
+                <a16:creationId xmlns:a16="http://schemas.microsoft.com/office/drawing/2014/main" id="{CBB18F73-B6DE-4908-87A9-8C477E0A71B2}"/>
               </a:ext>
             </a:extLst>
           </p:cNvPr>
@@ -11107,7 +11183,7 @@
           <p:cNvPr id="24" name="">
             <a:extLst xmlns:a="http://schemas.openxmlformats.org/drawingml/2006/main">
               <a:ext uri="{FF2B5EF4-FFF2-40B4-BE49-F238E27FC236}">
-                <a16:creationId xmlns:a16="http://schemas.microsoft.com/office/drawing/2014/main" id="{5000DE9E-EBE0-4106-BD6E-834F129AB71C}"/>
+                <a16:creationId xmlns:a16="http://schemas.microsoft.com/office/drawing/2014/main" id="{97B865E2-7BFB-4861-8682-B49BC6579984}"/>
               </a:ext>
             </a:extLst>
           </p:cNvPr>
@@ -11165,7 +11241,7 @@
           <p:cNvPr id="25" name="">
             <a:extLst xmlns:a="http://schemas.openxmlformats.org/drawingml/2006/main">
               <a:ext uri="{FF2B5EF4-FFF2-40B4-BE49-F238E27FC236}">
-                <a16:creationId xmlns:a16="http://schemas.microsoft.com/office/drawing/2014/main" id="{4CCC7C83-FDD9-4F22-9FB9-F2E1184DB18A}"/>
+                <a16:creationId xmlns:a16="http://schemas.microsoft.com/office/drawing/2014/main" id="{95CE0E8B-B513-41B4-BE41-0E51298094CB}"/>
               </a:ext>
             </a:extLst>
           </p:cNvPr>
@@ -11223,7 +11299,7 @@
           <p:cNvPr id="26" name="">
             <a:extLst xmlns:a="http://schemas.openxmlformats.org/drawingml/2006/main">
               <a:ext uri="{FF2B5EF4-FFF2-40B4-BE49-F238E27FC236}">
-                <a16:creationId xmlns:a16="http://schemas.microsoft.com/office/drawing/2014/main" id="{573F4245-85FD-45EE-8A4C-607DF810C54D}"/>
+                <a16:creationId xmlns:a16="http://schemas.microsoft.com/office/drawing/2014/main" id="{77AD757B-6605-423D-9BF2-9D1271103C98}"/>
               </a:ext>
             </a:extLst>
           </p:cNvPr>
@@ -11281,7 +11357,7 @@
           <p:cNvPr id="27" name="">
             <a:extLst xmlns:a="http://schemas.openxmlformats.org/drawingml/2006/main">
               <a:ext uri="{FF2B5EF4-FFF2-40B4-BE49-F238E27FC236}">
-                <a16:creationId xmlns:a16="http://schemas.microsoft.com/office/drawing/2014/main" id="{FEA8558A-6E75-40C2-9595-5A343AEA2F27}"/>
+                <a16:creationId xmlns:a16="http://schemas.microsoft.com/office/drawing/2014/main" id="{F7A47D79-2FD5-4E5E-AFFD-E4BE3231990C}"/>
               </a:ext>
             </a:extLst>
           </p:cNvPr>
@@ -11312,7 +11388,7 @@
           <p:cNvPr id="28" name="">
             <a:extLst xmlns:a="http://schemas.openxmlformats.org/drawingml/2006/main">
               <a:ext uri="{FF2B5EF4-FFF2-40B4-BE49-F238E27FC236}">
-                <a16:creationId xmlns:a16="http://schemas.microsoft.com/office/drawing/2014/main" id="{92009970-708B-4A91-AFCF-6BACAF414324}"/>
+                <a16:creationId xmlns:a16="http://schemas.microsoft.com/office/drawing/2014/main" id="{D1571F2A-34A2-4242-8A81-7A69826CE97F}"/>
               </a:ext>
             </a:extLst>
           </p:cNvPr>
@@ -11372,7 +11448,7 @@
           <p:cNvPr id="29" name="">
             <a:extLst xmlns:a="http://schemas.openxmlformats.org/drawingml/2006/main">
               <a:ext uri="{FF2B5EF4-FFF2-40B4-BE49-F238E27FC236}">
-                <a16:creationId xmlns:a16="http://schemas.microsoft.com/office/drawing/2014/main" id="{AB4B0A0A-EFC4-4067-9E2C-B52396904154}"/>
+                <a16:creationId xmlns:a16="http://schemas.microsoft.com/office/drawing/2014/main" id="{380569CC-922A-4ABE-AB92-8E024869954E}"/>
               </a:ext>
             </a:extLst>
           </p:cNvPr>
@@ -11430,7 +11506,7 @@
           <p:cNvPr id="30" name="">
             <a:extLst xmlns:a="http://schemas.openxmlformats.org/drawingml/2006/main">
               <a:ext uri="{FF2B5EF4-FFF2-40B4-BE49-F238E27FC236}">
-                <a16:creationId xmlns:a16="http://schemas.microsoft.com/office/drawing/2014/main" id="{6431B926-E6BE-49BA-A078-ECAE30AD81D8}"/>
+                <a16:creationId xmlns:a16="http://schemas.microsoft.com/office/drawing/2014/main" id="{C58A28BE-6B15-4927-B324-3A5141B91AB8}"/>
               </a:ext>
             </a:extLst>
           </p:cNvPr>
@@ -11488,7 +11564,7 @@
           <p:cNvPr id="31" name="">
             <a:extLst xmlns:a="http://schemas.openxmlformats.org/drawingml/2006/main">
               <a:ext uri="{FF2B5EF4-FFF2-40B4-BE49-F238E27FC236}">
-                <a16:creationId xmlns:a16="http://schemas.microsoft.com/office/drawing/2014/main" id="{5658718C-0F48-452B-BE83-4781CB905D1F}"/>
+                <a16:creationId xmlns:a16="http://schemas.microsoft.com/office/drawing/2014/main" id="{927E8E57-F455-4C20-936A-5E422CD42579}"/>
               </a:ext>
             </a:extLst>
           </p:cNvPr>
@@ -11546,7 +11622,7 @@
           <p:cNvPr id="32" name="">
             <a:extLst xmlns:a="http://schemas.openxmlformats.org/drawingml/2006/main">
               <a:ext uri="{FF2B5EF4-FFF2-40B4-BE49-F238E27FC236}">
-                <a16:creationId xmlns:a16="http://schemas.microsoft.com/office/drawing/2014/main" id="{20C00AB9-3D97-4D23-98D3-1872330A35E0}"/>
+                <a16:creationId xmlns:a16="http://schemas.microsoft.com/office/drawing/2014/main" id="{B91A7371-26CF-4765-BD71-4031005ED493}"/>
               </a:ext>
             </a:extLst>
           </p:cNvPr>
@@ -11604,7 +11680,7 @@
           <p:cNvPr id="33" name="">
             <a:extLst xmlns:a="http://schemas.openxmlformats.org/drawingml/2006/main">
               <a:ext uri="{FF2B5EF4-FFF2-40B4-BE49-F238E27FC236}">
-                <a16:creationId xmlns:a16="http://schemas.microsoft.com/office/drawing/2014/main" id="{E7806194-3B75-401A-BE84-C072458CD810}"/>
+                <a16:creationId xmlns:a16="http://schemas.microsoft.com/office/drawing/2014/main" id="{57C52E3C-54AF-4639-B7F9-A09E2B881565}"/>
               </a:ext>
             </a:extLst>
           </p:cNvPr>
@@ -11635,7 +11711,7 @@
           <p:cNvPr id="34" name="">
             <a:extLst xmlns:a="http://schemas.openxmlformats.org/drawingml/2006/main">
               <a:ext uri="{FF2B5EF4-FFF2-40B4-BE49-F238E27FC236}">
-                <a16:creationId xmlns:a16="http://schemas.microsoft.com/office/drawing/2014/main" id="{41DDD657-733C-4679-8F3D-FDEAFB965BB1}"/>
+                <a16:creationId xmlns:a16="http://schemas.microsoft.com/office/drawing/2014/main" id="{2EE26CBB-D9F4-4CBB-94AA-5B5272F5460B}"/>
               </a:ext>
             </a:extLst>
           </p:cNvPr>
@@ -11691,7 +11767,7 @@
     </p:spTree>
     <p:extLst>
       <p:ext uri="{BB962C8B-B14F-4D97-AF65-F5344CB8AC3E}">
-        <p14:creationId xmlns:p14="http://schemas.microsoft.com/office/powerpoint/2010/main" val="1576508346"/>
+        <p14:creationId xmlns:p14="http://schemas.microsoft.com/office/powerpoint/2010/main" val="665553368"/>
       </p:ext>
     </p:extLst>
   </p:cSld>
@@ -11719,10 +11795,10 @@
       </p:grpSpPr>
       <p:sp>
         <p:nvSpPr>
-          <p:cNvPr id="25" name="">
-            <a:extLst xmlns:a="http://schemas.openxmlformats.org/drawingml/2006/main">
-              <a:ext uri="{FF2B5EF4-FFF2-40B4-BE49-F238E27FC236}">
-                <a16:creationId xmlns:a16="http://schemas.microsoft.com/office/drawing/2014/main" id="{7D2BC197-957D-4EFB-AC32-84909A5E6233}"/>
+          <p:cNvPr id="19" name="">
+            <a:extLst xmlns:a="http://schemas.openxmlformats.org/drawingml/2006/main">
+              <a:ext uri="{FF2B5EF4-FFF2-40B4-BE49-F238E27FC236}">
+                <a16:creationId xmlns:a16="http://schemas.microsoft.com/office/drawing/2014/main" id="{62573216-D3D0-4BFD-80FC-11883B6EE025}"/>
               </a:ext>
             </a:extLst>
           </p:cNvPr>
@@ -11753,7 +11829,7 @@
           <p:cNvPr id="2" name="">
             <a:extLst xmlns:a="http://schemas.openxmlformats.org/drawingml/2006/main">
               <a:ext uri="{FF2B5EF4-FFF2-40B4-BE49-F238E27FC236}">
-                <a16:creationId xmlns:a16="http://schemas.microsoft.com/office/drawing/2014/main" id="{1A703339-2F73-42A6-ADE5-66859832135F}"/>
+                <a16:creationId xmlns:a16="http://schemas.microsoft.com/office/drawing/2014/main" id="{4502C982-D549-48CE-BCAC-FFA3940B8883}"/>
               </a:ext>
             </a:extLst>
           </p:cNvPr>
@@ -11783,7 +11859,7 @@
           <a:lstStyle xmlns:a="http://schemas.openxmlformats.org/drawingml/2006/main"/>
           <a:p xmlns:a="http://schemas.openxmlformats.org/drawingml/2006/main">
             <a:pPr algn="l">
-              <a:defRPr sz="2925" b="1" i="0">
+              <a:defRPr sz="3225" b="1" i="0">
                 <a:solidFill>
                   <a:srgbClr val="102A43"/>
                 </a:solidFill>
@@ -11793,7 +11869,7 @@
               </a:defRPr>
             </a:pPr>
             <a:r>
-              <a:rPr sz="2925" b="1" i="0">
+              <a:rPr sz="3225" b="1" i="0">
                 <a:solidFill>
                   <a:srgbClr val="102A43"/>
                 </a:solidFill>
@@ -11801,7 +11877,7 @@
                 <a:ea typeface="Nimbus Sans"/>
                 <a:cs typeface="Nimbus Sans"/>
               </a:rPr>
-              <a:t>A 90-day pilot can answer the deployment question</a:t>
+              <a:t>Proposed pilot phases and feasibility targets</a:t>
             </a:r>
           </a:p>
         </p:txBody>
@@ -11811,7 +11887,7 @@
           <p:cNvPr id="3" name="">
             <a:extLst xmlns:a="http://schemas.openxmlformats.org/drawingml/2006/main">
               <a:ext uri="{FF2B5EF4-FFF2-40B4-BE49-F238E27FC236}">
-                <a16:creationId xmlns:a16="http://schemas.microsoft.com/office/drawing/2014/main" id="{8ACB2A02-6FC7-4B06-9BC0-FC0EAF75C15B}"/>
+                <a16:creationId xmlns:a16="http://schemas.microsoft.com/office/drawing/2014/main" id="{93205C26-3B7B-4973-8E8C-EAC4D2E587A6}"/>
               </a:ext>
             </a:extLst>
           </p:cNvPr>
@@ -11869,110 +11945,77 @@
           <p:cNvPr id="4" name="">
             <a:extLst xmlns:a="http://schemas.openxmlformats.org/drawingml/2006/main">
               <a:ext uri="{FF2B5EF4-FFF2-40B4-BE49-F238E27FC236}">
-                <a16:creationId xmlns:a16="http://schemas.microsoft.com/office/drawing/2014/main" id="{21D1F170-7B22-44A3-88D5-42C6157B9969}"/>
-              </a:ext>
-            </a:extLst>
-          </p:cNvPr>
-          <p:cNvSpPr>
-            <a:spLocks xmlns:a="http://schemas.openxmlformats.org/drawingml/2006/main" noGrp="1"/>
-          </p:cNvSpPr>
-          <p:nvPr/>
-        </p:nvSpPr>
-        <p:spPr>
-          <a:xfrm xmlns:a="http://schemas.openxmlformats.org/drawingml/2006/main">
-            <a:off x="590550" y="1600200"/>
-            <a:ext cx="3476625" cy="4038600"/>
-          </a:xfrm>
-          <a:prstGeom xmlns:a="http://schemas.openxmlformats.org/drawingml/2006/main" prst="roundRect">
-            <a:avLst>
-              <a:gd name="adj" fmla="val 2740"/>
-            </a:avLst>
-          </a:prstGeom>
-          <a:solidFill xmlns:a="http://schemas.openxmlformats.org/drawingml/2006/main">
-            <a:srgbClr val="E8F2F0"/>
-          </a:solidFill>
-          <a:ln xmlns:a="http://schemas.openxmlformats.org/drawingml/2006/main" w="0">
-            <a:noFill/>
-            <a:prstDash val="solid"/>
-          </a:ln>
-        </p:spPr>
+                <a16:creationId xmlns:a16="http://schemas.microsoft.com/office/drawing/2014/main" id="{261DDEDE-3D1C-4772-882C-B3A6D883E04D}"/>
+              </a:ext>
+            </a:extLst>
+          </p:cNvPr>
+          <p:cNvSpPr>
+            <a:spLocks xmlns:a="http://schemas.openxmlformats.org/drawingml/2006/main" noGrp="1"/>
+          </p:cNvSpPr>
+          <p:nvPr/>
+        </p:nvSpPr>
+        <p:spPr>
+          <a:xfrm xmlns:a="http://schemas.openxmlformats.org/drawingml/2006/main">
+            <a:off x="762000" y="1571625"/>
+            <a:ext cx="1666875" cy="400050"/>
+          </a:xfrm>
+          <a:prstGeom xmlns:a="http://schemas.openxmlformats.org/drawingml/2006/main" prst="rect">
+            <a:avLst/>
+          </a:prstGeom>
+          <a:noFill xmlns:a="http://schemas.openxmlformats.org/drawingml/2006/main"/>
+          <a:ln xmlns:a="http://schemas.openxmlformats.org/drawingml/2006/main" w="0">
+            <a:noFill/>
+            <a:prstDash val="solid"/>
+          </a:ln>
+        </p:spPr>
+        <p:txBody>
+          <a:bodyPr xmlns:a="http://schemas.openxmlformats.org/drawingml/2006/main" wrap="square" lIns="0" tIns="0" rIns="0" bIns="0" anchor="t">
+            <a:noAutofit/>
+          </a:bodyPr>
+          <a:lstStyle xmlns:a="http://schemas.openxmlformats.org/drawingml/2006/main"/>
+          <a:p xmlns:a="http://schemas.openxmlformats.org/drawingml/2006/main">
+            <a:pPr algn="l">
+              <a:defRPr sz="1800" b="1" i="0">
+                <a:solidFill>
+                  <a:srgbClr val="0E7C7B"/>
+                </a:solidFill>
+                <a:latin typeface="Nimbus Sans"/>
+                <a:ea typeface="Nimbus Sans"/>
+                <a:cs typeface="Nimbus Sans"/>
+              </a:defRPr>
+            </a:pPr>
+            <a:r>
+              <a:rPr sz="1800" b="1" i="0">
+                <a:solidFill>
+                  <a:srgbClr val="0E7C7B"/>
+                </a:solidFill>
+                <a:latin typeface="Nimbus Sans"/>
+                <a:ea typeface="Nimbus Sans"/>
+                <a:cs typeface="Nimbus Sans"/>
+              </a:rPr>
+              <a:t>Weeks 0–4</a:t>
+            </a:r>
+          </a:p>
+        </p:txBody>
       </p:sp>
       <p:sp>
         <p:nvSpPr>
           <p:cNvPr id="5" name="">
             <a:extLst xmlns:a="http://schemas.openxmlformats.org/drawingml/2006/main">
               <a:ext uri="{FF2B5EF4-FFF2-40B4-BE49-F238E27FC236}">
-                <a16:creationId xmlns:a16="http://schemas.microsoft.com/office/drawing/2014/main" id="{B761FC47-F6E4-41A2-BFEC-5FC93144A67E}"/>
-              </a:ext>
-            </a:extLst>
-          </p:cNvPr>
-          <p:cNvSpPr>
-            <a:spLocks xmlns:a="http://schemas.openxmlformats.org/drawingml/2006/main" noGrp="1"/>
-          </p:cNvSpPr>
-          <p:nvPr/>
-        </p:nvSpPr>
-        <p:spPr>
-          <a:xfrm xmlns:a="http://schemas.openxmlformats.org/drawingml/2006/main">
-            <a:off x="857250" y="1847850"/>
-            <a:ext cx="2857500" cy="285750"/>
-          </a:xfrm>
-          <a:prstGeom xmlns:a="http://schemas.openxmlformats.org/drawingml/2006/main" prst="rect">
-            <a:avLst/>
-          </a:prstGeom>
-          <a:noFill xmlns:a="http://schemas.openxmlformats.org/drawingml/2006/main"/>
-          <a:ln xmlns:a="http://schemas.openxmlformats.org/drawingml/2006/main" w="0">
-            <a:noFill/>
-            <a:prstDash val="solid"/>
-          </a:ln>
-        </p:spPr>
-        <p:txBody>
-          <a:bodyPr xmlns:a="http://schemas.openxmlformats.org/drawingml/2006/main" wrap="square" lIns="0" tIns="0" rIns="0" bIns="0" anchor="t">
-            <a:noAutofit/>
-          </a:bodyPr>
-          <a:lstStyle xmlns:a="http://schemas.openxmlformats.org/drawingml/2006/main"/>
-          <a:p xmlns:a="http://schemas.openxmlformats.org/drawingml/2006/main">
-            <a:pPr algn="l">
-              <a:defRPr sz="1350" b="1" i="0">
-                <a:solidFill>
-                  <a:srgbClr val="0E7C7B"/>
-                </a:solidFill>
-                <a:latin typeface="Nimbus Sans"/>
-                <a:ea typeface="Nimbus Sans"/>
-                <a:cs typeface="Nimbus Sans"/>
-              </a:defRPr>
-            </a:pPr>
-            <a:r>
-              <a:rPr sz="1350" b="1" i="0">
-                <a:solidFill>
-                  <a:srgbClr val="0E7C7B"/>
-                </a:solidFill>
-                <a:latin typeface="Nimbus Sans"/>
-                <a:ea typeface="Nimbus Sans"/>
-                <a:cs typeface="Nimbus Sans"/>
-              </a:rPr>
-              <a:t>Weeks 0–4</a:t>
-            </a:r>
-          </a:p>
-        </p:txBody>
-      </p:sp>
-      <p:sp>
-        <p:nvSpPr>
-          <p:cNvPr id="6" name="">
-            <a:extLst xmlns:a="http://schemas.openxmlformats.org/drawingml/2006/main">
-              <a:ext uri="{FF2B5EF4-FFF2-40B4-BE49-F238E27FC236}">
-                <a16:creationId xmlns:a16="http://schemas.microsoft.com/office/drawing/2014/main" id="{AEB438CB-02E4-4F8E-ADD3-B6EDA0CC36FB}"/>
-              </a:ext>
-            </a:extLst>
-          </p:cNvPr>
-          <p:cNvSpPr>
-            <a:spLocks xmlns:a="http://schemas.openxmlformats.org/drawingml/2006/main" noGrp="1"/>
-          </p:cNvSpPr>
-          <p:nvPr/>
-        </p:nvSpPr>
-        <p:spPr>
-          <a:xfrm xmlns:a="http://schemas.openxmlformats.org/drawingml/2006/main">
-            <a:off x="857250" y="2305050"/>
-            <a:ext cx="2905125" cy="666750"/>
+                <a16:creationId xmlns:a16="http://schemas.microsoft.com/office/drawing/2014/main" id="{65EAEA91-2D03-4E40-82AB-06EEE0E0B358}"/>
+              </a:ext>
+            </a:extLst>
+          </p:cNvPr>
+          <p:cNvSpPr>
+            <a:spLocks xmlns:a="http://schemas.openxmlformats.org/drawingml/2006/main" noGrp="1"/>
+          </p:cNvSpPr>
+          <p:nvPr/>
+        </p:nvSpPr>
+        <p:spPr>
+          <a:xfrm xmlns:a="http://schemas.openxmlformats.org/drawingml/2006/main">
+            <a:off x="2619375" y="1571625"/>
+            <a:ext cx="8477250" cy="361950"/>
           </a:xfrm>
           <a:prstGeom xmlns:a="http://schemas.openxmlformats.org/drawingml/2006/main" prst="rect">
             <a:avLst/>
@@ -12008,7 +12051,65 @@
                 <a:ea typeface="Nimbus Sans"/>
                 <a:cs typeface="Nimbus Sans"/>
               </a:rPr>
-              <a:t>Local retrospective validation</a:t>
+              <a:t>Local validation</a:t>
+            </a:r>
+          </a:p>
+        </p:txBody>
+      </p:sp>
+      <p:sp>
+        <p:nvSpPr>
+          <p:cNvPr id="6" name="">
+            <a:extLst xmlns:a="http://schemas.openxmlformats.org/drawingml/2006/main">
+              <a:ext uri="{FF2B5EF4-FFF2-40B4-BE49-F238E27FC236}">
+                <a16:creationId xmlns:a16="http://schemas.microsoft.com/office/drawing/2014/main" id="{BE4A2EEE-D41E-4E45-9DDE-F6265DCD3782}"/>
+              </a:ext>
+            </a:extLst>
+          </p:cNvPr>
+          <p:cNvSpPr>
+            <a:spLocks xmlns:a="http://schemas.openxmlformats.org/drawingml/2006/main" noGrp="1"/>
+          </p:cNvSpPr>
+          <p:nvPr/>
+        </p:nvSpPr>
+        <p:spPr>
+          <a:xfrm xmlns:a="http://schemas.openxmlformats.org/drawingml/2006/main">
+            <a:off x="2619375" y="1981200"/>
+            <a:ext cx="8477250" cy="381000"/>
+          </a:xfrm>
+          <a:prstGeom xmlns:a="http://schemas.openxmlformats.org/drawingml/2006/main" prst="rect">
+            <a:avLst/>
+          </a:prstGeom>
+          <a:noFill xmlns:a="http://schemas.openxmlformats.org/drawingml/2006/main"/>
+          <a:ln xmlns:a="http://schemas.openxmlformats.org/drawingml/2006/main" w="0">
+            <a:noFill/>
+            <a:prstDash val="solid"/>
+          </a:ln>
+        </p:spPr>
+        <p:txBody>
+          <a:bodyPr xmlns:a="http://schemas.openxmlformats.org/drawingml/2006/main" wrap="square" lIns="0" tIns="0" rIns="0" bIns="0" anchor="t">
+            <a:noAutofit/>
+          </a:bodyPr>
+          <a:lstStyle xmlns:a="http://schemas.openxmlformats.org/drawingml/2006/main"/>
+          <a:p xmlns:a="http://schemas.openxmlformats.org/drawingml/2006/main">
+            <a:pPr algn="l">
+              <a:defRPr sz="1650" b="0" i="0">
+                <a:solidFill>
+                  <a:srgbClr val="243B53"/>
+                </a:solidFill>
+                <a:latin typeface="Nimbus Sans"/>
+                <a:ea typeface="Nimbus Sans"/>
+                <a:cs typeface="Nimbus Sans"/>
+              </a:defRPr>
+            </a:pPr>
+            <a:r>
+              <a:rPr sz="1650" b="0" i="0">
+                <a:solidFill>
+                  <a:srgbClr val="243B53"/>
+                </a:solidFill>
+                <a:latin typeface="Nimbus Sans"/>
+                <a:ea typeface="Nimbus Sans"/>
+                <a:cs typeface="Nimbus Sans"/>
+              </a:rPr>
+              <a:t>Check features, calibration, subgroup errors and workload</a:t>
             </a:r>
           </a:p>
         </p:txBody>
@@ -12018,257 +12119,77 @@
           <p:cNvPr id="7" name="">
             <a:extLst xmlns:a="http://schemas.openxmlformats.org/drawingml/2006/main">
               <a:ext uri="{FF2B5EF4-FFF2-40B4-BE49-F238E27FC236}">
-                <a16:creationId xmlns:a16="http://schemas.microsoft.com/office/drawing/2014/main" id="{23B9D25F-48BD-40E6-9F42-529533C126DC}"/>
-              </a:ext>
-            </a:extLst>
-          </p:cNvPr>
-          <p:cNvSpPr>
-            <a:spLocks xmlns:a="http://schemas.openxmlformats.org/drawingml/2006/main" noGrp="1"/>
-          </p:cNvSpPr>
-          <p:nvPr/>
-        </p:nvSpPr>
-        <p:spPr>
-          <a:xfrm xmlns:a="http://schemas.openxmlformats.org/drawingml/2006/main">
-            <a:off x="857250" y="3105150"/>
-            <a:ext cx="2905125" cy="0"/>
-          </a:xfrm>
-          <a:prstGeom xmlns:a="http://schemas.openxmlformats.org/drawingml/2006/main" prst="line">
-            <a:avLst/>
-          </a:prstGeom>
-          <a:noFill xmlns:a="http://schemas.openxmlformats.org/drawingml/2006/main"/>
-          <a:ln xmlns:a="http://schemas.openxmlformats.org/drawingml/2006/main" w="28575">
-            <a:solidFill>
-              <a:srgbClr val="2A9D8F"/>
-            </a:solidFill>
-            <a:prstDash val="solid"/>
-          </a:ln>
-        </p:spPr>
+                <a16:creationId xmlns:a16="http://schemas.microsoft.com/office/drawing/2014/main" id="{882763CE-6BB0-483C-B8C1-ADE2E47D82BE}"/>
+              </a:ext>
+            </a:extLst>
+          </p:cNvPr>
+          <p:cNvSpPr>
+            <a:spLocks xmlns:a="http://schemas.openxmlformats.org/drawingml/2006/main" noGrp="1"/>
+          </p:cNvSpPr>
+          <p:nvPr/>
+        </p:nvSpPr>
+        <p:spPr>
+          <a:xfrm xmlns:a="http://schemas.openxmlformats.org/drawingml/2006/main">
+            <a:off x="762000" y="2552700"/>
+            <a:ext cx="1666875" cy="400050"/>
+          </a:xfrm>
+          <a:prstGeom xmlns:a="http://schemas.openxmlformats.org/drawingml/2006/main" prst="rect">
+            <a:avLst/>
+          </a:prstGeom>
+          <a:noFill xmlns:a="http://schemas.openxmlformats.org/drawingml/2006/main"/>
+          <a:ln xmlns:a="http://schemas.openxmlformats.org/drawingml/2006/main" w="0">
+            <a:noFill/>
+            <a:prstDash val="solid"/>
+          </a:ln>
+        </p:spPr>
+        <p:txBody>
+          <a:bodyPr xmlns:a="http://schemas.openxmlformats.org/drawingml/2006/main" wrap="square" lIns="0" tIns="0" rIns="0" bIns="0" anchor="t">
+            <a:noAutofit/>
+          </a:bodyPr>
+          <a:lstStyle xmlns:a="http://schemas.openxmlformats.org/drawingml/2006/main"/>
+          <a:p xmlns:a="http://schemas.openxmlformats.org/drawingml/2006/main">
+            <a:pPr algn="l">
+              <a:defRPr sz="1800" b="1" i="0">
+                <a:solidFill>
+                  <a:srgbClr val="0E7C7B"/>
+                </a:solidFill>
+                <a:latin typeface="Nimbus Sans"/>
+                <a:ea typeface="Nimbus Sans"/>
+                <a:cs typeface="Nimbus Sans"/>
+              </a:defRPr>
+            </a:pPr>
+            <a:r>
+              <a:rPr sz="1800" b="1" i="0">
+                <a:solidFill>
+                  <a:srgbClr val="0E7C7B"/>
+                </a:solidFill>
+                <a:latin typeface="Nimbus Sans"/>
+                <a:ea typeface="Nimbus Sans"/>
+                <a:cs typeface="Nimbus Sans"/>
+              </a:rPr>
+              <a:t>Weeks 5–8</a:t>
+            </a:r>
+          </a:p>
+        </p:txBody>
       </p:sp>
       <p:sp>
         <p:nvSpPr>
           <p:cNvPr id="8" name="">
             <a:extLst xmlns:a="http://schemas.openxmlformats.org/drawingml/2006/main">
               <a:ext uri="{FF2B5EF4-FFF2-40B4-BE49-F238E27FC236}">
-                <a16:creationId xmlns:a16="http://schemas.microsoft.com/office/drawing/2014/main" id="{39084D94-1C3D-473F-ACFD-C78E86D09602}"/>
-              </a:ext>
-            </a:extLst>
-          </p:cNvPr>
-          <p:cNvSpPr>
-            <a:spLocks xmlns:a="http://schemas.openxmlformats.org/drawingml/2006/main" noGrp="1"/>
-          </p:cNvSpPr>
-          <p:nvPr/>
-        </p:nvSpPr>
-        <p:spPr>
-          <a:xfrm xmlns:a="http://schemas.openxmlformats.org/drawingml/2006/main">
-            <a:off x="857250" y="3333750"/>
-            <a:ext cx="2905125" cy="1333500"/>
-          </a:xfrm>
-          <a:prstGeom xmlns:a="http://schemas.openxmlformats.org/drawingml/2006/main" prst="rect">
-            <a:avLst/>
-          </a:prstGeom>
-          <a:noFill xmlns:a="http://schemas.openxmlformats.org/drawingml/2006/main"/>
-          <a:ln xmlns:a="http://schemas.openxmlformats.org/drawingml/2006/main" w="0">
-            <a:noFill/>
-            <a:prstDash val="solid"/>
-          </a:ln>
-        </p:spPr>
-        <p:txBody>
-          <a:bodyPr xmlns:a="http://schemas.openxmlformats.org/drawingml/2006/main" wrap="square" lIns="0" tIns="0" rIns="0" bIns="0" anchor="t">
-            <a:noAutofit/>
-          </a:bodyPr>
-          <a:lstStyle xmlns:a="http://schemas.openxmlformats.org/drawingml/2006/main"/>
-          <a:p xmlns:a="http://schemas.openxmlformats.org/drawingml/2006/main">
-            <a:pPr algn="l">
-              <a:defRPr sz="1425" b="0" i="0">
-                <a:solidFill>
-                  <a:srgbClr val="243B53"/>
-                </a:solidFill>
-                <a:latin typeface="Nimbus Sans"/>
-                <a:ea typeface="Nimbus Sans"/>
-                <a:cs typeface="Nimbus Sans"/>
-              </a:defRPr>
-            </a:pPr>
-            <a:r>
-              <a:rPr sz="1425" b="0" i="0">
-                <a:solidFill>
-                  <a:srgbClr val="243B53"/>
-                </a:solidFill>
-                <a:latin typeface="Nimbus Sans"/>
-                <a:ea typeface="Nimbus Sans"/>
-                <a:cs typeface="Nimbus Sans"/>
-              </a:rPr>
-              <a:t>Rebuild features, check data quality, assess calibration, capacity, subgroups, and missingness</a:t>
-            </a:r>
-          </a:p>
-        </p:txBody>
-      </p:sp>
-      <p:sp>
-        <p:nvSpPr>
-          <p:cNvPr id="9" name="">
-            <a:extLst xmlns:a="http://schemas.openxmlformats.org/drawingml/2006/main">
-              <a:ext uri="{FF2B5EF4-FFF2-40B4-BE49-F238E27FC236}">
-                <a16:creationId xmlns:a16="http://schemas.microsoft.com/office/drawing/2014/main" id="{F69E2626-49AD-4A80-AB3D-6AA4BC6AB403}"/>
-              </a:ext>
-            </a:extLst>
-          </p:cNvPr>
-          <p:cNvSpPr>
-            <a:spLocks xmlns:a="http://schemas.openxmlformats.org/drawingml/2006/main" noGrp="1"/>
-          </p:cNvSpPr>
-          <p:nvPr/>
-        </p:nvSpPr>
-        <p:spPr>
-          <a:xfrm xmlns:a="http://schemas.openxmlformats.org/drawingml/2006/main">
-            <a:off x="857250" y="4876800"/>
-            <a:ext cx="2905125" cy="590550"/>
-          </a:xfrm>
-          <a:prstGeom xmlns:a="http://schemas.openxmlformats.org/drawingml/2006/main" prst="rect">
-            <a:avLst/>
-          </a:prstGeom>
-          <a:noFill xmlns:a="http://schemas.openxmlformats.org/drawingml/2006/main"/>
-          <a:ln xmlns:a="http://schemas.openxmlformats.org/drawingml/2006/main" w="0">
-            <a:noFill/>
-            <a:prstDash val="solid"/>
-          </a:ln>
-        </p:spPr>
-        <p:txBody>
-          <a:bodyPr xmlns:a="http://schemas.openxmlformats.org/drawingml/2006/main" wrap="square" lIns="0" tIns="0" rIns="0" bIns="0" anchor="t">
-            <a:noAutofit/>
-          </a:bodyPr>
-          <a:lstStyle xmlns:a="http://schemas.openxmlformats.org/drawingml/2006/main"/>
-          <a:p xmlns:a="http://schemas.openxmlformats.org/drawingml/2006/main">
-            <a:pPr algn="l">
-              <a:defRPr sz="1350" b="1" i="0">
-                <a:solidFill>
-                  <a:srgbClr val="287D5A"/>
-                </a:solidFill>
-                <a:latin typeface="Nimbus Sans"/>
-                <a:ea typeface="Nimbus Sans"/>
-                <a:cs typeface="Nimbus Sans"/>
-              </a:defRPr>
-            </a:pPr>
-            <a:r>
-              <a:rPr sz="1350" b="1" i="0">
-                <a:solidFill>
-                  <a:srgbClr val="287D5A"/>
-                </a:solidFill>
-                <a:latin typeface="Nimbus Sans"/>
-                <a:ea typeface="Nimbus Sans"/>
-                <a:cs typeface="Nimbus Sans"/>
-              </a:rPr>
-              <a:t>Gate: model and data fit for observation</a:t>
-            </a:r>
-          </a:p>
-        </p:txBody>
-      </p:sp>
-      <p:sp>
-        <p:nvSpPr>
-          <p:cNvPr id="10" name="">
-            <a:extLst xmlns:a="http://schemas.openxmlformats.org/drawingml/2006/main">
-              <a:ext uri="{FF2B5EF4-FFF2-40B4-BE49-F238E27FC236}">
-                <a16:creationId xmlns:a16="http://schemas.microsoft.com/office/drawing/2014/main" id="{B960F53C-2F66-477A-B7AC-59F8915A0D45}"/>
-              </a:ext>
-            </a:extLst>
-          </p:cNvPr>
-          <p:cNvSpPr>
-            <a:spLocks xmlns:a="http://schemas.openxmlformats.org/drawingml/2006/main" noGrp="1"/>
-          </p:cNvSpPr>
-          <p:nvPr/>
-        </p:nvSpPr>
-        <p:spPr>
-          <a:xfrm xmlns:a="http://schemas.openxmlformats.org/drawingml/2006/main">
-            <a:off x="4448175" y="1600200"/>
-            <a:ext cx="3476625" cy="4038600"/>
-          </a:xfrm>
-          <a:prstGeom xmlns:a="http://schemas.openxmlformats.org/drawingml/2006/main" prst="roundRect">
-            <a:avLst>
-              <a:gd name="adj" fmla="val 2740"/>
-            </a:avLst>
-          </a:prstGeom>
-          <a:solidFill xmlns:a="http://schemas.openxmlformats.org/drawingml/2006/main">
-            <a:srgbClr val="E8EEF4"/>
-          </a:solidFill>
-          <a:ln xmlns:a="http://schemas.openxmlformats.org/drawingml/2006/main" w="0">
-            <a:noFill/>
-            <a:prstDash val="solid"/>
-          </a:ln>
-        </p:spPr>
-      </p:sp>
-      <p:sp>
-        <p:nvSpPr>
-          <p:cNvPr id="11" name="">
-            <a:extLst xmlns:a="http://schemas.openxmlformats.org/drawingml/2006/main">
-              <a:ext uri="{FF2B5EF4-FFF2-40B4-BE49-F238E27FC236}">
-                <a16:creationId xmlns:a16="http://schemas.microsoft.com/office/drawing/2014/main" id="{B456A8ED-7169-465E-A4A9-8E4541D0163D}"/>
-              </a:ext>
-            </a:extLst>
-          </p:cNvPr>
-          <p:cNvSpPr>
-            <a:spLocks xmlns:a="http://schemas.openxmlformats.org/drawingml/2006/main" noGrp="1"/>
-          </p:cNvSpPr>
-          <p:nvPr/>
-        </p:nvSpPr>
-        <p:spPr>
-          <a:xfrm xmlns:a="http://schemas.openxmlformats.org/drawingml/2006/main">
-            <a:off x="4714875" y="1847850"/>
-            <a:ext cx="2857500" cy="285750"/>
-          </a:xfrm>
-          <a:prstGeom xmlns:a="http://schemas.openxmlformats.org/drawingml/2006/main" prst="rect">
-            <a:avLst/>
-          </a:prstGeom>
-          <a:noFill xmlns:a="http://schemas.openxmlformats.org/drawingml/2006/main"/>
-          <a:ln xmlns:a="http://schemas.openxmlformats.org/drawingml/2006/main" w="0">
-            <a:noFill/>
-            <a:prstDash val="solid"/>
-          </a:ln>
-        </p:spPr>
-        <p:txBody>
-          <a:bodyPr xmlns:a="http://schemas.openxmlformats.org/drawingml/2006/main" wrap="square" lIns="0" tIns="0" rIns="0" bIns="0" anchor="t">
-            <a:noAutofit/>
-          </a:bodyPr>
-          <a:lstStyle xmlns:a="http://schemas.openxmlformats.org/drawingml/2006/main"/>
-          <a:p xmlns:a="http://schemas.openxmlformats.org/drawingml/2006/main">
-            <a:pPr algn="l">
-              <a:defRPr sz="1350" b="1" i="0">
-                <a:solidFill>
-                  <a:srgbClr val="0E7C7B"/>
-                </a:solidFill>
-                <a:latin typeface="Nimbus Sans"/>
-                <a:ea typeface="Nimbus Sans"/>
-                <a:cs typeface="Nimbus Sans"/>
-              </a:defRPr>
-            </a:pPr>
-            <a:r>
-              <a:rPr sz="1350" b="1" i="0">
-                <a:solidFill>
-                  <a:srgbClr val="0E7C7B"/>
-                </a:solidFill>
-                <a:latin typeface="Nimbus Sans"/>
-                <a:ea typeface="Nimbus Sans"/>
-                <a:cs typeface="Nimbus Sans"/>
-              </a:rPr>
-              <a:t>Weeks 5–8</a:t>
-            </a:r>
-          </a:p>
-        </p:txBody>
-      </p:sp>
-      <p:sp>
-        <p:nvSpPr>
-          <p:cNvPr id="12" name="">
-            <a:extLst xmlns:a="http://schemas.openxmlformats.org/drawingml/2006/main">
-              <a:ext uri="{FF2B5EF4-FFF2-40B4-BE49-F238E27FC236}">
-                <a16:creationId xmlns:a16="http://schemas.microsoft.com/office/drawing/2014/main" id="{C610EB36-3F50-4D10-AD24-07C2EFFB4E4B}"/>
-              </a:ext>
-            </a:extLst>
-          </p:cNvPr>
-          <p:cNvSpPr>
-            <a:spLocks xmlns:a="http://schemas.openxmlformats.org/drawingml/2006/main" noGrp="1"/>
-          </p:cNvSpPr>
-          <p:nvPr/>
-        </p:nvSpPr>
-        <p:spPr>
-          <a:xfrm xmlns:a="http://schemas.openxmlformats.org/drawingml/2006/main">
-            <a:off x="4714875" y="2305050"/>
-            <a:ext cx="2905125" cy="666750"/>
+                <a16:creationId xmlns:a16="http://schemas.microsoft.com/office/drawing/2014/main" id="{FA649246-8C1C-4E14-B1D5-79651AFDC65B}"/>
+              </a:ext>
+            </a:extLst>
+          </p:cNvPr>
+          <p:cNvSpPr>
+            <a:spLocks xmlns:a="http://schemas.openxmlformats.org/drawingml/2006/main" noGrp="1"/>
+          </p:cNvSpPr>
+          <p:nvPr/>
+        </p:nvSpPr>
+        <p:spPr>
+          <a:xfrm xmlns:a="http://schemas.openxmlformats.org/drawingml/2006/main">
+            <a:off x="2619375" y="2552700"/>
+            <a:ext cx="8477250" cy="361950"/>
           </a:xfrm>
           <a:prstGeom xmlns:a="http://schemas.openxmlformats.org/drawingml/2006/main" prst="rect">
             <a:avLst/>
@@ -12304,60 +12225,29 @@
                 <a:ea typeface="Nimbus Sans"/>
                 <a:cs typeface="Nimbus Sans"/>
               </a:rPr>
-              <a:t>Prospective silent mode</a:t>
-            </a:r>
-          </a:p>
-        </p:txBody>
-      </p:sp>
-      <p:sp>
-        <p:nvSpPr>
-          <p:cNvPr id="13" name="">
-            <a:extLst xmlns:a="http://schemas.openxmlformats.org/drawingml/2006/main">
-              <a:ext uri="{FF2B5EF4-FFF2-40B4-BE49-F238E27FC236}">
-                <a16:creationId xmlns:a16="http://schemas.microsoft.com/office/drawing/2014/main" id="{1A311AFF-B9F2-40ED-81A1-F65822A31B4B}"/>
-              </a:ext>
-            </a:extLst>
-          </p:cNvPr>
-          <p:cNvSpPr>
-            <a:spLocks xmlns:a="http://schemas.openxmlformats.org/drawingml/2006/main" noGrp="1"/>
-          </p:cNvSpPr>
-          <p:nvPr/>
-        </p:nvSpPr>
-        <p:spPr>
-          <a:xfrm xmlns:a="http://schemas.openxmlformats.org/drawingml/2006/main">
-            <a:off x="4714875" y="3105150"/>
-            <a:ext cx="2905125" cy="0"/>
-          </a:xfrm>
-          <a:prstGeom xmlns:a="http://schemas.openxmlformats.org/drawingml/2006/main" prst="line">
-            <a:avLst/>
-          </a:prstGeom>
-          <a:noFill xmlns:a="http://schemas.openxmlformats.org/drawingml/2006/main"/>
-          <a:ln xmlns:a="http://schemas.openxmlformats.org/drawingml/2006/main" w="28575">
-            <a:solidFill>
-              <a:srgbClr val="2A9D8F"/>
-            </a:solidFill>
-            <a:prstDash val="solid"/>
-          </a:ln>
-        </p:spPr>
-      </p:sp>
-      <p:sp>
-        <p:nvSpPr>
-          <p:cNvPr id="14" name="">
-            <a:extLst xmlns:a="http://schemas.openxmlformats.org/drawingml/2006/main">
-              <a:ext uri="{FF2B5EF4-FFF2-40B4-BE49-F238E27FC236}">
-                <a16:creationId xmlns:a16="http://schemas.microsoft.com/office/drawing/2014/main" id="{FE12797E-207A-46EE-A4D2-1B3DCBE05EC8}"/>
-              </a:ext>
-            </a:extLst>
-          </p:cNvPr>
-          <p:cNvSpPr>
-            <a:spLocks xmlns:a="http://schemas.openxmlformats.org/drawingml/2006/main" noGrp="1"/>
-          </p:cNvSpPr>
-          <p:nvPr/>
-        </p:nvSpPr>
-        <p:spPr>
-          <a:xfrm xmlns:a="http://schemas.openxmlformats.org/drawingml/2006/main">
-            <a:off x="4714875" y="3333750"/>
-            <a:ext cx="2905125" cy="1333500"/>
+              <a:t>Silent evaluation</a:t>
+            </a:r>
+          </a:p>
+        </p:txBody>
+      </p:sp>
+      <p:sp>
+        <p:nvSpPr>
+          <p:cNvPr id="9" name="">
+            <a:extLst xmlns:a="http://schemas.openxmlformats.org/drawingml/2006/main">
+              <a:ext uri="{FF2B5EF4-FFF2-40B4-BE49-F238E27FC236}">
+                <a16:creationId xmlns:a16="http://schemas.microsoft.com/office/drawing/2014/main" id="{C74F6C67-3520-49A7-9CEB-8ED4DCBADF8C}"/>
+              </a:ext>
+            </a:extLst>
+          </p:cNvPr>
+          <p:cNvSpPr>
+            <a:spLocks xmlns:a="http://schemas.openxmlformats.org/drawingml/2006/main" noGrp="1"/>
+          </p:cNvSpPr>
+          <p:nvPr/>
+        </p:nvSpPr>
+        <p:spPr>
+          <a:xfrm xmlns:a="http://schemas.openxmlformats.org/drawingml/2006/main">
+            <a:off x="2619375" y="2962275"/>
+            <a:ext cx="8477250" cy="381000"/>
           </a:xfrm>
           <a:prstGeom xmlns:a="http://schemas.openxmlformats.org/drawingml/2006/main" prst="rect">
             <a:avLst/>
@@ -12375,7 +12265,7 @@
           <a:lstStyle xmlns:a="http://schemas.openxmlformats.org/drawingml/2006/main"/>
           <a:p xmlns:a="http://schemas.openxmlformats.org/drawingml/2006/main">
             <a:pPr algn="l">
-              <a:defRPr sz="1425" b="0" i="0">
+              <a:defRPr sz="1650" b="0" i="0">
                 <a:solidFill>
                   <a:srgbClr val="243B53"/>
                 </a:solidFill>
@@ -12385,7 +12275,7 @@
               </a:defRPr>
             </a:pPr>
             <a:r>
-              <a:rPr sz="1425" b="0" i="0">
+              <a:rPr sz="1650" b="0" i="0">
                 <a:solidFill>
                   <a:srgbClr val="243B53"/>
                 </a:solidFill>
@@ -12393,29 +12283,29 @@
                 <a:ea typeface="Nimbus Sans"/>
                 <a:cs typeface="Nimbus Sans"/>
               </a:rPr>
-              <a:t>Generate scores without showing clinicians. Measure volume, latency, drift, and workflow timing</a:t>
-            </a:r>
-          </a:p>
-        </p:txBody>
-      </p:sp>
-      <p:sp>
-        <p:nvSpPr>
-          <p:cNvPr id="15" name="">
-            <a:extLst xmlns:a="http://schemas.openxmlformats.org/drawingml/2006/main">
-              <a:ext uri="{FF2B5EF4-FFF2-40B4-BE49-F238E27FC236}">
-                <a16:creationId xmlns:a16="http://schemas.microsoft.com/office/drawing/2014/main" id="{3FF81E33-9A08-483A-B5F2-396478D887DF}"/>
-              </a:ext>
-            </a:extLst>
-          </p:cNvPr>
-          <p:cNvSpPr>
-            <a:spLocks xmlns:a="http://schemas.openxmlformats.org/drawingml/2006/main" noGrp="1"/>
-          </p:cNvSpPr>
-          <p:nvPr/>
-        </p:nvSpPr>
-        <p:spPr>
-          <a:xfrm xmlns:a="http://schemas.openxmlformats.org/drawingml/2006/main">
-            <a:off x="4714875" y="4876800"/>
-            <a:ext cx="2905125" cy="590550"/>
+              <a:t>Score without displaying alerts; time simulated reviews</a:t>
+            </a:r>
+          </a:p>
+        </p:txBody>
+      </p:sp>
+      <p:sp>
+        <p:nvSpPr>
+          <p:cNvPr id="10" name="">
+            <a:extLst xmlns:a="http://schemas.openxmlformats.org/drawingml/2006/main">
+              <a:ext uri="{FF2B5EF4-FFF2-40B4-BE49-F238E27FC236}">
+                <a16:creationId xmlns:a16="http://schemas.microsoft.com/office/drawing/2014/main" id="{6AC9FADE-E2A6-485B-AF31-8B3B321103B9}"/>
+              </a:ext>
+            </a:extLst>
+          </p:cNvPr>
+          <p:cNvSpPr>
+            <a:spLocks xmlns:a="http://schemas.openxmlformats.org/drawingml/2006/main" noGrp="1"/>
+          </p:cNvSpPr>
+          <p:nvPr/>
+        </p:nvSpPr>
+        <p:spPr>
+          <a:xfrm xmlns:a="http://schemas.openxmlformats.org/drawingml/2006/main">
+            <a:off x="762000" y="3533775"/>
+            <a:ext cx="1666875" cy="400050"/>
           </a:xfrm>
           <a:prstGeom xmlns:a="http://schemas.openxmlformats.org/drawingml/2006/main" prst="rect">
             <a:avLst/>
@@ -12433,110 +12323,19 @@
           <a:lstStyle xmlns:a="http://schemas.openxmlformats.org/drawingml/2006/main"/>
           <a:p xmlns:a="http://schemas.openxmlformats.org/drawingml/2006/main">
             <a:pPr algn="l">
-              <a:defRPr sz="1350" b="1" i="0">
-                <a:solidFill>
-                  <a:srgbClr val="287D5A"/>
-                </a:solidFill>
-                <a:latin typeface="Nimbus Sans"/>
-                <a:ea typeface="Nimbus Sans"/>
-                <a:cs typeface="Nimbus Sans"/>
-              </a:defRPr>
-            </a:pPr>
-            <a:r>
-              <a:rPr sz="1350" b="1" i="0">
-                <a:solidFill>
-                  <a:srgbClr val="287D5A"/>
-                </a:solidFill>
-                <a:latin typeface="Nimbus Sans"/>
-                <a:ea typeface="Nimbus Sans"/>
-                <a:cs typeface="Nimbus Sans"/>
-              </a:rPr>
-              <a:t>Gate: technically reliable and operationally feasible</a:t>
-            </a:r>
-          </a:p>
-        </p:txBody>
-      </p:sp>
-      <p:sp>
-        <p:nvSpPr>
-          <p:cNvPr id="16" name="">
-            <a:extLst xmlns:a="http://schemas.openxmlformats.org/drawingml/2006/main">
-              <a:ext uri="{FF2B5EF4-FFF2-40B4-BE49-F238E27FC236}">
-                <a16:creationId xmlns:a16="http://schemas.microsoft.com/office/drawing/2014/main" id="{9942EC49-D94C-4017-8AE6-276A637EE24B}"/>
-              </a:ext>
-            </a:extLst>
-          </p:cNvPr>
-          <p:cNvSpPr>
-            <a:spLocks xmlns:a="http://schemas.openxmlformats.org/drawingml/2006/main" noGrp="1"/>
-          </p:cNvSpPr>
-          <p:nvPr/>
-        </p:nvSpPr>
-        <p:spPr>
-          <a:xfrm xmlns:a="http://schemas.openxmlformats.org/drawingml/2006/main">
-            <a:off x="8305800" y="1600200"/>
-            <a:ext cx="3476625" cy="4038600"/>
-          </a:xfrm>
-          <a:prstGeom xmlns:a="http://schemas.openxmlformats.org/drawingml/2006/main" prst="roundRect">
-            <a:avLst>
-              <a:gd name="adj" fmla="val 2740"/>
-            </a:avLst>
-          </a:prstGeom>
-          <a:solidFill xmlns:a="http://schemas.openxmlformats.org/drawingml/2006/main">
-            <a:srgbClr val="F7E8DF"/>
-          </a:solidFill>
-          <a:ln xmlns:a="http://schemas.openxmlformats.org/drawingml/2006/main" w="0">
-            <a:noFill/>
-            <a:prstDash val="solid"/>
-          </a:ln>
-        </p:spPr>
-      </p:sp>
-      <p:sp>
-        <p:nvSpPr>
-          <p:cNvPr id="17" name="">
-            <a:extLst xmlns:a="http://schemas.openxmlformats.org/drawingml/2006/main">
-              <a:ext uri="{FF2B5EF4-FFF2-40B4-BE49-F238E27FC236}">
-                <a16:creationId xmlns:a16="http://schemas.microsoft.com/office/drawing/2014/main" id="{D7775435-83F4-41CB-99CC-943B439CE181}"/>
-              </a:ext>
-            </a:extLst>
-          </p:cNvPr>
-          <p:cNvSpPr>
-            <a:spLocks xmlns:a="http://schemas.openxmlformats.org/drawingml/2006/main" noGrp="1"/>
-          </p:cNvSpPr>
-          <p:nvPr/>
-        </p:nvSpPr>
-        <p:spPr>
-          <a:xfrm xmlns:a="http://schemas.openxmlformats.org/drawingml/2006/main">
-            <a:off x="8572500" y="1847850"/>
-            <a:ext cx="2857500" cy="285750"/>
-          </a:xfrm>
-          <a:prstGeom xmlns:a="http://schemas.openxmlformats.org/drawingml/2006/main" prst="rect">
-            <a:avLst/>
-          </a:prstGeom>
-          <a:noFill xmlns:a="http://schemas.openxmlformats.org/drawingml/2006/main"/>
-          <a:ln xmlns:a="http://schemas.openxmlformats.org/drawingml/2006/main" w="0">
-            <a:noFill/>
-            <a:prstDash val="solid"/>
-          </a:ln>
-        </p:spPr>
-        <p:txBody>
-          <a:bodyPr xmlns:a="http://schemas.openxmlformats.org/drawingml/2006/main" wrap="square" lIns="0" tIns="0" rIns="0" bIns="0" anchor="t">
-            <a:noAutofit/>
-          </a:bodyPr>
-          <a:lstStyle xmlns:a="http://schemas.openxmlformats.org/drawingml/2006/main"/>
-          <a:p xmlns:a="http://schemas.openxmlformats.org/drawingml/2006/main">
-            <a:pPr algn="l">
-              <a:defRPr sz="1350" b="1" i="0">
-                <a:solidFill>
-                  <a:srgbClr val="E76F51"/>
-                </a:solidFill>
-                <a:latin typeface="Nimbus Sans"/>
-                <a:ea typeface="Nimbus Sans"/>
-                <a:cs typeface="Nimbus Sans"/>
-              </a:defRPr>
-            </a:pPr>
-            <a:r>
-              <a:rPr sz="1350" b="1" i="0">
-                <a:solidFill>
-                  <a:srgbClr val="E76F51"/>
+              <a:defRPr sz="1800" b="1" i="0">
+                <a:solidFill>
+                  <a:srgbClr val="0E7C7B"/>
+                </a:solidFill>
+                <a:latin typeface="Nimbus Sans"/>
+                <a:ea typeface="Nimbus Sans"/>
+                <a:cs typeface="Nimbus Sans"/>
+              </a:defRPr>
+            </a:pPr>
+            <a:r>
+              <a:rPr sz="1800" b="1" i="0">
+                <a:solidFill>
+                  <a:srgbClr val="0E7C7B"/>
                 </a:solidFill>
                 <a:latin typeface="Nimbus Sans"/>
                 <a:ea typeface="Nimbus Sans"/>
@@ -12549,22 +12348,22 @@
       </p:sp>
       <p:sp>
         <p:nvSpPr>
-          <p:cNvPr id="18" name="">
-            <a:extLst xmlns:a="http://schemas.openxmlformats.org/drawingml/2006/main">
-              <a:ext uri="{FF2B5EF4-FFF2-40B4-BE49-F238E27FC236}">
-                <a16:creationId xmlns:a16="http://schemas.microsoft.com/office/drawing/2014/main" id="{FAEE1036-20A4-413C-92E8-156385D2A688}"/>
-              </a:ext>
-            </a:extLst>
-          </p:cNvPr>
-          <p:cNvSpPr>
-            <a:spLocks xmlns:a="http://schemas.openxmlformats.org/drawingml/2006/main" noGrp="1"/>
-          </p:cNvSpPr>
-          <p:nvPr/>
-        </p:nvSpPr>
-        <p:spPr>
-          <a:xfrm xmlns:a="http://schemas.openxmlformats.org/drawingml/2006/main">
-            <a:off x="8572500" y="2305050"/>
-            <a:ext cx="2905125" cy="666750"/>
+          <p:cNvPr id="11" name="">
+            <a:extLst xmlns:a="http://schemas.openxmlformats.org/drawingml/2006/main">
+              <a:ext uri="{FF2B5EF4-FFF2-40B4-BE49-F238E27FC236}">
+                <a16:creationId xmlns:a16="http://schemas.microsoft.com/office/drawing/2014/main" id="{EC9935E1-53EF-4BB9-918A-09E820CD0DEB}"/>
+              </a:ext>
+            </a:extLst>
+          </p:cNvPr>
+          <p:cNvSpPr>
+            <a:spLocks xmlns:a="http://schemas.openxmlformats.org/drawingml/2006/main" noGrp="1"/>
+          </p:cNvSpPr>
+          <p:nvPr/>
+        </p:nvSpPr>
+        <p:spPr>
+          <a:xfrm xmlns:a="http://schemas.openxmlformats.org/drawingml/2006/main">
+            <a:off x="2619375" y="3533775"/>
+            <a:ext cx="8477250" cy="361950"/>
           </a:xfrm>
           <a:prstGeom xmlns:a="http://schemas.openxmlformats.org/drawingml/2006/main" prst="rect">
             <a:avLst/>
@@ -12600,60 +12399,29 @@
                 <a:ea typeface="Nimbus Sans"/>
                 <a:cs typeface="Nimbus Sans"/>
               </a:rPr>
-              <a:t>Supervised pilot</a:t>
-            </a:r>
-          </a:p>
-        </p:txBody>
-      </p:sp>
-      <p:sp>
-        <p:nvSpPr>
-          <p:cNvPr id="19" name="">
-            <a:extLst xmlns:a="http://schemas.openxmlformats.org/drawingml/2006/main">
-              <a:ext uri="{FF2B5EF4-FFF2-40B4-BE49-F238E27FC236}">
-                <a16:creationId xmlns:a16="http://schemas.microsoft.com/office/drawing/2014/main" id="{EF091BF7-DF41-4B1D-89E0-F97552A23ECE}"/>
-              </a:ext>
-            </a:extLst>
-          </p:cNvPr>
-          <p:cNvSpPr>
-            <a:spLocks xmlns:a="http://schemas.openxmlformats.org/drawingml/2006/main" noGrp="1"/>
-          </p:cNvSpPr>
-          <p:nvPr/>
-        </p:nvSpPr>
-        <p:spPr>
-          <a:xfrm xmlns:a="http://schemas.openxmlformats.org/drawingml/2006/main">
-            <a:off x="8572500" y="3105150"/>
-            <a:ext cx="2905125" cy="0"/>
-          </a:xfrm>
-          <a:prstGeom xmlns:a="http://schemas.openxmlformats.org/drawingml/2006/main" prst="line">
-            <a:avLst/>
-          </a:prstGeom>
-          <a:noFill xmlns:a="http://schemas.openxmlformats.org/drawingml/2006/main"/>
-          <a:ln xmlns:a="http://schemas.openxmlformats.org/drawingml/2006/main" w="28575">
-            <a:solidFill>
-              <a:srgbClr val="E76F51"/>
-            </a:solidFill>
-            <a:prstDash val="solid"/>
-          </a:ln>
-        </p:spPr>
-      </p:sp>
-      <p:sp>
-        <p:nvSpPr>
-          <p:cNvPr id="20" name="">
-            <a:extLst xmlns:a="http://schemas.openxmlformats.org/drawingml/2006/main">
-              <a:ext uri="{FF2B5EF4-FFF2-40B4-BE49-F238E27FC236}">
-                <a16:creationId xmlns:a16="http://schemas.microsoft.com/office/drawing/2014/main" id="{53FA6AA8-AC92-451A-A3CA-80B937E052B5}"/>
-              </a:ext>
-            </a:extLst>
-          </p:cNvPr>
-          <p:cNvSpPr>
-            <a:spLocks xmlns:a="http://schemas.openxmlformats.org/drawingml/2006/main" noGrp="1"/>
-          </p:cNvSpPr>
-          <p:nvPr/>
-        </p:nvSpPr>
-        <p:spPr>
-          <a:xfrm xmlns:a="http://schemas.openxmlformats.org/drawingml/2006/main">
-            <a:off x="8572500" y="3333750"/>
-            <a:ext cx="2905125" cy="1333500"/>
+              <a:t>Conditional supervised study</a:t>
+            </a:r>
+          </a:p>
+        </p:txBody>
+      </p:sp>
+      <p:sp>
+        <p:nvSpPr>
+          <p:cNvPr id="12" name="">
+            <a:extLst xmlns:a="http://schemas.openxmlformats.org/drawingml/2006/main">
+              <a:ext uri="{FF2B5EF4-FFF2-40B4-BE49-F238E27FC236}">
+                <a16:creationId xmlns:a16="http://schemas.microsoft.com/office/drawing/2014/main" id="{8EE8EA37-B68E-4A2B-8301-67B2C20CCDF7}"/>
+              </a:ext>
+            </a:extLst>
+          </p:cNvPr>
+          <p:cNvSpPr>
+            <a:spLocks xmlns:a="http://schemas.openxmlformats.org/drawingml/2006/main" noGrp="1"/>
+          </p:cNvSpPr>
+          <p:nvPr/>
+        </p:nvSpPr>
+        <p:spPr>
+          <a:xfrm xmlns:a="http://schemas.openxmlformats.org/drawingml/2006/main">
+            <a:off x="2619375" y="3943350"/>
+            <a:ext cx="8477250" cy="381000"/>
           </a:xfrm>
           <a:prstGeom xmlns:a="http://schemas.openxmlformats.org/drawingml/2006/main" prst="rect">
             <a:avLst/>
@@ -12671,7 +12439,7 @@
           <a:lstStyle xmlns:a="http://schemas.openxmlformats.org/drawingml/2006/main"/>
           <a:p xmlns:a="http://schemas.openxmlformats.org/drawingml/2006/main">
             <a:pPr algn="l">
-              <a:defRPr sz="1425" b="0" i="0">
+              <a:defRPr sz="1650" b="0" i="0">
                 <a:solidFill>
                   <a:srgbClr val="243B53"/>
                 </a:solidFill>
@@ -12681,7 +12449,7 @@
               </a:defRPr>
             </a:pPr>
             <a:r>
-              <a:rPr sz="1425" b="0" i="0">
+              <a:rPr sz="1650" b="0" i="0">
                 <a:solidFill>
                   <a:srgbClr val="243B53"/>
                 </a:solidFill>
@@ -12689,29 +12457,29 @@
                 <a:ea typeface="Nimbus Sans"/>
                 <a:cs typeface="Nimbus Sans"/>
               </a:rPr>
-              <a:t>Show alerts only if prior gates pass. Record review time, action, overrides, safety, and patient outcomes</a:t>
-            </a:r>
-          </a:p>
-        </p:txBody>
-      </p:sp>
-      <p:sp>
-        <p:nvSpPr>
-          <p:cNvPr id="21" name="">
-            <a:extLst xmlns:a="http://schemas.openxmlformats.org/drawingml/2006/main">
-              <a:ext uri="{FF2B5EF4-FFF2-40B4-BE49-F238E27FC236}">
-                <a16:creationId xmlns:a16="http://schemas.microsoft.com/office/drawing/2014/main" id="{DAFAF7F7-116D-41BE-AB59-3777CA71B010}"/>
-              </a:ext>
-            </a:extLst>
-          </p:cNvPr>
-          <p:cNvSpPr>
-            <a:spLocks xmlns:a="http://schemas.openxmlformats.org/drawingml/2006/main" noGrp="1"/>
-          </p:cNvSpPr>
-          <p:nvPr/>
-        </p:nvSpPr>
-        <p:spPr>
-          <a:xfrm xmlns:a="http://schemas.openxmlformats.org/drawingml/2006/main">
-            <a:off x="8572500" y="4876800"/>
-            <a:ext cx="2905125" cy="590550"/>
+              <a:t>Proceed only after agreed safety and governance gates</a:t>
+            </a:r>
+          </a:p>
+        </p:txBody>
+      </p:sp>
+      <p:sp>
+        <p:nvSpPr>
+          <p:cNvPr id="13" name="">
+            <a:extLst xmlns:a="http://schemas.openxmlformats.org/drawingml/2006/main">
+              <a:ext uri="{FF2B5EF4-FFF2-40B4-BE49-F238E27FC236}">
+                <a16:creationId xmlns:a16="http://schemas.microsoft.com/office/drawing/2014/main" id="{3E440BB8-18E6-46B2-8E8C-56D7D11536F4}"/>
+              </a:ext>
+            </a:extLst>
+          </p:cNvPr>
+          <p:cNvSpPr>
+            <a:spLocks xmlns:a="http://schemas.openxmlformats.org/drawingml/2006/main" noGrp="1"/>
+          </p:cNvSpPr>
+          <p:nvPr/>
+        </p:nvSpPr>
+        <p:spPr>
+          <a:xfrm xmlns:a="http://schemas.openxmlformats.org/drawingml/2006/main">
+            <a:off x="762000" y="4714875"/>
+            <a:ext cx="10477500" cy="361950"/>
           </a:xfrm>
           <a:prstGeom xmlns:a="http://schemas.openxmlformats.org/drawingml/2006/main" prst="rect">
             <a:avLst/>
@@ -12729,47 +12497,47 @@
           <a:lstStyle xmlns:a="http://schemas.openxmlformats.org/drawingml/2006/main"/>
           <a:p xmlns:a="http://schemas.openxmlformats.org/drawingml/2006/main">
             <a:pPr algn="l">
-              <a:defRPr sz="1350" b="1" i="0">
-                <a:solidFill>
-                  <a:srgbClr val="B23A48"/>
-                </a:solidFill>
-                <a:latin typeface="Nimbus Sans"/>
-                <a:ea typeface="Nimbus Sans"/>
-                <a:cs typeface="Nimbus Sans"/>
-              </a:defRPr>
-            </a:pPr>
-            <a:r>
-              <a:rPr sz="1350" b="1" i="0">
-                <a:solidFill>
-                  <a:srgbClr val="B23A48"/>
-                </a:solidFill>
-                <a:latin typeface="Nimbus Sans"/>
-                <a:ea typeface="Nimbus Sans"/>
-                <a:cs typeface="Nimbus Sans"/>
-              </a:rPr>
-              <a:t>Gate: benefit warrants a larger evaluation</a:t>
-            </a:r>
-          </a:p>
-        </p:txBody>
-      </p:sp>
-      <p:sp>
-        <p:nvSpPr>
-          <p:cNvPr id="22" name="">
-            <a:extLst xmlns:a="http://schemas.openxmlformats.org/drawingml/2006/main">
-              <a:ext uri="{FF2B5EF4-FFF2-40B4-BE49-F238E27FC236}">
-                <a16:creationId xmlns:a16="http://schemas.microsoft.com/office/drawing/2014/main" id="{813739DF-D092-4A04-8810-727DAED779D9}"/>
-              </a:ext>
-            </a:extLst>
-          </p:cNvPr>
-          <p:cNvSpPr>
-            <a:spLocks xmlns:a="http://schemas.openxmlformats.org/drawingml/2006/main" noGrp="1"/>
-          </p:cNvSpPr>
-          <p:nvPr/>
-        </p:nvSpPr>
-        <p:spPr>
-          <a:xfrm xmlns:a="http://schemas.openxmlformats.org/drawingml/2006/main">
-            <a:off x="742950" y="5905500"/>
-            <a:ext cx="10668000" cy="323850"/>
+              <a:defRPr sz="1875" b="1" i="0">
+                <a:solidFill>
+                  <a:srgbClr val="0E7C7B"/>
+                </a:solidFill>
+                <a:latin typeface="Nimbus Sans"/>
+                <a:ea typeface="Nimbus Sans"/>
+                <a:cs typeface="Nimbus Sans"/>
+              </a:defRPr>
+            </a:pPr>
+            <a:r>
+              <a:rPr sz="1875" b="1" i="0">
+                <a:solidFill>
+                  <a:srgbClr val="0E7C7B"/>
+                </a:solidFill>
+                <a:latin typeface="Nimbus Sans"/>
+                <a:ea typeface="Nimbus Sans"/>
+                <a:cs typeface="Nimbus Sans"/>
+              </a:rPr>
+              <a:t>Draft targets for a future fixed-threshold evaluation</a:t>
+            </a:r>
+          </a:p>
+        </p:txBody>
+      </p:sp>
+      <p:sp>
+        <p:nvSpPr>
+          <p:cNvPr id="14" name="">
+            <a:extLst xmlns:a="http://schemas.openxmlformats.org/drawingml/2006/main">
+              <a:ext uri="{FF2B5EF4-FFF2-40B4-BE49-F238E27FC236}">
+                <a16:creationId xmlns:a16="http://schemas.microsoft.com/office/drawing/2014/main" id="{24522E40-0056-4FA0-AC59-8B71EE7E036A}"/>
+              </a:ext>
+            </a:extLst>
+          </p:cNvPr>
+          <p:cNvSpPr>
+            <a:spLocks xmlns:a="http://schemas.openxmlformats.org/drawingml/2006/main" noGrp="1"/>
+          </p:cNvSpPr>
+          <p:nvPr/>
+        </p:nvSpPr>
+        <p:spPr>
+          <a:xfrm xmlns:a="http://schemas.openxmlformats.org/drawingml/2006/main">
+            <a:off x="762000" y="5162550"/>
+            <a:ext cx="10477500" cy="342900"/>
           </a:xfrm>
           <a:prstGeom xmlns:a="http://schemas.openxmlformats.org/drawingml/2006/main" prst="rect">
             <a:avLst/>
@@ -12786,8 +12554,8 @@
           </a:bodyPr>
           <a:lstStyle xmlns:a="http://schemas.openxmlformats.org/drawingml/2006/main"/>
           <a:p xmlns:a="http://schemas.openxmlformats.org/drawingml/2006/main">
-            <a:pPr algn="ctr">
-              <a:defRPr sz="1650" b="1" i="0">
+            <a:pPr algn="l">
+              <a:defRPr sz="1725" b="0" i="0">
                 <a:solidFill>
                   <a:srgbClr val="102A43"/>
                 </a:solidFill>
@@ -12797,7 +12565,7 @@
               </a:defRPr>
             </a:pPr>
             <a:r>
-              <a:rPr sz="1650" b="1" i="0">
+              <a:rPr sz="1725" b="0" i="0">
                 <a:solidFill>
                   <a:srgbClr val="102A43"/>
                 </a:solidFill>
@@ -12805,17 +12573,133 @@
                 <a:ea typeface="Nimbus Sans"/>
                 <a:cs typeface="Nimbus Sans"/>
               </a:rPr>
-              <a:t>Pre-register performance, workload, equity, and safety criteria before the pilot begins.</a:t>
-            </a:r>
-          </a:p>
-        </p:txBody>
-      </p:sp>
-      <p:sp>
-        <p:nvSpPr>
-          <p:cNvPr id="23" name="">
-            <a:extLst xmlns:a="http://schemas.openxmlformats.org/drawingml/2006/main">
-              <a:ext uri="{FF2B5EF4-FFF2-40B4-BE49-F238E27FC236}">
-                <a16:creationId xmlns:a16="http://schemas.microsoft.com/office/drawing/2014/main" id="{7736A1DA-2EA8-46EF-9A25-FB253F715586}"/>
+              <a:t>Sensitivity ≥65%, ≤20 alerts and ≤15 false alerts per 100 sessions</a:t>
+            </a:r>
+          </a:p>
+        </p:txBody>
+      </p:sp>
+      <p:sp>
+        <p:nvSpPr>
+          <p:cNvPr id="15" name="">
+            <a:extLst xmlns:a="http://schemas.openxmlformats.org/drawingml/2006/main">
+              <a:ext uri="{FF2B5EF4-FFF2-40B4-BE49-F238E27FC236}">
+                <a16:creationId xmlns:a16="http://schemas.microsoft.com/office/drawing/2014/main" id="{320D0578-5437-4A4E-A880-B0D063943CAF}"/>
+              </a:ext>
+            </a:extLst>
+          </p:cNvPr>
+          <p:cNvSpPr>
+            <a:spLocks xmlns:a="http://schemas.openxmlformats.org/drawingml/2006/main" noGrp="1"/>
+          </p:cNvSpPr>
+          <p:nvPr/>
+        </p:nvSpPr>
+        <p:spPr>
+          <a:xfrm xmlns:a="http://schemas.openxmlformats.org/drawingml/2006/main">
+            <a:off x="762000" y="5543550"/>
+            <a:ext cx="10668000" cy="476250"/>
+          </a:xfrm>
+          <a:prstGeom xmlns:a="http://schemas.openxmlformats.org/drawingml/2006/main" prst="rect">
+            <a:avLst/>
+          </a:prstGeom>
+          <a:noFill xmlns:a="http://schemas.openxmlformats.org/drawingml/2006/main"/>
+          <a:ln xmlns:a="http://schemas.openxmlformats.org/drawingml/2006/main" w="0">
+            <a:noFill/>
+            <a:prstDash val="solid"/>
+          </a:ln>
+        </p:spPr>
+        <p:txBody>
+          <a:bodyPr xmlns:a="http://schemas.openxmlformats.org/drawingml/2006/main" wrap="square" lIns="0" tIns="0" rIns="0" bIns="0" anchor="t">
+            <a:noAutofit/>
+          </a:bodyPr>
+          <a:lstStyle xmlns:a="http://schemas.openxmlformats.org/drawingml/2006/main"/>
+          <a:p xmlns:a="http://schemas.openxmlformats.org/drawingml/2006/main">
+            <a:pPr algn="l">
+              <a:defRPr sz="1650" b="0" i="0">
+                <a:solidFill>
+                  <a:srgbClr val="243B53"/>
+                </a:solidFill>
+                <a:latin typeface="Nimbus Sans"/>
+                <a:ea typeface="Nimbus Sans"/>
+                <a:cs typeface="Nimbus Sans"/>
+              </a:defRPr>
+            </a:pPr>
+            <a:r>
+              <a:rPr sz="1650" b="0" i="0">
+                <a:solidFill>
+                  <a:srgbClr val="243B53"/>
+                </a:solidFill>
+                <a:latin typeface="Nimbus Sans"/>
+                <a:ea typeface="Nimbus Sans"/>
+                <a:cs typeface="Nimbus Sans"/>
+              </a:rPr>
+              <a:t>Median active review ≤2 min per alert; local approval and uncertainty review required</a:t>
+            </a:r>
+          </a:p>
+        </p:txBody>
+      </p:sp>
+      <p:sp>
+        <p:nvSpPr>
+          <p:cNvPr id="16" name="">
+            <a:extLst xmlns:a="http://schemas.openxmlformats.org/drawingml/2006/main">
+              <a:ext uri="{FF2B5EF4-FFF2-40B4-BE49-F238E27FC236}">
+                <a16:creationId xmlns:a16="http://schemas.microsoft.com/office/drawing/2014/main" id="{9E12C2A4-8B85-4714-BD09-48459286201F}"/>
+              </a:ext>
+            </a:extLst>
+          </p:cNvPr>
+          <p:cNvSpPr>
+            <a:spLocks xmlns:a="http://schemas.openxmlformats.org/drawingml/2006/main" noGrp="1"/>
+          </p:cNvSpPr>
+          <p:nvPr/>
+        </p:nvSpPr>
+        <p:spPr>
+          <a:xfrm xmlns:a="http://schemas.openxmlformats.org/drawingml/2006/main">
+            <a:off x="552450" y="6229350"/>
+            <a:ext cx="10668000" cy="200025"/>
+          </a:xfrm>
+          <a:prstGeom xmlns:a="http://schemas.openxmlformats.org/drawingml/2006/main" prst="rect">
+            <a:avLst/>
+          </a:prstGeom>
+          <a:noFill xmlns:a="http://schemas.openxmlformats.org/drawingml/2006/main"/>
+          <a:ln xmlns:a="http://schemas.openxmlformats.org/drawingml/2006/main" w="0">
+            <a:noFill/>
+            <a:prstDash val="solid"/>
+          </a:ln>
+        </p:spPr>
+        <p:txBody>
+          <a:bodyPr xmlns:a="http://schemas.openxmlformats.org/drawingml/2006/main" wrap="square" lIns="0" tIns="0" rIns="0" bIns="0" anchor="t">
+            <a:noAutofit/>
+          </a:bodyPr>
+          <a:lstStyle xmlns:a="http://schemas.openxmlformats.org/drawingml/2006/main"/>
+          <a:p xmlns:a="http://schemas.openxmlformats.org/drawingml/2006/main">
+            <a:pPr algn="l">
+              <a:defRPr sz="975" b="0" i="1">
+                <a:solidFill>
+                  <a:srgbClr val="627D98"/>
+                </a:solidFill>
+                <a:latin typeface="Nimbus Sans"/>
+                <a:ea typeface="Nimbus Sans"/>
+                <a:cs typeface="Nimbus Sans"/>
+              </a:defRPr>
+            </a:pPr>
+            <a:r>
+              <a:rPr sz="975" b="0" i="1">
+                <a:solidFill>
+                  <a:srgbClr val="627D98"/>
+                </a:solidFill>
+                <a:latin typeface="Nimbus Sans"/>
+                <a:ea typeface="Nimbus Sans"/>
+                <a:cs typeface="Nimbus Sans"/>
+              </a:rPr>
+              <a:t>Post-study proposals, not achieved results or approved standards; docs/evaluation_protocol.md</a:t>
+            </a:r>
+          </a:p>
+        </p:txBody>
+      </p:sp>
+      <p:sp>
+        <p:nvSpPr>
+          <p:cNvPr id="17" name="">
+            <a:extLst xmlns:a="http://schemas.openxmlformats.org/drawingml/2006/main">
+              <a:ext uri="{FF2B5EF4-FFF2-40B4-BE49-F238E27FC236}">
+                <a16:creationId xmlns:a16="http://schemas.microsoft.com/office/drawing/2014/main" id="{E7855972-2ECA-4330-A2E4-336A1F7897CD}"/>
               </a:ext>
             </a:extLst>
           </p:cNvPr>
@@ -12843,10 +12727,10 @@
       </p:sp>
       <p:sp>
         <p:nvSpPr>
-          <p:cNvPr id="24" name="">
-            <a:extLst xmlns:a="http://schemas.openxmlformats.org/drawingml/2006/main">
-              <a:ext uri="{FF2B5EF4-FFF2-40B4-BE49-F238E27FC236}">
-                <a16:creationId xmlns:a16="http://schemas.microsoft.com/office/drawing/2014/main" id="{AA42C59D-CBD6-4FBD-922B-FC2B276A9FFE}"/>
+          <p:cNvPr id="18" name="">
+            <a:extLst xmlns:a="http://schemas.openxmlformats.org/drawingml/2006/main">
+              <a:ext uri="{FF2B5EF4-FFF2-40B4-BE49-F238E27FC236}">
+                <a16:creationId xmlns:a16="http://schemas.microsoft.com/office/drawing/2014/main" id="{DF9CF2BF-FEF4-49CF-BEF8-CD2ACBE3A95C}"/>
               </a:ext>
             </a:extLst>
           </p:cNvPr>
@@ -12902,7 +12786,7 @@
     </p:spTree>
     <p:extLst>
       <p:ext uri="{BB962C8B-B14F-4D97-AF65-F5344CB8AC3E}">
-        <p14:creationId xmlns:p14="http://schemas.microsoft.com/office/powerpoint/2010/main" val="499903251"/>
+        <p14:creationId xmlns:p14="http://schemas.microsoft.com/office/powerpoint/2010/main" val="1046665764"/>
       </p:ext>
     </p:extLst>
   </p:cSld>

</xml_diff>

<commit_message>
Align submission reports and slides and verify local inference
</commit_message>
<xml_diff>
--- a/reports/Franklin_Guillano_DIAL_ALERT_Business_Presentation.pptx
+++ b/reports/Franklin_Guillano_DIAL_ALERT_Business_Presentation.pptx
@@ -17,6 +17,7 @@
     <p:sldId xmlns:r="http://schemas.openxmlformats.org/officeDocument/2006/relationships" id="262" r:id="R4fd89c71c3ca4a23"/>
     <p:sldId xmlns:r="http://schemas.openxmlformats.org/officeDocument/2006/relationships" id="263" r:id="R08ed60c549c34f0d"/>
     <p:sldId xmlns:r="http://schemas.openxmlformats.org/officeDocument/2006/relationships" id="264" r:id="R3c38607a5d2548f6"/>
+    <p:sldId xmlns:ns0="http://schemas.openxmlformats.org/officeDocument/2006/relationships" id="266" ns0:id="rId16"/>
     <p:sldId xmlns:r="http://schemas.openxmlformats.org/officeDocument/2006/relationships" id="265" r:id="Rcecb6e3d1b4949e8"/>
   </p:sldIdLst>
   <p:sldSz cx="12192000" cy="6858000"/>
@@ -2220,6 +2221,10 @@
             <a:prstDash val="solid"/>
           </a:ln>
         </p:spPr>
+        <p:txBody xmlns:a="http://schemas.openxmlformats.org/drawingml/2006/main">
+          <a:bodyPr/>
+          <a:p/>
+        </p:txBody>
       </p:sp>
       <p:sp>
         <p:nvSpPr>
@@ -2448,6 +2453,10 @@
             <a:prstDash val="solid"/>
           </a:ln>
         </p:spPr>
+        <p:txBody xmlns:a="http://schemas.openxmlformats.org/drawingml/2006/main">
+          <a:bodyPr/>
+          <a:p/>
+        </p:txBody>
       </p:sp>
       <p:sp>
         <p:nvSpPr>
@@ -2641,6 +2650,10 @@
             <a:prstDash val="solid"/>
           </a:ln>
         </p:spPr>
+        <p:txBody xmlns:a="http://schemas.openxmlformats.org/drawingml/2006/main">
+          <a:bodyPr/>
+          <a:p/>
+        </p:txBody>
       </p:sp>
       <p:sp>
         <p:nvSpPr>
@@ -2695,7 +2708,7 @@
                 <a:ea typeface="Nimbus Sans"/>
                 <a:cs typeface="Nimbus Sans"/>
               </a:rPr>
-              <a:t>DIAL-ALERT executive presentation  /  01</a:t>
+              <a:t>DIAL-ALERT business presentation  /  01</a:t>
             </a:r>
           </a:p>
         </p:txBody>
@@ -2759,6 +2772,10 @@
             <a:prstDash val="solid"/>
           </a:ln>
         </p:spPr>
+        <p:txBody xmlns:a="http://schemas.openxmlformats.org/drawingml/2006/main">
+          <a:bodyPr/>
+          <a:p/>
+        </p:txBody>
       </p:sp>
       <p:sp>
         <p:nvSpPr>
@@ -2964,6 +2981,10 @@
             <a:prstDash val="solid"/>
           </a:ln>
         </p:spPr>
+        <p:txBody xmlns:a="http://schemas.openxmlformats.org/drawingml/2006/main">
+          <a:bodyPr/>
+          <a:p/>
+        </p:txBody>
       </p:sp>
       <p:sp>
         <p:nvSpPr>
@@ -3053,6 +3074,10 @@
             <a:prstDash val="solid"/>
           </a:ln>
         </p:spPr>
+        <p:txBody xmlns:a="http://schemas.openxmlformats.org/drawingml/2006/main">
+          <a:bodyPr/>
+          <a:p/>
+        </p:txBody>
       </p:sp>
       <p:sp>
         <p:nvSpPr>
@@ -3142,6 +3167,10 @@
             <a:prstDash val="solid"/>
           </a:ln>
         </p:spPr>
+        <p:txBody xmlns:a="http://schemas.openxmlformats.org/drawingml/2006/main">
+          <a:bodyPr/>
+          <a:p/>
+        </p:txBody>
       </p:sp>
       <p:sp>
         <p:nvSpPr>
@@ -3231,6 +3260,10 @@
             <a:prstDash val="solid"/>
           </a:ln>
         </p:spPr>
+        <p:txBody xmlns:a="http://schemas.openxmlformats.org/drawingml/2006/main">
+          <a:bodyPr/>
+          <a:p/>
+        </p:txBody>
       </p:sp>
       <p:sp>
         <p:nvSpPr>
@@ -3320,6 +3353,10 @@
             <a:prstDash val="solid"/>
           </a:ln>
         </p:spPr>
+        <p:txBody xmlns:a="http://schemas.openxmlformats.org/drawingml/2006/main">
+          <a:bodyPr/>
+          <a:p/>
+        </p:txBody>
       </p:sp>
       <p:sp>
         <p:nvSpPr>
@@ -3409,6 +3446,10 @@
             <a:prstDash val="solid"/>
           </a:ln>
         </p:spPr>
+        <p:txBody xmlns:a="http://schemas.openxmlformats.org/drawingml/2006/main">
+          <a:bodyPr/>
+          <a:p/>
+        </p:txBody>
       </p:sp>
       <p:sp>
         <p:nvSpPr>
@@ -3498,6 +3539,10 @@
             <a:prstDash val="solid"/>
           </a:ln>
         </p:spPr>
+        <p:txBody xmlns:a="http://schemas.openxmlformats.org/drawingml/2006/main">
+          <a:bodyPr/>
+          <a:p/>
+        </p:txBody>
       </p:sp>
       <p:sp>
         <p:nvSpPr>
@@ -3587,6 +3632,10 @@
             <a:prstDash val="solid"/>
           </a:ln>
         </p:spPr>
+        <p:txBody xmlns:a="http://schemas.openxmlformats.org/drawingml/2006/main">
+          <a:bodyPr/>
+          <a:p/>
+        </p:txBody>
       </p:sp>
       <p:sp>
         <p:nvSpPr>
@@ -3676,6 +3725,10 @@
             <a:prstDash val="solid"/>
           </a:ln>
         </p:spPr>
+        <p:txBody xmlns:a="http://schemas.openxmlformats.org/drawingml/2006/main">
+          <a:bodyPr/>
+          <a:p/>
+        </p:txBody>
       </p:sp>
       <p:sp>
         <p:nvSpPr>
@@ -3765,6 +3818,10 @@
             <a:prstDash val="solid"/>
           </a:ln>
         </p:spPr>
+        <p:txBody xmlns:a="http://schemas.openxmlformats.org/drawingml/2006/main">
+          <a:bodyPr/>
+          <a:p/>
+        </p:txBody>
       </p:sp>
       <p:sp>
         <p:nvSpPr>
@@ -3854,6 +3911,10 @@
             <a:prstDash val="solid"/>
           </a:ln>
         </p:spPr>
+        <p:txBody xmlns:a="http://schemas.openxmlformats.org/drawingml/2006/main">
+          <a:bodyPr/>
+          <a:p/>
+        </p:txBody>
       </p:sp>
       <p:sp>
         <p:nvSpPr>
@@ -3908,7 +3969,7 @@
                 <a:ea typeface="Nimbus Sans"/>
                 <a:cs typeface="Nimbus Sans"/>
               </a:rPr>
-              <a:t>DIAL-ALERT executive presentation  /  10</a:t>
+              <a:t>DIAL-ALERT business presentation  /  11</a:t>
             </a:r>
           </a:p>
         </p:txBody>
@@ -3920,6 +3981,338 @@
       </p:ext>
     </p:extLst>
   </p:cSld>
+</p:sld>
+</file>
+
+<file path=ppt/slides/slide11.xml><?xml version="1.0" encoding="utf-8"?>
+<p:sld xmlns:a="http://schemas.openxmlformats.org/drawingml/2006/main" xmlns:p="http://schemas.openxmlformats.org/presentationml/2006/main" xmlns:r="http://schemas.openxmlformats.org/officeDocument/2006/relationships">
+  <p:cSld>
+    <p:bg>
+      <p:bgPr>
+        <a:solidFill>
+          <a:srgbClr val="F7F5EF"/>
+        </a:solidFill>
+        <a:effectLst/>
+      </p:bgPr>
+    </p:bg>
+    <p:spTree>
+      <p:nvGrpSpPr>
+        <p:cNvPr id="1" name=""/>
+        <p:cNvGrpSpPr/>
+        <p:nvPr/>
+      </p:nvGrpSpPr>
+      <p:grpSpPr/>
+      <p:sp>
+        <p:nvSpPr>
+          <p:cNvPr id="2" name="TextBox 1"/>
+          <p:cNvSpPr txBox="1"/>
+          <p:nvPr/>
+        </p:nvSpPr>
+        <p:spPr>
+          <a:xfrm>
+            <a:off x="777240" y="320040"/>
+            <a:ext cx="10698480" cy="594360"/>
+          </a:xfrm>
+          <a:prstGeom prst="rect">
+            <a:avLst/>
+          </a:prstGeom>
+          <a:noFill/>
+        </p:spPr>
+        <p:txBody>
+          <a:bodyPr wrap="square" lIns="0" rIns="0">
+            <a:spAutoFit/>
+          </a:bodyPr>
+          <a:lstStyle/>
+          <a:p>
+            <a:r>
+              <a:rPr sz="2900" b="1">
+                <a:solidFill>
+                  <a:srgbClr val="102A43"/>
+                </a:solidFill>
+                <a:latin typeface="Nimbus Sans"/>
+              </a:rPr>
+              <a:t>Proposed pilot targets are not results</a:t>
+            </a:r>
+          </a:p>
+        </p:txBody>
+      </p:sp>
+      <p:sp>
+        <p:nvSpPr>
+          <p:cNvPr id="3" name="TextBox 2"/>
+          <p:cNvSpPr txBox="1"/>
+          <p:nvPr/>
+        </p:nvSpPr>
+        <p:spPr>
+          <a:xfrm>
+            <a:off x="777240" y="987552"/>
+            <a:ext cx="10698480" cy="502920"/>
+          </a:xfrm>
+          <a:prstGeom prst="rect">
+            <a:avLst/>
+          </a:prstGeom>
+          <a:noFill/>
+        </p:spPr>
+        <p:txBody>
+          <a:bodyPr wrap="square" lIns="0" rIns="0">
+            <a:spAutoFit/>
+          </a:bodyPr>
+          <a:lstStyle/>
+          <a:p>
+            <a:r>
+              <a:rPr sz="1600" b="0">
+                <a:solidFill>
+                  <a:srgbClr val="627D98"/>
+                </a:solidFill>
+                <a:latin typeface="Nimbus Sans"/>
+              </a:rPr>
+              <a:t>Prespecify one alert policy and local safety stopping rules</a:t>
+            </a:r>
+          </a:p>
+        </p:txBody>
+      </p:sp>
+      <p:sp>
+        <p:nvSpPr>
+          <p:cNvPr id="4" name="TextBox 3"/>
+          <p:cNvSpPr txBox="1"/>
+          <p:nvPr/>
+        </p:nvSpPr>
+        <p:spPr>
+          <a:xfrm>
+            <a:off x="777240" y="1783080"/>
+            <a:ext cx="10515600" cy="384048"/>
+          </a:xfrm>
+          <a:prstGeom prst="rect">
+            <a:avLst/>
+          </a:prstGeom>
+          <a:noFill/>
+        </p:spPr>
+        <p:txBody>
+          <a:bodyPr wrap="square" lIns="0" rIns="0">
+            <a:spAutoFit/>
+          </a:bodyPr>
+          <a:lstStyle/>
+          <a:p>
+            <a:r>
+              <a:rPr sz="2100" b="1">
+                <a:solidFill>
+                  <a:srgbClr val="0E7C7B"/>
+                </a:solidFill>
+                <a:latin typeface="Nimbus Sans"/>
+              </a:rPr>
+              <a:t>Event detection</a:t>
+            </a:r>
+          </a:p>
+        </p:txBody>
+      </p:sp>
+      <p:sp>
+        <p:nvSpPr>
+          <p:cNvPr id="5" name="TextBox 4"/>
+          <p:cNvSpPr txBox="1"/>
+          <p:nvPr/>
+        </p:nvSpPr>
+        <p:spPr>
+          <a:xfrm>
+            <a:off x="777240" y="2221991"/>
+            <a:ext cx="10515600" cy="749808"/>
+          </a:xfrm>
+          <a:prstGeom prst="rect">
+            <a:avLst/>
+          </a:prstGeom>
+          <a:noFill/>
+        </p:spPr>
+        <p:txBody>
+          <a:bodyPr wrap="square" lIns="0" rIns="0">
+            <a:spAutoFit/>
+          </a:bodyPr>
+          <a:lstStyle/>
+          <a:p>
+            <a:r>
+              <a:rPr sz="2000" b="0">
+                <a:solidFill>
+                  <a:srgbClr val="102A43"/>
+                </a:solidFill>
+                <a:latin typeface="Nimbus Sans"/>
+              </a:rPr>
+              <a:t>At least 65% of later SBP-below-90 events detected in eligible sessions.</a:t>
+            </a:r>
+          </a:p>
+        </p:txBody>
+      </p:sp>
+      <p:sp>
+        <p:nvSpPr>
+          <p:cNvPr id="6" name="TextBox 5"/>
+          <p:cNvSpPr txBox="1"/>
+          <p:nvPr/>
+        </p:nvSpPr>
+        <p:spPr>
+          <a:xfrm>
+            <a:off x="777240" y="3200400"/>
+            <a:ext cx="10515600" cy="384048"/>
+          </a:xfrm>
+          <a:prstGeom prst="rect">
+            <a:avLst/>
+          </a:prstGeom>
+          <a:noFill/>
+        </p:spPr>
+        <p:txBody>
+          <a:bodyPr wrap="square" lIns="0" rIns="0">
+            <a:spAutoFit/>
+          </a:bodyPr>
+          <a:lstStyle/>
+          <a:p>
+            <a:r>
+              <a:rPr sz="2100" b="1">
+                <a:solidFill>
+                  <a:srgbClr val="0E7C7B"/>
+                </a:solidFill>
+                <a:latin typeface="Nimbus Sans"/>
+              </a:rPr>
+              <a:t>False-alert workload</a:t>
+            </a:r>
+          </a:p>
+        </p:txBody>
+      </p:sp>
+      <p:sp>
+        <p:nvSpPr>
+          <p:cNvPr id="7" name="TextBox 6"/>
+          <p:cNvSpPr txBox="1"/>
+          <p:nvPr/>
+        </p:nvSpPr>
+        <p:spPr>
+          <a:xfrm>
+            <a:off x="777240" y="3639312"/>
+            <a:ext cx="10515600" cy="749808"/>
+          </a:xfrm>
+          <a:prstGeom prst="rect">
+            <a:avLst/>
+          </a:prstGeom>
+          <a:noFill/>
+        </p:spPr>
+        <p:txBody>
+          <a:bodyPr wrap="square" lIns="0" rIns="0">
+            <a:spAutoFit/>
+          </a:bodyPr>
+          <a:lstStyle/>
+          <a:p>
+            <a:r>
+              <a:rPr sz="2000" b="0">
+                <a:solidFill>
+                  <a:srgbClr val="102A43"/>
+                </a:solidFill>
+                <a:latin typeface="Nimbus Sans"/>
+              </a:rPr>
+              <a:t>No more than 15 false alerts per 100 eligible sessions.</a:t>
+            </a:r>
+          </a:p>
+        </p:txBody>
+      </p:sp>
+      <p:sp>
+        <p:nvSpPr>
+          <p:cNvPr id="8" name="TextBox 7"/>
+          <p:cNvSpPr txBox="1"/>
+          <p:nvPr/>
+        </p:nvSpPr>
+        <p:spPr>
+          <a:xfrm>
+            <a:off x="777240" y="4617720"/>
+            <a:ext cx="10515600" cy="384048"/>
+          </a:xfrm>
+          <a:prstGeom prst="rect">
+            <a:avLst/>
+          </a:prstGeom>
+          <a:noFill/>
+        </p:spPr>
+        <p:txBody>
+          <a:bodyPr wrap="square" lIns="0" rIns="0">
+            <a:spAutoFit/>
+          </a:bodyPr>
+          <a:lstStyle/>
+          <a:p>
+            <a:r>
+              <a:rPr sz="2100" b="1">
+                <a:solidFill>
+                  <a:srgbClr val="0E7C7B"/>
+                </a:solidFill>
+                <a:latin typeface="Nimbus Sans"/>
+              </a:rPr>
+              <a:t>Review time</a:t>
+            </a:r>
+          </a:p>
+        </p:txBody>
+      </p:sp>
+      <p:sp>
+        <p:nvSpPr>
+          <p:cNvPr id="9" name="TextBox 8"/>
+          <p:cNvSpPr txBox="1"/>
+          <p:nvPr/>
+        </p:nvSpPr>
+        <p:spPr>
+          <a:xfrm>
+            <a:off x="777240" y="5056631"/>
+            <a:ext cx="10515600" cy="749808"/>
+          </a:xfrm>
+          <a:prstGeom prst="rect">
+            <a:avLst/>
+          </a:prstGeom>
+          <a:noFill/>
+        </p:spPr>
+        <p:txBody>
+          <a:bodyPr wrap="square" lIns="0" rIns="0">
+            <a:spAutoFit/>
+          </a:bodyPr>
+          <a:lstStyle/>
+          <a:p>
+            <a:r>
+              <a:rPr sz="2000" b="0">
+                <a:solidFill>
+                  <a:srgbClr val="102A43"/>
+                </a:solidFill>
+                <a:latin typeface="Nimbus Sans"/>
+              </a:rPr>
+              <a:t>Median at most 2 minutes per displayed alert. Measure outcomes and full costs before claiming benefit.</a:t>
+            </a:r>
+          </a:p>
+        </p:txBody>
+      </p:sp>
+      <p:sp>
+        <p:nvSpPr>
+          <p:cNvPr id="10" name="TextBox 9"/>
+          <p:cNvSpPr txBox="1"/>
+          <p:nvPr/>
+        </p:nvSpPr>
+        <p:spPr>
+          <a:xfrm>
+            <a:off x="777240" y="6446520"/>
+            <a:ext cx="10515600" cy="228600"/>
+          </a:xfrm>
+          <a:prstGeom prst="rect">
+            <a:avLst/>
+          </a:prstGeom>
+          <a:noFill/>
+        </p:spPr>
+        <p:txBody>
+          <a:bodyPr wrap="square" lIns="0" rIns="0">
+            <a:spAutoFit/>
+          </a:bodyPr>
+          <a:lstStyle/>
+          <a:p>
+            <a:r>
+              <a:rPr sz="1000" b="0">
+                <a:solidFill>
+                  <a:srgbClr val="627D98"/>
+                </a:solidFill>
+                <a:latin typeface="Nimbus Sans"/>
+              </a:rPr>
+              <a:t>DIAL-ALERT | Academic prototype</a:t>
+            </a:r>
+          </a:p>
+        </p:txBody>
+      </p:sp>
+    </p:spTree>
+  </p:cSld>
+  <p:clrMapOvr>
+    <a:masterClrMapping/>
+  </p:clrMapOvr>
 </p:sld>
 </file>
 
@@ -3972,6 +4365,10 @@
             <a:prstDash val="solid"/>
           </a:ln>
         </p:spPr>
+        <p:txBody xmlns:a="http://schemas.openxmlformats.org/drawingml/2006/main">
+          <a:bodyPr/>
+          <a:p/>
+        </p:txBody>
       </p:sp>
       <p:sp>
         <p:nvSpPr>
@@ -4084,7 +4481,7 @@
                 <a:ea typeface="Nimbus Sans"/>
                 <a:cs typeface="Nimbus Sans"/>
               </a:rPr>
-              <a:t>Internal test performance supports a governed pilot decision</a:t>
+              <a:t>170 test patients; 20% capacity recall 95% CI 63.2% to 74.4%</a:t>
             </a:r>
           </a:p>
         </p:txBody>
@@ -4235,6 +4632,10 @@
             <a:prstDash val="solid"/>
           </a:ln>
         </p:spPr>
+        <p:txBody xmlns:a="http://schemas.openxmlformats.org/drawingml/2006/main">
+          <a:bodyPr/>
+          <a:p/>
+        </p:txBody>
       </p:sp>
       <p:sp>
         <p:nvSpPr>
@@ -4521,6 +4922,10 @@
             <a:prstDash val="solid"/>
           </a:ln>
         </p:spPr>
+        <p:txBody xmlns:a="http://schemas.openxmlformats.org/drawingml/2006/main">
+          <a:bodyPr/>
+          <a:p/>
+        </p:txBody>
       </p:sp>
       <p:sp>
         <p:nvSpPr>
@@ -4668,6 +5073,10 @@
             <a:prstDash val="solid"/>
           </a:ln>
         </p:spPr>
+        <p:txBody xmlns:a="http://schemas.openxmlformats.org/drawingml/2006/main">
+          <a:bodyPr/>
+          <a:p/>
+        </p:txBody>
       </p:sp>
       <p:sp>
         <p:nvSpPr>
@@ -4722,7 +5131,7 @@
                 <a:ea typeface="Nimbus Sans"/>
                 <a:cs typeface="Nimbus Sans"/>
               </a:rPr>
-              <a:t>DIAL-ALERT executive presentation  /  02</a:t>
+              <a:t>DIAL-ALERT business presentation  /  02</a:t>
             </a:r>
           </a:p>
         </p:txBody>
@@ -4786,6 +5195,10 @@
             <a:prstDash val="solid"/>
           </a:ln>
         </p:spPr>
+        <p:txBody xmlns:a="http://schemas.openxmlformats.org/drawingml/2006/main">
+          <a:bodyPr/>
+          <a:p/>
+        </p:txBody>
       </p:sp>
       <p:sp>
         <p:nvSpPr>
@@ -4935,6 +5348,10 @@
             <a:prstDash val="solid"/>
           </a:ln>
         </p:spPr>
+        <p:txBody xmlns:a="http://schemas.openxmlformats.org/drawingml/2006/main">
+          <a:bodyPr/>
+          <a:p/>
+        </p:txBody>
       </p:sp>
       <p:sp>
         <p:nvSpPr>
@@ -5144,6 +5561,10 @@
             <a:prstDash val="solid"/>
           </a:ln>
         </p:spPr>
+        <p:txBody xmlns:a="http://schemas.openxmlformats.org/drawingml/2006/main">
+          <a:bodyPr/>
+          <a:p/>
+        </p:txBody>
       </p:sp>
       <p:sp>
         <p:nvSpPr>
@@ -5353,6 +5774,10 @@
             <a:prstDash val="solid"/>
           </a:ln>
         </p:spPr>
+        <p:txBody xmlns:a="http://schemas.openxmlformats.org/drawingml/2006/main">
+          <a:bodyPr/>
+          <a:p/>
+        </p:txBody>
       </p:sp>
       <p:sp>
         <p:nvSpPr>
@@ -5562,6 +5987,10 @@
             <a:prstDash val="solid"/>
           </a:ln>
         </p:spPr>
+        <p:txBody xmlns:a="http://schemas.openxmlformats.org/drawingml/2006/main">
+          <a:bodyPr/>
+          <a:p/>
+        </p:txBody>
       </p:sp>
       <p:sp>
         <p:nvSpPr>
@@ -5847,6 +6276,10 @@
             <a:prstDash val="solid"/>
           </a:ln>
         </p:spPr>
+        <p:txBody xmlns:a="http://schemas.openxmlformats.org/drawingml/2006/main">
+          <a:bodyPr/>
+          <a:p/>
+        </p:txBody>
       </p:sp>
       <p:sp>
         <p:nvSpPr>
@@ -6052,6 +6485,10 @@
             <a:prstDash val="solid"/>
           </a:ln>
         </p:spPr>
+        <p:txBody xmlns:a="http://schemas.openxmlformats.org/drawingml/2006/main">
+          <a:bodyPr/>
+          <a:p/>
+        </p:txBody>
       </p:sp>
       <p:sp>
         <p:nvSpPr>
@@ -6106,7 +6543,7 @@
                 <a:ea typeface="Nimbus Sans"/>
                 <a:cs typeface="Nimbus Sans"/>
               </a:rPr>
-              <a:t>DIAL-ALERT executive presentation  /  03</a:t>
+              <a:t>DIAL-ALERT business presentation  /  03</a:t>
             </a:r>
           </a:p>
         </p:txBody>
@@ -6170,6 +6607,10 @@
             <a:prstDash val="solid"/>
           </a:ln>
         </p:spPr>
+        <p:txBody xmlns:a="http://schemas.openxmlformats.org/drawingml/2006/main">
+          <a:bodyPr/>
+          <a:p/>
+        </p:txBody>
       </p:sp>
       <p:sp>
         <p:nvSpPr>
@@ -6687,6 +7128,10 @@
             <a:prstDash val="solid"/>
           </a:ln>
         </p:spPr>
+        <p:txBody xmlns:a="http://schemas.openxmlformats.org/drawingml/2006/main">
+          <a:bodyPr/>
+          <a:p/>
+        </p:txBody>
       </p:sp>
       <p:sp>
         <p:nvSpPr>
@@ -6892,6 +7337,10 @@
             <a:prstDash val="solid"/>
           </a:ln>
         </p:spPr>
+        <p:txBody xmlns:a="http://schemas.openxmlformats.org/drawingml/2006/main">
+          <a:bodyPr/>
+          <a:p/>
+        </p:txBody>
       </p:sp>
       <p:sp>
         <p:nvSpPr>
@@ -6946,7 +7395,7 @@
                 <a:ea typeface="Nimbus Sans"/>
                 <a:cs typeface="Nimbus Sans"/>
               </a:rPr>
-              <a:t>DIAL-ALERT executive presentation  /  04</a:t>
+              <a:t>DIAL-ALERT business presentation  /  04</a:t>
             </a:r>
           </a:p>
         </p:txBody>
@@ -7010,6 +7459,10 @@
             <a:prstDash val="solid"/>
           </a:ln>
         </p:spPr>
+        <p:txBody xmlns:a="http://schemas.openxmlformats.org/drawingml/2006/main">
+          <a:bodyPr/>
+          <a:p/>
+        </p:txBody>
       </p:sp>
       <p:sp>
         <p:nvSpPr>
@@ -7421,6 +7874,10 @@
             <a:prstDash val="solid"/>
           </a:ln>
         </p:spPr>
+        <p:txBody xmlns:a="http://schemas.openxmlformats.org/drawingml/2006/main">
+          <a:bodyPr/>
+          <a:p/>
+        </p:txBody>
       </p:sp>
       <p:sp>
         <p:nvSpPr>
@@ -7475,7 +7932,7 @@
                 <a:ea typeface="Nimbus Sans"/>
                 <a:cs typeface="Nimbus Sans"/>
               </a:rPr>
-              <a:t>DIAL-ALERT executive presentation  /  05</a:t>
+              <a:t>DIAL-ALERT business presentation  /  05</a:t>
             </a:r>
           </a:p>
         </p:txBody>
@@ -7539,6 +7996,10 @@
             <a:prstDash val="solid"/>
           </a:ln>
         </p:spPr>
+        <p:txBody xmlns:a="http://schemas.openxmlformats.org/drawingml/2006/main">
+          <a:bodyPr/>
+          <a:p/>
+        </p:txBody>
       </p:sp>
       <p:sp>
         <p:nvSpPr>
@@ -7688,6 +8149,10 @@
             <a:prstDash val="solid"/>
           </a:ln>
         </p:spPr>
+        <p:txBody xmlns:a="http://schemas.openxmlformats.org/drawingml/2006/main">
+          <a:bodyPr/>
+          <a:p/>
+        </p:txBody>
       </p:sp>
       <p:sp>
         <p:nvSpPr>
@@ -7835,6 +8300,10 @@
             <a:prstDash val="solid"/>
           </a:ln>
         </p:spPr>
+        <p:txBody xmlns:a="http://schemas.openxmlformats.org/drawingml/2006/main">
+          <a:bodyPr/>
+          <a:p/>
+        </p:txBody>
       </p:sp>
       <p:sp>
         <p:nvSpPr>
@@ -7924,6 +8393,10 @@
             <a:prstDash val="solid"/>
           </a:ln>
         </p:spPr>
+        <p:txBody xmlns:a="http://schemas.openxmlformats.org/drawingml/2006/main">
+          <a:bodyPr/>
+          <a:p/>
+        </p:txBody>
       </p:sp>
       <p:sp>
         <p:nvSpPr>
@@ -8013,6 +8486,10 @@
             <a:prstDash val="solid"/>
           </a:ln>
         </p:spPr>
+        <p:txBody xmlns:a="http://schemas.openxmlformats.org/drawingml/2006/main">
+          <a:bodyPr/>
+          <a:p/>
+        </p:txBody>
       </p:sp>
       <p:sp>
         <p:nvSpPr>
@@ -8102,6 +8579,10 @@
             <a:prstDash val="solid"/>
           </a:ln>
         </p:spPr>
+        <p:txBody xmlns:a="http://schemas.openxmlformats.org/drawingml/2006/main">
+          <a:bodyPr/>
+          <a:p/>
+        </p:txBody>
       </p:sp>
       <p:sp>
         <p:nvSpPr>
@@ -8191,6 +8672,10 @@
             <a:prstDash val="solid"/>
           </a:ln>
         </p:spPr>
+        <p:txBody xmlns:a="http://schemas.openxmlformats.org/drawingml/2006/main">
+          <a:bodyPr/>
+          <a:p/>
+        </p:txBody>
       </p:sp>
       <p:sp>
         <p:nvSpPr>
@@ -8280,6 +8765,10 @@
             <a:prstDash val="solid"/>
           </a:ln>
         </p:spPr>
+        <p:txBody xmlns:a="http://schemas.openxmlformats.org/drawingml/2006/main">
+          <a:bodyPr/>
+          <a:p/>
+        </p:txBody>
       </p:sp>
       <p:sp>
         <p:nvSpPr>
@@ -8369,6 +8858,10 @@
             <a:prstDash val="solid"/>
           </a:ln>
         </p:spPr>
+        <p:txBody xmlns:a="http://schemas.openxmlformats.org/drawingml/2006/main">
+          <a:bodyPr/>
+          <a:p/>
+        </p:txBody>
       </p:sp>
       <p:sp>
         <p:nvSpPr>
@@ -8458,6 +8951,10 @@
             <a:prstDash val="solid"/>
           </a:ln>
         </p:spPr>
+        <p:txBody xmlns:a="http://schemas.openxmlformats.org/drawingml/2006/main">
+          <a:bodyPr/>
+          <a:p/>
+        </p:txBody>
       </p:sp>
       <p:sp>
         <p:nvSpPr>
@@ -8547,6 +9044,10 @@
             <a:prstDash val="solid"/>
           </a:ln>
         </p:spPr>
+        <p:txBody xmlns:a="http://schemas.openxmlformats.org/drawingml/2006/main">
+          <a:bodyPr/>
+          <a:p/>
+        </p:txBody>
       </p:sp>
       <p:sp>
         <p:nvSpPr>
@@ -8636,6 +9137,10 @@
             <a:prstDash val="solid"/>
           </a:ln>
         </p:spPr>
+        <p:txBody xmlns:a="http://schemas.openxmlformats.org/drawingml/2006/main">
+          <a:bodyPr/>
+          <a:p/>
+        </p:txBody>
       </p:sp>
       <p:sp>
         <p:nvSpPr>
@@ -8725,6 +9230,10 @@
             <a:prstDash val="solid"/>
           </a:ln>
         </p:spPr>
+        <p:txBody xmlns:a="http://schemas.openxmlformats.org/drawingml/2006/main">
+          <a:bodyPr/>
+          <a:p/>
+        </p:txBody>
       </p:sp>
       <p:sp>
         <p:nvSpPr>
@@ -8779,7 +9288,7 @@
                 <a:ea typeface="Nimbus Sans"/>
                 <a:cs typeface="Nimbus Sans"/>
               </a:rPr>
-              <a:t>DIAL-ALERT executive presentation  /  06</a:t>
+              <a:t>DIAL-ALERT business presentation  /  06</a:t>
             </a:r>
           </a:p>
         </p:txBody>
@@ -8843,6 +9352,10 @@
             <a:prstDash val="solid"/>
           </a:ln>
         </p:spPr>
+        <p:txBody xmlns:a="http://schemas.openxmlformats.org/drawingml/2006/main">
+          <a:bodyPr/>
+          <a:p/>
+        </p:txBody>
       </p:sp>
       <p:sp>
         <p:nvSpPr>
@@ -9048,6 +9561,10 @@
             <a:prstDash val="solid"/>
           </a:ln>
         </p:spPr>
+        <p:txBody xmlns:a="http://schemas.openxmlformats.org/drawingml/2006/main">
+          <a:bodyPr/>
+          <a:p/>
+        </p:txBody>
       </p:sp>
       <p:sp>
         <p:nvSpPr>
@@ -9195,6 +9712,10 @@
             <a:prstDash val="solid"/>
           </a:ln>
         </p:spPr>
+        <p:txBody xmlns:a="http://schemas.openxmlformats.org/drawingml/2006/main">
+          <a:bodyPr/>
+          <a:p/>
+        </p:txBody>
       </p:sp>
       <p:sp>
         <p:nvSpPr>
@@ -9342,6 +9863,10 @@
             <a:prstDash val="solid"/>
           </a:ln>
         </p:spPr>
+        <p:txBody xmlns:a="http://schemas.openxmlformats.org/drawingml/2006/main">
+          <a:bodyPr/>
+          <a:p/>
+        </p:txBody>
       </p:sp>
       <p:sp>
         <p:nvSpPr>
@@ -9489,6 +10014,10 @@
             <a:prstDash val="solid"/>
           </a:ln>
         </p:spPr>
+        <p:txBody xmlns:a="http://schemas.openxmlformats.org/drawingml/2006/main">
+          <a:bodyPr/>
+          <a:p/>
+        </p:txBody>
       </p:sp>
       <p:sp>
         <p:nvSpPr>
@@ -9606,28 +10135,6 @@
           </a:p>
         </p:txBody>
       </p:sp>
-      <p:pic>
-        <p:nvPicPr>
-          <p:cNvPr id="39" name=""/>
-          <p:cNvPicPr>
-            <a:picLocks xmlns:a="http://schemas.openxmlformats.org/drawingml/2006/main" noChangeAspect="1"/>
-          </p:cNvPicPr>
-          <p:nvPr/>
-        </p:nvPicPr>
-        <p:blipFill>
-          <a:blip xmlns:r="http://schemas.openxmlformats.org/officeDocument/2006/relationships" xmlns:a="http://schemas.openxmlformats.org/drawingml/2006/main" r:embed="R6de58cb279214e03"/>
-          <a:stretch xmlns:a="http://schemas.openxmlformats.org/drawingml/2006/main"/>
-        </p:blipFill>
-        <p:spPr>
-          <a:xfrm xmlns:a="http://schemas.openxmlformats.org/drawingml/2006/main">
-            <a:off x="4762500" y="1696546"/>
-            <a:ext cx="6858000" cy="3503007"/>
-          </a:xfrm>
-          <a:prstGeom xmlns:a="http://schemas.openxmlformats.org/drawingml/2006/main" prst="rect">
-            <a:avLst/>
-          </a:prstGeom>
-        </p:spPr>
-      </p:pic>
       <p:sp>
         <p:nvSpPr>
           <p:cNvPr id="18" name="">
@@ -9660,6 +10167,10 @@
             <a:prstDash val="solid"/>
           </a:ln>
         </p:spPr>
+        <p:txBody xmlns:a="http://schemas.openxmlformats.org/drawingml/2006/main">
+          <a:bodyPr/>
+          <a:p/>
+        </p:txBody>
       </p:sp>
       <p:sp>
         <p:nvSpPr>
@@ -9807,6 +10318,10 @@
             <a:prstDash val="solid"/>
           </a:ln>
         </p:spPr>
+        <p:txBody xmlns:a="http://schemas.openxmlformats.org/drawingml/2006/main">
+          <a:bodyPr/>
+          <a:p/>
+        </p:txBody>
       </p:sp>
       <p:sp>
         <p:nvSpPr>
@@ -9861,7 +10376,129 @@
                 <a:ea typeface="Nimbus Sans"/>
                 <a:cs typeface="Nimbus Sans"/>
               </a:rPr>
-              <a:t>DIAL-ALERT executive presentation  /  07</a:t>
+              <a:t>DIAL-ALERT business presentation  /  07</a:t>
+            </a:r>
+          </a:p>
+        </p:txBody>
+      </p:sp>
+      <p:sp xmlns:a="http://schemas.openxmlformats.org/drawingml/2006/main">
+        <p:nvSpPr>
+          <p:cNvPr id="24" name="TextBox 23"/>
+          <p:cNvSpPr txBox="1"/>
+          <p:nvPr/>
+        </p:nvSpPr>
+        <p:spPr>
+          <a:xfrm>
+            <a:off x="4937760" y="1645920"/>
+            <a:ext cx="6126480" cy="457200"/>
+          </a:xfrm>
+          <a:prstGeom prst="rect">
+            <a:avLst/>
+          </a:prstGeom>
+          <a:noFill/>
+        </p:spPr>
+        <p:txBody>
+          <a:bodyPr wrap="square" lIns="0" rIns="0">
+            <a:spAutoFit/>
+          </a:bodyPr>
+          <a:lstStyle/>
+          <a:p>
+            <a:r>
+              <a:rPr sz="2300" b="1">
+                <a:solidFill>
+                  <a:srgbClr val="0E7C7B"/>
+                </a:solidFill>
+                <a:latin typeface="Nimbus Sans"/>
+              </a:rPr>
+              <a:t>Exploratory fairness audit</a:t>
+            </a:r>
+          </a:p>
+        </p:txBody>
+      </p:sp>
+      <p:sp xmlns:a="http://schemas.openxmlformats.org/drawingml/2006/main">
+        <p:nvSpPr>
+          <p:cNvPr id="25" name="TextBox 24"/>
+          <p:cNvSpPr txBox="1"/>
+          <p:nvPr/>
+        </p:nvSpPr>
+        <p:spPr>
+          <a:xfrm>
+            <a:off x="4937760" y="2286000"/>
+            <a:ext cx="6126480" cy="1554480"/>
+          </a:xfrm>
+          <a:prstGeom prst="rect">
+            <a:avLst/>
+          </a:prstGeom>
+          <a:noFill/>
+        </p:spPr>
+        <p:txBody>
+          <a:bodyPr wrap="square" lIns="0" rIns="0">
+            <a:spAutoFit/>
+          </a:bodyPr>
+          <a:lstStyle/>
+          <a:p>
+            <a:r>
+              <a:rPr sz="2300" b="0">
+                <a:solidFill>
+                  <a:srgbClr val="102A43"/>
+                </a:solidFill>
+                <a:latin typeface="Nimbus Sans"/>
+              </a:rPr>
+              <a:t>Recorded-sex selection ratio: 0.705</a:t>
+            </a:r>
+            <a:br/>
+            <a:r>
+              <a:rPr sz="2300" b="0">
+                <a:solidFill>
+                  <a:srgbClr val="102A43"/>
+                </a:solidFill>
+                <a:latin typeface="Nimbus Sans"/>
+              </a:rPr>
+              <a:t>Reweighting candidate: 0.764</a:t>
+            </a:r>
+            <a:br/>
+            <a:r>
+              <a:rPr sz="2300" b="0">
+                <a:solidFill>
+                  <a:srgbClr val="102A43"/>
+                </a:solidFill>
+                <a:latin typeface="Nimbus Sans"/>
+              </a:rPr>
+              <a:t>Age-group selection ratio: 0.541</a:t>
+            </a:r>
+          </a:p>
+        </p:txBody>
+      </p:sp>
+      <p:sp xmlns:a="http://schemas.openxmlformats.org/drawingml/2006/main">
+        <p:nvSpPr>
+          <p:cNvPr id="26" name="TextBox 25"/>
+          <p:cNvSpPr txBox="1"/>
+          <p:nvPr/>
+        </p:nvSpPr>
+        <p:spPr>
+          <a:xfrm>
+            <a:off x="4937760" y="4114800"/>
+            <a:ext cx="5852160" cy="822960"/>
+          </a:xfrm>
+          <a:prstGeom prst="rect">
+            <a:avLst/>
+          </a:prstGeom>
+          <a:noFill/>
+        </p:spPr>
+        <p:txBody>
+          <a:bodyPr wrap="square" lIns="0" rIns="0">
+            <a:spAutoFit/>
+          </a:bodyPr>
+          <a:lstStyle/>
+          <a:p>
+            <a:r>
+              <a:rPr sz="2200" b="1">
+                <a:solidFill>
+                  <a:srgbClr val="102A43"/>
+                </a:solidFill>
+                <a:latin typeface="Nimbus Sans"/>
+              </a:rPr>
+              <a:t>Confirm on fresh patients before adopting mitigation.</a:t>
             </a:r>
           </a:p>
         </p:txBody>
@@ -9925,6 +10562,10 @@
             <a:prstDash val="solid"/>
           </a:ln>
         </p:spPr>
+        <p:txBody xmlns:a="http://schemas.openxmlformats.org/drawingml/2006/main">
+          <a:bodyPr/>
+          <a:p/>
+        </p:txBody>
       </p:sp>
       <p:sp>
         <p:nvSpPr>
@@ -10246,6 +10887,10 @@
             <a:prstDash val="solid"/>
           </a:ln>
         </p:spPr>
+        <p:txBody xmlns:a="http://schemas.openxmlformats.org/drawingml/2006/main">
+          <a:bodyPr/>
+          <a:p/>
+        </p:txBody>
       </p:sp>
       <p:sp>
         <p:nvSpPr>
@@ -10511,6 +11156,10 @@
             <a:prstDash val="solid"/>
           </a:ln>
         </p:spPr>
+        <p:txBody xmlns:a="http://schemas.openxmlformats.org/drawingml/2006/main">
+          <a:bodyPr/>
+          <a:p/>
+        </p:txBody>
       </p:sp>
       <p:sp>
         <p:nvSpPr>
@@ -10776,6 +11425,10 @@
             <a:prstDash val="solid"/>
           </a:ln>
         </p:spPr>
+        <p:txBody xmlns:a="http://schemas.openxmlformats.org/drawingml/2006/main">
+          <a:bodyPr/>
+          <a:p/>
+        </p:txBody>
       </p:sp>
       <p:sp>
         <p:nvSpPr>
@@ -11041,6 +11694,10 @@
             <a:prstDash val="solid"/>
           </a:ln>
         </p:spPr>
+        <p:txBody xmlns:a="http://schemas.openxmlformats.org/drawingml/2006/main">
+          <a:bodyPr/>
+          <a:p/>
+        </p:txBody>
       </p:sp>
       <p:sp>
         <p:nvSpPr>
@@ -11306,6 +11963,10 @@
             <a:prstDash val="solid"/>
           </a:ln>
         </p:spPr>
+        <p:txBody xmlns:a="http://schemas.openxmlformats.org/drawingml/2006/main">
+          <a:bodyPr/>
+          <a:p/>
+        </p:txBody>
       </p:sp>
       <p:sp>
         <p:nvSpPr>
@@ -11629,6 +12290,10 @@
             <a:prstDash val="solid"/>
           </a:ln>
         </p:spPr>
+        <p:txBody xmlns:a="http://schemas.openxmlformats.org/drawingml/2006/main">
+          <a:bodyPr/>
+          <a:p/>
+        </p:txBody>
       </p:sp>
       <p:sp>
         <p:nvSpPr>
@@ -11683,7 +12348,7 @@
                 <a:ea typeface="Nimbus Sans"/>
                 <a:cs typeface="Nimbus Sans"/>
               </a:rPr>
-              <a:t>DIAL-ALERT executive presentation  /  08</a:t>
+              <a:t>DIAL-ALERT business presentation  /  08</a:t>
             </a:r>
           </a:p>
         </p:txBody>
@@ -11747,6 +12412,10 @@
             <a:prstDash val="solid"/>
           </a:ln>
         </p:spPr>
+        <p:txBody xmlns:a="http://schemas.openxmlformats.org/drawingml/2006/main">
+          <a:bodyPr/>
+          <a:p/>
+        </p:txBody>
       </p:sp>
       <p:sp>
         <p:nvSpPr>
@@ -11801,7 +12470,7 @@
                 <a:ea typeface="Nimbus Sans"/>
                 <a:cs typeface="Nimbus Sans"/>
               </a:rPr>
-              <a:t>A 90-day pilot can answer the deployment question</a:t>
+              <a:t>A staged pilot should assess feasibility and safety</a:t>
             </a:r>
           </a:p>
         </p:txBody>
@@ -11859,7 +12528,7 @@
                 <a:ea typeface="Nimbus Sans"/>
                 <a:cs typeface="Nimbus Sans"/>
               </a:rPr>
-              <a:t>Progression depends on evidence at the end of each phase</a:t>
+              <a:t>Illustrative timing; progression requires evidence and safety review</a:t>
             </a:r>
           </a:p>
         </p:txBody>
@@ -11896,6 +12565,10 @@
             <a:prstDash val="solid"/>
           </a:ln>
         </p:spPr>
+        <p:txBody xmlns:a="http://schemas.openxmlformats.org/drawingml/2006/main">
+          <a:bodyPr/>
+          <a:p/>
+        </p:txBody>
       </p:sp>
       <p:sp>
         <p:nvSpPr>
@@ -12043,6 +12716,10 @@
             <a:prstDash val="solid"/>
           </a:ln>
         </p:spPr>
+        <p:txBody xmlns:a="http://schemas.openxmlformats.org/drawingml/2006/main">
+          <a:bodyPr/>
+          <a:p/>
+        </p:txBody>
       </p:sp>
       <p:sp>
         <p:nvSpPr>
@@ -12192,6 +12869,10 @@
             <a:prstDash val="solid"/>
           </a:ln>
         </p:spPr>
+        <p:txBody xmlns:a="http://schemas.openxmlformats.org/drawingml/2006/main">
+          <a:bodyPr/>
+          <a:p/>
+        </p:txBody>
       </p:sp>
       <p:sp>
         <p:nvSpPr>
@@ -12339,6 +13020,10 @@
             <a:prstDash val="solid"/>
           </a:ln>
         </p:spPr>
+        <p:txBody xmlns:a="http://schemas.openxmlformats.org/drawingml/2006/main">
+          <a:bodyPr/>
+          <a:p/>
+        </p:txBody>
       </p:sp>
       <p:sp>
         <p:nvSpPr>
@@ -12488,6 +13173,10 @@
             <a:prstDash val="solid"/>
           </a:ln>
         </p:spPr>
+        <p:txBody xmlns:a="http://schemas.openxmlformats.org/drawingml/2006/main">
+          <a:bodyPr/>
+          <a:p/>
+        </p:txBody>
       </p:sp>
       <p:sp>
         <p:nvSpPr>
@@ -12635,6 +13324,10 @@
             <a:prstDash val="solid"/>
           </a:ln>
         </p:spPr>
+        <p:txBody xmlns:a="http://schemas.openxmlformats.org/drawingml/2006/main">
+          <a:bodyPr/>
+          <a:p/>
+        </p:txBody>
       </p:sp>
       <p:sp>
         <p:nvSpPr>
@@ -12747,7 +13440,7 @@
                 <a:ea typeface="Nimbus Sans"/>
                 <a:cs typeface="Nimbus Sans"/>
               </a:rPr>
-              <a:t>Gate: benefit warrants a larger evaluation</a:t>
+              <a:t>Gate: feasibility supports a larger study</a:t>
             </a:r>
           </a:p>
         </p:txBody>
@@ -12840,6 +13533,10 @@
             <a:prstDash val="solid"/>
           </a:ln>
         </p:spPr>
+        <p:txBody xmlns:a="http://schemas.openxmlformats.org/drawingml/2006/main">
+          <a:bodyPr/>
+          <a:p/>
+        </p:txBody>
       </p:sp>
       <p:sp>
         <p:nvSpPr>
@@ -12894,7 +13591,7 @@
                 <a:ea typeface="Nimbus Sans"/>
                 <a:cs typeface="Nimbus Sans"/>
               </a:rPr>
-              <a:t>DIAL-ALERT executive presentation  /  09</a:t>
+              <a:t>DIAL-ALERT business presentation  /  09</a:t>
             </a:r>
           </a:p>
         </p:txBody>

</xml_diff>